<commit_message>
Fix issues found in end-to-end browser test
- Home links and buttons in a corner were swallowed by the secret-sequence
  detector; only taps that continue a sequence in progress are now consumed
- PDF export was 61 MB for 4 pages: enable jsPDF compression, render charts at 2x
- Lazy-load jsPDF so kiosk startup doesn't parse it (main chunk 589 kB -> 190 kB)
- Default button labels strip the BTN_ prefix (BTN_Sustainability -> Sustainability)
- Template: remove run-level hyperlinks that underlined button captions
- Setup thumbnails sized to their cards
- Add .claude/launch.json for local preview under /stuPad/

Co-Authored-By: Claude Opus 5.5 <noreply@anthropic.com>
</commit_message>
<xml_diff>
--- a/public/template.pptx
+++ b/public/template.pptx
@@ -1433,20 +1433,13 @@
               <a:buNone/>
             </a:pPr>
             <a:r>
-              <a:rPr lang="en-US" sz="2000" b="1" u="sng" dirty="0">
+              <a:rPr lang="en-US" sz="2000" b="1" dirty="0">
                 <a:solidFill>
                   <a:srgbClr val="FFFFFF"/>
                 </a:solidFill>
                 <a:latin typeface="Helvetica Neue" pitchFamily="34" charset="0"/>
                 <a:ea typeface="Helvetica Neue" pitchFamily="34" charset="-122"/>
                 <a:cs typeface="Helvetica Neue" pitchFamily="34" charset="-120"/>
-                <a:hlinkClick r:id="rId1" action="ppaction://hlinksldjump" tooltip="">
-                  <a:extLst>
-                    <a:ext uri="{A12FA001-AC4F-418D-AE19-62706E023703}">
-                      <ahyp:hlinkClr xmlns:ahyp="http://schemas.microsoft.com/office/drawing/2018/hyperlinkcolor" val="tx"/>
-                    </a:ext>
-                  </a:extLst>
-                </a:hlinkClick>
               </a:rPr>
               <a:t>Sustainability</a:t>
             </a:r>
@@ -1489,20 +1482,13 @@
               <a:buNone/>
             </a:pPr>
             <a:r>
-              <a:rPr lang="en-US" sz="2000" b="1" u="sng" dirty="0">
+              <a:rPr lang="en-US" sz="2000" b="1" dirty="0">
                 <a:solidFill>
                   <a:srgbClr val="FFFFFF"/>
                 </a:solidFill>
                 <a:latin typeface="Helvetica Neue" pitchFamily="34" charset="0"/>
                 <a:ea typeface="Helvetica Neue" pitchFamily="34" charset="-122"/>
                 <a:cs typeface="Helvetica Neue" pitchFamily="34" charset="-120"/>
-                <a:hlinkClick r:id="rId2" action="ppaction://hlinksldjump" tooltip="">
-                  <a:extLst>
-                    <a:ext uri="{A12FA001-AC4F-418D-AE19-62706E023703}">
-                      <ahyp:hlinkClr xmlns:ahyp="http://schemas.microsoft.com/office/drawing/2018/hyperlinkcolor" val="tx"/>
-                    </a:ext>
-                  </a:extLst>
-                </a:hlinkClick>
               </a:rPr>
               <a:t>Innovation</a:t>
             </a:r>
@@ -1545,20 +1531,13 @@
               <a:buNone/>
             </a:pPr>
             <a:r>
-              <a:rPr lang="en-US" sz="2000" b="1" u="sng" dirty="0">
+              <a:rPr lang="en-US" sz="2000" b="1" dirty="0">
                 <a:solidFill>
                   <a:srgbClr val="FFFFFF"/>
                 </a:solidFill>
                 <a:latin typeface="Helvetica Neue" pitchFamily="34" charset="0"/>
                 <a:ea typeface="Helvetica Neue" pitchFamily="34" charset="-122"/>
                 <a:cs typeface="Helvetica Neue" pitchFamily="34" charset="-120"/>
-                <a:hlinkClick r:id="rId3" action="ppaction://hlinksldjump" tooltip="">
-                  <a:extLst>
-                    <a:ext uri="{A12FA001-AC4F-418D-AE19-62706E023703}">
-                      <ahyp:hlinkClr xmlns:ahyp="http://schemas.microsoft.com/office/drawing/2018/hyperlinkcolor" val="tx"/>
-                    </a:ext>
-                  </a:extLst>
-                </a:hlinkClick>
               </a:rPr>
               <a:t>People</a:t>
             </a:r>
@@ -1601,20 +1580,13 @@
               <a:buNone/>
             </a:pPr>
             <a:r>
-              <a:rPr lang="en-US" sz="2000" b="1" u="sng" dirty="0">
+              <a:rPr lang="en-US" sz="2000" b="1" dirty="0">
                 <a:solidFill>
                   <a:srgbClr val="FFFFFF"/>
                 </a:solidFill>
                 <a:latin typeface="Helvetica Neue" pitchFamily="34" charset="0"/>
                 <a:ea typeface="Helvetica Neue" pitchFamily="34" charset="-122"/>
                 <a:cs typeface="Helvetica Neue" pitchFamily="34" charset="-120"/>
-                <a:hlinkClick r:id="rId4" action="ppaction://hlinksldjump" tooltip="">
-                  <a:extLst>
-                    <a:ext uri="{A12FA001-AC4F-418D-AE19-62706E023703}">
-                      <ahyp:hlinkClr xmlns:ahyp="http://schemas.microsoft.com/office/drawing/2018/hyperlinkcolor" val="tx"/>
-                    </a:ext>
-                  </a:extLst>
-                </a:hlinkClick>
               </a:rPr>
               <a:t>Contact</a:t>
             </a:r>
@@ -1802,20 +1774,13 @@
               <a:buNone/>
             </a:pPr>
             <a:r>
-              <a:rPr lang="en-US" sz="1400" b="1" u="sng" dirty="0">
+              <a:rPr lang="en-US" sz="1400" b="1" dirty="0">
                 <a:solidFill>
                   <a:srgbClr val="FFFFFF"/>
                 </a:solidFill>
                 <a:latin typeface="Helvetica Neue" pitchFamily="34" charset="0"/>
                 <a:ea typeface="Helvetica Neue" pitchFamily="34" charset="-122"/>
                 <a:cs typeface="Helvetica Neue" pitchFamily="34" charset="-120"/>
-                <a:hlinkClick r:id="rId1" action="ppaction://hlinksldjump" tooltip="">
-                  <a:extLst>
-                    <a:ext uri="{A12FA001-AC4F-418D-AE19-62706E023703}">
-                      <ahyp:hlinkClr xmlns:ahyp="http://schemas.microsoft.com/office/drawing/2018/hyperlinkcolor" val="tx"/>
-                    </a:ext>
-                  </a:extLst>
-                </a:hlinkClick>
               </a:rPr>
               <a:t>Home</a:t>
             </a:r>
@@ -1964,20 +1929,13 @@
               <a:buNone/>
             </a:pPr>
             <a:r>
-              <a:rPr lang="en-US" sz="1400" b="1" u="sng" dirty="0">
+              <a:rPr lang="en-US" sz="1400" b="1" dirty="0">
                 <a:solidFill>
                   <a:srgbClr val="FFFFFF"/>
                 </a:solidFill>
                 <a:latin typeface="Helvetica Neue" pitchFamily="34" charset="0"/>
                 <a:ea typeface="Helvetica Neue" pitchFamily="34" charset="-122"/>
                 <a:cs typeface="Helvetica Neue" pitchFamily="34" charset="-120"/>
-                <a:hlinkClick r:id="rId1" action="ppaction://hlinksldjump" tooltip="">
-                  <a:extLst>
-                    <a:ext uri="{A12FA001-AC4F-418D-AE19-62706E023703}">
-                      <ahyp:hlinkClr xmlns:ahyp="http://schemas.microsoft.com/office/drawing/2018/hyperlinkcolor" val="tx"/>
-                    </a:ext>
-                  </a:extLst>
-                </a:hlinkClick>
               </a:rPr>
               <a:t>Home</a:t>
             </a:r>
@@ -2126,20 +2084,13 @@
               <a:buNone/>
             </a:pPr>
             <a:r>
-              <a:rPr lang="en-US" sz="1400" b="1" u="sng" dirty="0">
+              <a:rPr lang="en-US" sz="1400" b="1" dirty="0">
                 <a:solidFill>
                   <a:srgbClr val="FFFFFF"/>
                 </a:solidFill>
                 <a:latin typeface="Helvetica Neue" pitchFamily="34" charset="0"/>
                 <a:ea typeface="Helvetica Neue" pitchFamily="34" charset="-122"/>
                 <a:cs typeface="Helvetica Neue" pitchFamily="34" charset="-120"/>
-                <a:hlinkClick r:id="rId1" action="ppaction://hlinksldjump" tooltip="">
-                  <a:extLst>
-                    <a:ext uri="{A12FA001-AC4F-418D-AE19-62706E023703}">
-                      <ahyp:hlinkClr xmlns:ahyp="http://schemas.microsoft.com/office/drawing/2018/hyperlinkcolor" val="tx"/>
-                    </a:ext>
-                  </a:extLst>
-                </a:hlinkClick>
               </a:rPr>
               <a:t>Home</a:t>
             </a:r>
@@ -2288,20 +2239,13 @@
               <a:buNone/>
             </a:pPr>
             <a:r>
-              <a:rPr lang="en-US" sz="1400" b="1" u="sng" dirty="0">
+              <a:rPr lang="en-US" sz="1400" b="1" dirty="0">
                 <a:solidFill>
                   <a:srgbClr val="FFFFFF"/>
                 </a:solidFill>
                 <a:latin typeface="Helvetica Neue" pitchFamily="34" charset="0"/>
                 <a:ea typeface="Helvetica Neue" pitchFamily="34" charset="-122"/>
                 <a:cs typeface="Helvetica Neue" pitchFamily="34" charset="-120"/>
-                <a:hlinkClick r:id="rId1" action="ppaction://hlinksldjump" tooltip="">
-                  <a:extLst>
-                    <a:ext uri="{A12FA001-AC4F-418D-AE19-62706E023703}">
-                      <ahyp:hlinkClr xmlns:ahyp="http://schemas.microsoft.com/office/drawing/2018/hyperlinkcolor" val="tx"/>
-                    </a:ext>
-                  </a:extLst>
-                </a:hlinkClick>
               </a:rPr>
               <a:t>Home</a:t>
             </a:r>

</xml_diff>

<commit_message>
Multi-slide navigation within a visit; fix white flash on slide change
- Destination slides can link onward to further slides (explicit slide links
  and PowerPoint Next/Previous/Last Slide actions). New Deck.navLinks, logged
  as slide_nav events within the same visit; timeout resets on nav.
- Validation uses reachability from slide 1; self-links produce a warning.
- Reports: slide views and nav taps; setup preview follows nav links.
- Template and new multi-slide fixture.
- SlideStage mounts every slide once and fades the incoming slide in on top
  of the fully opaque outgoing one; kiosk sets html/body background to black
  so unpainted tiles never show the near-white page background on iPadOS.

Co-Authored-By: Claude Opus 5.5 <noreply@anthropic.com>
</commit_message>
<xml_diff>
--- a/public/template.pptx
+++ b/public/template.pptx
@@ -11,9 +11,10 @@
     <p:sldId id="259" r:id="rId5"/>
     <p:sldId id="260" r:id="rId6"/>
     <p:sldId id="261" r:id="rId7"/>
+    <p:sldId id="262" r:id="rId8"/>
   </p:sldIdLst>
   <p:notesMasterIdLst>
-    <p:notesMasterId r:id="rId8"/>
+    <p:notesMasterId r:id="rId9"/>
   </p:notesMasterIdLst>
   <p:sldSz cx="12191695" cy="6858000"/>
   <p:notesSz cx="6858000" cy="12191695"/>
@@ -989,6 +990,94 @@
 </p:notes>
 </file>
 
+<file path=ppt/notesSlides/notesSlide7.xml><?xml version="1.0" encoding="utf-8"?>
+<p:notes xmlns:a="http://schemas.openxmlformats.org/drawingml/2006/main" xmlns:r="http://schemas.openxmlformats.org/officeDocument/2006/relationships" xmlns:p="http://schemas.openxmlformats.org/presentationml/2006/main">
+  <p:cSld>
+    <p:spTree>
+      <p:nvGrpSpPr>
+        <p:cNvPr id="1" name=""/>
+        <p:cNvGrpSpPr/>
+        <p:nvPr/>
+      </p:nvGrpSpPr>
+      <p:grpSpPr>
+        <a:xfrm>
+          <a:off x="0" y="0"/>
+          <a:ext cx="0" cy="0"/>
+          <a:chOff x="0" y="0"/>
+          <a:chExt cx="0" cy="0"/>
+        </a:xfrm>
+      </p:grpSpPr>
+      <p:sp>
+        <p:nvSpPr>
+          <p:cNvPr id="2" name="Slide Image Placeholder 1"/>
+          <p:cNvSpPr>
+            <a:spLocks noGrp="1" noRot="1" noChangeAspect="1"/>
+          </p:cNvSpPr>
+          <p:nvPr>
+            <p:ph type="sldImg"/>
+          </p:nvPr>
+        </p:nvSpPr>
+        <p:spPr/>
+      </p:sp>
+      <p:sp>
+        <p:nvSpPr>
+          <p:cNvPr id="3" name="Notes Placeholder 2"/>
+          <p:cNvSpPr>
+            <a:spLocks noGrp="1"/>
+          </p:cNvSpPr>
+          <p:nvPr>
+            <p:ph type="body" idx="1"/>
+          </p:nvPr>
+        </p:nvSpPr>
+        <p:spPr/>
+        <p:txBody>
+          <a:bodyPr/>
+          <a:lstStyle/>
+          <a:p>
+            <a:r>
+              <a:rPr lang="en-US" dirty="0"/>
+              <a:t/>
+            </a:r>
+            <a:endParaRPr lang="en-US" dirty="0"/>
+          </a:p>
+        </p:txBody>
+      </p:sp>
+      <p:sp>
+        <p:nvSpPr>
+          <p:cNvPr id="4" name="Slide Number Placeholder 3"/>
+          <p:cNvSpPr>
+            <a:spLocks noGrp="1"/>
+          </p:cNvSpPr>
+          <p:nvPr>
+            <p:ph type="sldNum" sz="quarter" idx="10"/>
+          </p:nvPr>
+        </p:nvSpPr>
+        <p:spPr/>
+        <p:txBody>
+          <a:bodyPr/>
+          <a:lstStyle/>
+          <a:p>
+            <a:fld id="{F7021451-1387-4CA6-816F-3879F97B5CBC}" type="slidenum">
+              <a:rPr lang="en-US"/>
+              <a:t>7</a:t>
+            </a:fld>
+            <a:endParaRPr lang="en-US"/>
+          </a:p>
+        </p:txBody>
+      </p:sp>
+    </p:spTree>
+    <p:extLst>
+      <p:ext uri="{BB962C8B-B14F-4D97-AF65-F5344CB8AC3E}">
+        <p14:creationId xmlns:p14="http://schemas.microsoft.com/office/powerpoint/2010/main" val="1024086991"/>
+      </p:ext>
+    </p:extLst>
+  </p:cSld>
+  <p:clrMapOvr>
+    <a:masterClrMapping/>
+  </p:clrMapOvr>
+</p:notes>
+</file>
+
 <file path=ppt/slideLayouts/slideLayout1.xml><?xml version="1.0" encoding="utf-8"?>
 <p:sldLayout xmlns:a="http://schemas.openxmlformats.org/drawingml/2006/main" xmlns:r="http://schemas.openxmlformats.org/officeDocument/2006/relationships" xmlns:p="http://schemas.openxmlformats.org/presentationml/2006/main" preserve="1">
   <p:cSld name="DEFAULT">
@@ -1788,6 +1877,51 @@
           </a:p>
         </p:txBody>
       </p:sp>
+      <p:sp>
+        <p:nvSpPr>
+          <p:cNvPr id="5" name="BTN_Next">
+            <a:hlinkClick r:id="rId2" tooltip="" action="ppaction://hlinksldjump"/>
+          </p:cNvPr>
+          <p:cNvSpPr/>
+          <p:nvPr/>
+        </p:nvSpPr>
+        <p:spPr>
+          <a:xfrm>
+            <a:off x="2377440" y="5943600"/>
+            <a:ext cx="1645920" cy="548640"/>
+          </a:xfrm>
+          <a:prstGeom prst="roundRect">
+            <a:avLst>
+              <a:gd name="adj" fmla="val 25000"/>
+            </a:avLst>
+          </a:prstGeom>
+          <a:solidFill>
+            <a:srgbClr val="2E7D6B"/>
+          </a:solidFill>
+          <a:ln/>
+        </p:spPr>
+        <p:txBody>
+          <a:bodyPr wrap="square" rtlCol="0" anchor="ctr"/>
+          <a:lstStyle/>
+          <a:p>
+            <a:pPr algn="ctr" indent="0" marL="0">
+              <a:buNone/>
+            </a:pPr>
+            <a:r>
+              <a:rPr lang="en-US" sz="1400" b="1" dirty="0">
+                <a:solidFill>
+                  <a:srgbClr val="FFFFFF"/>
+                </a:solidFill>
+                <a:latin typeface="Helvetica Neue" pitchFamily="34" charset="0"/>
+                <a:ea typeface="Helvetica Neue" pitchFamily="34" charset="-122"/>
+                <a:cs typeface="Helvetica Neue" pitchFamily="34" charset="-120"/>
+              </a:rPr>
+              <a:t>Next</a:t>
+            </a:r>
+            <a:endParaRPr lang="en-US" sz="1400" dirty="0"/>
+          </a:p>
+        </p:txBody>
+      </p:sp>
     </p:spTree>
   </p:cSld>
   <p:clrMapOvr>
@@ -2431,6 +2565,206 @@
                 <a:cs typeface="Helvetica Neue" pitchFamily="34" charset="-120"/>
               </a:rPr>
               <a:t>Use system or bundled fonts only; anything else is flagged at setup.</a:t>
+            </a:r>
+            <a:endParaRPr lang="en-US" sz="1400" dirty="0"/>
+          </a:p>
+        </p:txBody>
+      </p:sp>
+    </p:spTree>
+  </p:cSld>
+  <p:clrMapOvr>
+    <a:masterClrMapping/>
+  </p:clrMapOvr>
+</p:sld>
+</file>
+
+<file path=ppt/slides/slide7.xml><?xml version="1.0" encoding="utf-8"?>
+<p:sld xmlns:a="http://schemas.openxmlformats.org/drawingml/2006/main" xmlns:r="http://schemas.openxmlformats.org/officeDocument/2006/relationships" xmlns:p="http://schemas.openxmlformats.org/presentationml/2006/main">
+  <p:cSld name="Slide 7">
+    <p:bg>
+      <p:bgPr>
+        <a:solidFill>
+          <a:srgbClr val="F5F3EE"/>
+        </a:solidFill>
+      </p:bgPr>
+    </p:bg>
+    <p:spTree>
+      <p:nvGrpSpPr>
+        <p:cNvPr id="1" name=""/>
+        <p:cNvGrpSpPr/>
+        <p:nvPr/>
+      </p:nvGrpSpPr>
+      <p:grpSpPr>
+        <a:xfrm>
+          <a:off x="0" y="0"/>
+          <a:ext cx="0" cy="0"/>
+          <a:chOff x="0" y="0"/>
+          <a:chExt cx="0" cy="0"/>
+        </a:xfrm>
+      </p:grpSpPr>
+      <p:sp>
+        <p:nvSpPr>
+          <p:cNvPr id="2" name="Text 0"/>
+          <p:cNvSpPr/>
+          <p:nvPr/>
+        </p:nvSpPr>
+        <p:spPr>
+          <a:xfrm>
+            <a:off x="548640" y="457200"/>
+            <a:ext cx="11091672" cy="914400"/>
+          </a:xfrm>
+          <a:prstGeom prst="rect">
+            <a:avLst/>
+          </a:prstGeom>
+          <a:noFill/>
+          <a:ln/>
+        </p:spPr>
+        <p:txBody>
+          <a:bodyPr wrap="square" rtlCol="0" anchor="ctr"/>
+          <a:lstStyle/>
+          <a:p>
+            <a:pPr indent="0" marL="0">
+              <a:buNone/>
+            </a:pPr>
+            <a:r>
+              <a:rPr lang="en-US" sz="3000" b="1" dirty="0">
+                <a:solidFill>
+                  <a:srgbClr val="1B2A4A"/>
+                </a:solidFill>
+                <a:latin typeface="Helvetica Neue" pitchFamily="34" charset="0"/>
+                <a:ea typeface="Helvetica Neue" pitchFamily="34" charset="-122"/>
+                <a:cs typeface="Helvetica Neue" pitchFamily="34" charset="-120"/>
+              </a:rPr>
+              <a:t>Sustainability (continued)</a:t>
+            </a:r>
+            <a:endParaRPr lang="en-US" sz="3000" dirty="0"/>
+          </a:p>
+        </p:txBody>
+      </p:sp>
+      <p:sp>
+        <p:nvSpPr>
+          <p:cNvPr id="3" name="Text 1"/>
+          <p:cNvSpPr/>
+          <p:nvPr/>
+        </p:nvSpPr>
+        <p:spPr>
+          <a:xfrm>
+            <a:off x="548640" y="1554480"/>
+            <a:ext cx="8686800" cy="1828800"/>
+          </a:xfrm>
+          <a:prstGeom prst="rect">
+            <a:avLst/>
+          </a:prstGeom>
+          <a:noFill/>
+          <a:ln/>
+        </p:spPr>
+        <p:txBody>
+          <a:bodyPr wrap="square" rtlCol="0" anchor="t"/>
+          <a:lstStyle/>
+          <a:p>
+            <a:pPr indent="0" marL="0">
+              <a:buNone/>
+            </a:pPr>
+            <a:r>
+              <a:rPr lang="en-US" sz="1600" dirty="0">
+                <a:solidFill>
+                  <a:srgbClr val="333333"/>
+                </a:solidFill>
+                <a:latin typeface="Helvetica Neue" pitchFamily="34" charset="0"/>
+                <a:ea typeface="Helvetica Neue" pitchFamily="34" charset="-122"/>
+                <a:cs typeface="Helvetica Neue" pitchFamily="34" charset="-120"/>
+              </a:rPr>
+              <a:t>A second slide chained from the Sustainability destination via its "Next" button, showing multi-level navigation beyond the Home &lt;-&gt; Destination pair.</a:t>
+            </a:r>
+            <a:endParaRPr lang="en-US" sz="1600" dirty="0"/>
+          </a:p>
+        </p:txBody>
+      </p:sp>
+      <p:sp>
+        <p:nvSpPr>
+          <p:cNvPr id="4" name="BTN_Back">
+            <a:hlinkClick r:id="rId1" tooltip="" action="ppaction://hlinksldjump"/>
+          </p:cNvPr>
+          <p:cNvSpPr/>
+          <p:nvPr/>
+        </p:nvSpPr>
+        <p:spPr>
+          <a:xfrm>
+            <a:off x="548640" y="5943600"/>
+            <a:ext cx="1645920" cy="548640"/>
+          </a:xfrm>
+          <a:prstGeom prst="roundRect">
+            <a:avLst>
+              <a:gd name="adj" fmla="val 25000"/>
+            </a:avLst>
+          </a:prstGeom>
+          <a:solidFill>
+            <a:srgbClr val="2E7D6B"/>
+          </a:solidFill>
+          <a:ln/>
+        </p:spPr>
+        <p:txBody>
+          <a:bodyPr wrap="square" rtlCol="0" anchor="ctr"/>
+          <a:lstStyle/>
+          <a:p>
+            <a:pPr algn="ctr" indent="0" marL="0">
+              <a:buNone/>
+            </a:pPr>
+            <a:r>
+              <a:rPr lang="en-US" sz="1400" b="1" dirty="0">
+                <a:solidFill>
+                  <a:srgbClr val="FFFFFF"/>
+                </a:solidFill>
+                <a:latin typeface="Helvetica Neue" pitchFamily="34" charset="0"/>
+                <a:ea typeface="Helvetica Neue" pitchFamily="34" charset="-122"/>
+                <a:cs typeface="Helvetica Neue" pitchFamily="34" charset="-120"/>
+              </a:rPr>
+              <a:t>Back</a:t>
+            </a:r>
+            <a:endParaRPr lang="en-US" sz="1400" dirty="0"/>
+          </a:p>
+        </p:txBody>
+      </p:sp>
+      <p:sp>
+        <p:nvSpPr>
+          <p:cNvPr id="5" name="BTN_Home">
+            <a:hlinkClick r:id="rId2" tooltip="" action="ppaction://hlinksldjump"/>
+          </p:cNvPr>
+          <p:cNvSpPr/>
+          <p:nvPr/>
+        </p:nvSpPr>
+        <p:spPr>
+          <a:xfrm>
+            <a:off x="2377440" y="5943600"/>
+            <a:ext cx="1645920" cy="548640"/>
+          </a:xfrm>
+          <a:prstGeom prst="roundRect">
+            <a:avLst>
+              <a:gd name="adj" fmla="val 25000"/>
+            </a:avLst>
+          </a:prstGeom>
+          <a:solidFill>
+            <a:srgbClr val="1B2A4A"/>
+          </a:solidFill>
+          <a:ln/>
+        </p:spPr>
+        <p:txBody>
+          <a:bodyPr wrap="square" rtlCol="0" anchor="ctr"/>
+          <a:lstStyle/>
+          <a:p>
+            <a:pPr algn="ctr" indent="0" marL="0">
+              <a:buNone/>
+            </a:pPr>
+            <a:r>
+              <a:rPr lang="en-US" sz="1400" b="1" dirty="0">
+                <a:solidFill>
+                  <a:srgbClr val="FFFFFF"/>
+                </a:solidFill>
+                <a:latin typeface="Helvetica Neue" pitchFamily="34" charset="0"/>
+                <a:ea typeface="Helvetica Neue" pitchFamily="34" charset="-122"/>
+                <a:cs typeface="Helvetica Neue" pitchFamily="34" charset="-120"/>
+              </a:rPr>
+              <a:t>Home</a:t>
             </a:r>
             <a:endParaRPr lang="en-US" sz="1400" dirty="0"/>
           </a:p>

</xml_diff>

<commit_message>
Update template deck: add T&Cs button and slide
Hand-edited in PowerPoint: slide 1 buttons renamed BTN_Link1-4 (first
relabelled "Template Guide") and a new BTN_Terms button links to a new
T&Cs slide 8. Template link-count test updated from 4 to 5.

Co-Authored-By: Claude Opus 5.5 <noreply@anthropic.com>
</commit_message>
<xml_diff>
--- a/public/template.pptx
+++ b/public/template.pptx
@@ -4,20 +4,21 @@
   <p:sldMasterIdLst>
     <p:sldMasterId id="2147483648" r:id="rId1"/>
   </p:sldMasterIdLst>
+  <p:notesMasterIdLst>
+    <p:notesMasterId r:id="rId10"/>
+  </p:notesMasterIdLst>
   <p:sldIdLst>
     <p:sldId id="256" r:id="rId2"/>
     <p:sldId id="257" r:id="rId3"/>
-    <p:sldId id="258" r:id="rId4"/>
-    <p:sldId id="259" r:id="rId5"/>
-    <p:sldId id="260" r:id="rId6"/>
-    <p:sldId id="261" r:id="rId7"/>
-    <p:sldId id="262" r:id="rId8"/>
+    <p:sldId id="262" r:id="rId4"/>
+    <p:sldId id="258" r:id="rId5"/>
+    <p:sldId id="259" r:id="rId6"/>
+    <p:sldId id="260" r:id="rId7"/>
+    <p:sldId id="263" r:id="rId8"/>
+    <p:sldId id="261" r:id="rId9"/>
   </p:sldIdLst>
-  <p:notesMasterIdLst>
-    <p:notesMasterId r:id="rId9"/>
-  </p:notesMasterIdLst>
-  <p:sldSz cx="12191695" cy="6858000"/>
-  <p:notesSz cx="6858000" cy="12191695"/>
+  <p:sldSz cx="12192000" cy="6858000"/>
+  <p:notesSz cx="6858000" cy="12192000"/>
   <p:defaultTextStyle>
     <a:lvl1pPr marL="0" algn="l" defTabSz="914400" rtl="0" eaLnBrk="1" latinLnBrk="0" hangingPunct="1">
       <a:defRPr sz="1800" kern="1200">
@@ -110,6 +111,11 @@
       </a:defRPr>
     </a:lvl9pPr>
   </p:defaultTextStyle>
+  <p:extLst>
+    <p:ext uri="{EFAFB233-063F-42B5-8137-9DF3F51BA10A}">
+      <p15:sldGuideLst xmlns:p15="http://schemas.microsoft.com/office/powerpoint/2012/main"/>
+    </p:ext>
+  </p:extLst>
 </p:presentation>
 </file>
 
@@ -135,234 +141,10 @@
           <a:chExt cx="0" cy="0"/>
         </a:xfrm>
       </p:grpSpPr>
-      <p:sp>
-        <p:nvSpPr>
-          <p:cNvPr id="2" name="Header Placeholder 1"/>
-          <p:cNvSpPr>
-            <a:spLocks noGrp="1"/>
-          </p:cNvSpPr>
-          <p:nvPr>
-            <p:ph type="hdr" sz="quarter"/>
-          </p:nvPr>
-        </p:nvSpPr>
-        <p:spPr>
-          <a:xfrm>
-            <a:off x="0" y="0"/>
-            <a:ext cx="2971800" cy="458788"/>
-          </a:xfrm>
-          <a:prstGeom prst="rect">
-            <a:avLst/>
-          </a:prstGeom>
-        </p:spPr>
-        <p:txBody>
-          <a:bodyPr vert="horz" lIns="91440" tIns="45720" rIns="91440" bIns="45720" rtlCol="0"/>
-          <a:lstStyle>
-            <a:lvl1pPr algn="l">
-              <a:defRPr sz="1200"/>
-            </a:lvl1pPr>
-          </a:lstStyle>
-          <a:p>
-            <a:endParaRPr lang="en-US"/>
-          </a:p>
-        </p:txBody>
-      </p:sp>
-      <p:sp>
-        <p:nvSpPr>
-          <p:cNvPr id="3" name="Date Placeholder 2"/>
-          <p:cNvSpPr>
-            <a:spLocks noGrp="1"/>
-          </p:cNvSpPr>
-          <p:nvPr>
-            <p:ph type="dt" idx="1"/>
-          </p:nvPr>
-        </p:nvSpPr>
-        <p:spPr>
-          <a:xfrm>
-            <a:off x="3884613" y="0"/>
-            <a:ext cx="2971800" cy="458788"/>
-          </a:xfrm>
-          <a:prstGeom prst="rect">
-            <a:avLst/>
-          </a:prstGeom>
-        </p:spPr>
-        <p:txBody>
-          <a:bodyPr vert="horz" lIns="91440" tIns="45720" rIns="91440" bIns="45720" rtlCol="0"/>
-          <a:lstStyle>
-            <a:lvl1pPr algn="r">
-              <a:defRPr sz="1200"/>
-            </a:lvl1pPr>
-          </a:lstStyle>
-          <a:p>
-            <a:fld id="{5282F153-3F37-0F45-9E97-73ACFA13230C}" type="datetimeFigureOut">
-              <a:rPr lang="en-US"/>
-              <a:t>7/23/19</a:t>
-            </a:fld>
-            <a:endParaRPr lang="en-US"/>
-          </a:p>
-        </p:txBody>
-      </p:sp>
-      <p:sp>
-        <p:nvSpPr>
-          <p:cNvPr id="4" name="Slide Image Placeholder 3"/>
-          <p:cNvSpPr>
-            <a:spLocks noGrp="1" noRot="1" noChangeAspect="1"/>
-          </p:cNvSpPr>
-          <p:nvPr>
-            <p:ph type="sldImg" idx="2"/>
-          </p:nvPr>
-        </p:nvSpPr>
-        <p:spPr>
-          <a:xfrm>
-            <a:off x="685800" y="1143000"/>
-            <a:ext cx="5486400" cy="3086100"/>
-          </a:xfrm>
-          <a:prstGeom prst="rect">
-            <a:avLst/>
-          </a:prstGeom>
-          <a:noFill/>
-          <a:ln w="12700">
-            <a:solidFill>
-              <a:prstClr val="black"/>
-            </a:solidFill>
-          </a:ln>
-        </p:spPr>
-        <p:txBody>
-          <a:bodyPr vert="horz" lIns="91440" tIns="45720" rIns="91440" bIns="45720" rtlCol="0" anchor="ctr"/>
-          <a:lstStyle/>
-          <a:p>
-            <a:endParaRPr lang="en-US"/>
-          </a:p>
-        </p:txBody>
-      </p:sp>
-      <p:sp>
-        <p:nvSpPr>
-          <p:cNvPr id="5" name="Notes Placeholder 4"/>
-          <p:cNvSpPr>
-            <a:spLocks noGrp="1"/>
-          </p:cNvSpPr>
-          <p:nvPr>
-            <p:ph type="body" sz="quarter" idx="3"/>
-          </p:nvPr>
-        </p:nvSpPr>
-        <p:spPr>
-          <a:xfrm>
-            <a:off x="685800" y="4400550"/>
-            <a:ext cx="5486400" cy="3600450"/>
-          </a:xfrm>
-          <a:prstGeom prst="rect">
-            <a:avLst/>
-          </a:prstGeom>
-        </p:spPr>
-        <p:txBody>
-          <a:bodyPr vert="horz" lIns="91440" tIns="45720" rIns="91440" bIns="45720" rtlCol="0"/>
-          <a:lstStyle/>
-          <a:p>
-            <a:pPr lvl="0"/>
-            <a:r>
-              <a:rPr lang="en-US"/>
-              <a:t>Click to edit Master text styles</a:t>
-            </a:r>
-          </a:p>
-          <a:p>
-            <a:pPr lvl="1"/>
-            <a:r>
-              <a:rPr lang="en-US"/>
-              <a:t>Second level</a:t>
-            </a:r>
-          </a:p>
-          <a:p>
-            <a:pPr lvl="2"/>
-            <a:r>
-              <a:rPr lang="en-US"/>
-              <a:t>Third level</a:t>
-            </a:r>
-          </a:p>
-          <a:p>
-            <a:pPr lvl="3"/>
-            <a:r>
-              <a:rPr lang="en-US"/>
-              <a:t>Fourth level</a:t>
-            </a:r>
-          </a:p>
-          <a:p>
-            <a:pPr lvl="4"/>
-            <a:r>
-              <a:rPr lang="en-US"/>
-              <a:t>Fifth level</a:t>
-            </a:r>
-          </a:p>
-        </p:txBody>
-      </p:sp>
-      <p:sp>
-        <p:nvSpPr>
-          <p:cNvPr id="6" name="Footer Placeholder 5"/>
-          <p:cNvSpPr>
-            <a:spLocks noGrp="1"/>
-          </p:cNvSpPr>
-          <p:nvPr>
-            <p:ph type="ftr" sz="quarter" idx="4"/>
-          </p:nvPr>
-        </p:nvSpPr>
-        <p:spPr>
-          <a:xfrm>
-            <a:off x="0" y="8685213"/>
-            <a:ext cx="2971800" cy="458787"/>
-          </a:xfrm>
-          <a:prstGeom prst="rect">
-            <a:avLst/>
-          </a:prstGeom>
-        </p:spPr>
-        <p:txBody>
-          <a:bodyPr vert="horz" lIns="91440" tIns="45720" rIns="91440" bIns="45720" rtlCol="0" anchor="b"/>
-          <a:lstStyle>
-            <a:lvl1pPr algn="l">
-              <a:defRPr sz="1200"/>
-            </a:lvl1pPr>
-          </a:lstStyle>
-          <a:p>
-            <a:endParaRPr lang="en-US"/>
-          </a:p>
-        </p:txBody>
-      </p:sp>
-      <p:sp>
-        <p:nvSpPr>
-          <p:cNvPr id="7" name="Slide Number Placeholder 6"/>
-          <p:cNvSpPr>
-            <a:spLocks noGrp="1"/>
-          </p:cNvSpPr>
-          <p:nvPr>
-            <p:ph type="sldNum" sz="quarter" idx="5"/>
-          </p:nvPr>
-        </p:nvSpPr>
-        <p:spPr>
-          <a:xfrm>
-            <a:off x="3884613" y="8685213"/>
-            <a:ext cx="2971800" cy="458787"/>
-          </a:xfrm>
-          <a:prstGeom prst="rect">
-            <a:avLst/>
-          </a:prstGeom>
-        </p:spPr>
-        <p:txBody>
-          <a:bodyPr vert="horz" lIns="91440" tIns="45720" rIns="91440" bIns="45720" rtlCol="0" anchor="b"/>
-          <a:lstStyle>
-            <a:lvl1pPr algn="r">
-              <a:defRPr sz="1200"/>
-            </a:lvl1pPr>
-          </a:lstStyle>
-          <a:p>
-            <a:fld id="{CE5E9CC1-C706-0F49-92D6-E571CC5EEA8F}" type="slidenum">
-              <a:rPr lang="en-US"/>
-              <a:t>‹#›</a:t>
-            </a:fld>
-            <a:endParaRPr lang="en-US"/>
-          </a:p>
-        </p:txBody>
-      </p:sp>
     </p:spTree>
     <p:extLst>
       <p:ext uri="{BB962C8B-B14F-4D97-AF65-F5344CB8AC3E}">
-        <p14:creationId xmlns:p14="http://schemas.microsoft.com/office/powerpoint/2010/main" val="1024086991"/>
+        <p14:creationId xmlns:p14="http://schemas.microsoft.com/office/powerpoint/2010/main" val="3254227340"/>
       </p:ext>
     </p:extLst>
   </p:cSld>
@@ -506,10 +288,6 @@
           <a:bodyPr/>
           <a:lstStyle/>
           <a:p>
-            <a:r>
-              <a:rPr lang="en-US" dirty="0"/>
-              <a:t/>
-            </a:r>
             <a:endParaRPr lang="en-US" dirty="0"/>
           </a:p>
         </p:txBody>
@@ -594,10 +372,6 @@
           <a:bodyPr/>
           <a:lstStyle/>
           <a:p>
-            <a:r>
-              <a:rPr lang="en-US" dirty="0"/>
-              <a:t/>
-            </a:r>
             <a:endParaRPr lang="en-US" dirty="0"/>
           </a:p>
         </p:txBody>
@@ -643,7 +417,13 @@
   <p:cSld>
     <p:spTree>
       <p:nvGrpSpPr>
-        <p:cNvPr id="1" name=""/>
+        <p:cNvPr id="1" name="">
+          <a:extLst>
+            <a:ext uri="{FF2B5EF4-FFF2-40B4-BE49-F238E27FC236}">
+              <a16:creationId xmlns:a16="http://schemas.microsoft.com/office/drawing/2014/main" id="{293D8745-AA8C-9D38-DCD7-006093DA584D}"/>
+            </a:ext>
+          </a:extLst>
+        </p:cNvPr>
         <p:cNvGrpSpPr/>
         <p:nvPr/>
       </p:nvGrpSpPr>
@@ -657,7 +437,13 @@
       </p:grpSpPr>
       <p:sp>
         <p:nvSpPr>
-          <p:cNvPr id="2" name="Slide Image Placeholder 1"/>
+          <p:cNvPr id="2" name="Slide Image Placeholder 1">
+            <a:extLst>
+              <a:ext uri="{FF2B5EF4-FFF2-40B4-BE49-F238E27FC236}">
+                <a16:creationId xmlns:a16="http://schemas.microsoft.com/office/drawing/2014/main" id="{C6E9599B-BFDD-B50F-3CA1-9793C033EC7E}"/>
+              </a:ext>
+            </a:extLst>
+          </p:cNvPr>
           <p:cNvSpPr>
             <a:spLocks noGrp="1" noRot="1" noChangeAspect="1"/>
           </p:cNvSpPr>
@@ -669,7 +455,13 @@
       </p:sp>
       <p:sp>
         <p:nvSpPr>
-          <p:cNvPr id="3" name="Notes Placeholder 2"/>
+          <p:cNvPr id="3" name="Notes Placeholder 2">
+            <a:extLst>
+              <a:ext uri="{FF2B5EF4-FFF2-40B4-BE49-F238E27FC236}">
+                <a16:creationId xmlns:a16="http://schemas.microsoft.com/office/drawing/2014/main" id="{BF0B8906-D50D-239F-7A78-B2036F025FF0}"/>
+              </a:ext>
+            </a:extLst>
+          </p:cNvPr>
           <p:cNvSpPr>
             <a:spLocks noGrp="1"/>
           </p:cNvSpPr>
@@ -682,17 +474,19 @@
           <a:bodyPr/>
           <a:lstStyle/>
           <a:p>
-            <a:r>
-              <a:rPr lang="en-US" dirty="0"/>
-              <a:t/>
-            </a:r>
             <a:endParaRPr lang="en-US" dirty="0"/>
           </a:p>
         </p:txBody>
       </p:sp>
       <p:sp>
         <p:nvSpPr>
-          <p:cNvPr id="4" name="Slide Number Placeholder 3"/>
+          <p:cNvPr id="4" name="Slide Number Placeholder 3">
+            <a:extLst>
+              <a:ext uri="{FF2B5EF4-FFF2-40B4-BE49-F238E27FC236}">
+                <a16:creationId xmlns:a16="http://schemas.microsoft.com/office/drawing/2014/main" id="{C86FA1BD-0F90-2EB0-D2B4-B7B34D587619}"/>
+              </a:ext>
+            </a:extLst>
+          </p:cNvPr>
           <p:cNvSpPr>
             <a:spLocks noGrp="1"/>
           </p:cNvSpPr>
@@ -705,18 +499,78 @@
           <a:bodyPr/>
           <a:lstStyle/>
           <a:p>
+            <a:pPr marL="0" marR="0" lvl="0" indent="0" algn="l" defTabSz="914400" rtl="0" eaLnBrk="1" fontAlgn="auto" latinLnBrk="0" hangingPunct="1">
+              <a:lnSpc>
+                <a:spcPct val="100000"/>
+              </a:lnSpc>
+              <a:spcBef>
+                <a:spcPts val="0"/>
+              </a:spcBef>
+              <a:spcAft>
+                <a:spcPts val="0"/>
+              </a:spcAft>
+              <a:buClrTx/>
+              <a:buSzTx/>
+              <a:buFontTx/>
+              <a:buNone/>
+              <a:tabLst/>
+              <a:defRPr/>
+            </a:pPr>
             <a:fld id="{F7021451-1387-4CA6-816F-3879F97B5CBC}" type="slidenum">
-              <a:rPr lang="en-US"/>
+              <a:rPr kumimoji="0" lang="en-US" sz="1800" b="0" i="0" u="none" strike="noStrike" kern="1200" cap="none" spc="0" normalizeH="0" baseline="0" noProof="0">
+                <a:ln>
+                  <a:noFill/>
+                </a:ln>
+                <a:solidFill>
+                  <a:prstClr val="black"/>
+                </a:solidFill>
+                <a:effectLst/>
+                <a:uLnTx/>
+                <a:uFillTx/>
+                <a:latin typeface="Aptos" panose="02110004020202020204"/>
+                <a:ea typeface="+mn-ea"/>
+                <a:cs typeface="+mn-cs"/>
+              </a:rPr>
+              <a:pPr marL="0" marR="0" lvl="0" indent="0" algn="l" defTabSz="914400" rtl="0" eaLnBrk="1" fontAlgn="auto" latinLnBrk="0" hangingPunct="1">
+                <a:lnSpc>
+                  <a:spcPct val="100000"/>
+                </a:lnSpc>
+                <a:spcBef>
+                  <a:spcPts val="0"/>
+                </a:spcBef>
+                <a:spcAft>
+                  <a:spcPts val="0"/>
+                </a:spcAft>
+                <a:buClrTx/>
+                <a:buSzTx/>
+                <a:buFontTx/>
+                <a:buNone/>
+                <a:tabLst/>
+                <a:defRPr/>
+              </a:pPr>
               <a:t>3</a:t>
             </a:fld>
-            <a:endParaRPr lang="en-US"/>
+            <a:endParaRPr kumimoji="0" lang="en-US" sz="1800" b="0" i="0" u="none" strike="noStrike" kern="1200" cap="none" spc="0" normalizeH="0" baseline="0" noProof="0">
+              <a:ln>
+                <a:noFill/>
+              </a:ln>
+              <a:solidFill>
+                <a:prstClr val="black"/>
+              </a:solidFill>
+              <a:effectLst/>
+              <a:uLnTx/>
+              <a:uFillTx/>
+              <a:latin typeface="Aptos" panose="02110004020202020204"/>
+              <a:ea typeface="+mn-ea"/>
+              <a:cs typeface="+mn-cs"/>
+            </a:endParaRPr>
           </a:p>
         </p:txBody>
       </p:sp>
     </p:spTree>
     <p:extLst>
       <p:ext uri="{BB962C8B-B14F-4D97-AF65-F5344CB8AC3E}">
-        <p14:creationId xmlns:p14="http://schemas.microsoft.com/office/powerpoint/2010/main" val="1024086991"/>
+        <p14:creationId xmlns:p14="http://schemas.microsoft.com/office/powerpoint/2010/main" val="3540153328"/>
       </p:ext>
     </p:extLst>
   </p:cSld>
@@ -770,10 +624,6 @@
           <a:bodyPr/>
           <a:lstStyle/>
           <a:p>
-            <a:r>
-              <a:rPr lang="en-US" dirty="0"/>
-              <a:t/>
-            </a:r>
             <a:endParaRPr lang="en-US" dirty="0"/>
           </a:p>
         </p:txBody>
@@ -858,10 +708,6 @@
           <a:bodyPr/>
           <a:lstStyle/>
           <a:p>
-            <a:r>
-              <a:rPr lang="en-US" dirty="0"/>
-              <a:t/>
-            </a:r>
             <a:endParaRPr lang="en-US" dirty="0"/>
           </a:p>
         </p:txBody>
@@ -946,10 +792,6 @@
           <a:bodyPr/>
           <a:lstStyle/>
           <a:p>
-            <a:r>
-              <a:rPr lang="en-US" dirty="0"/>
-              <a:t/>
-            </a:r>
             <a:endParaRPr lang="en-US" dirty="0"/>
           </a:p>
         </p:txBody>
@@ -995,6 +837,174 @@
   <p:cSld>
     <p:spTree>
       <p:nvGrpSpPr>
+        <p:cNvPr id="1" name="">
+          <a:extLst>
+            <a:ext uri="{FF2B5EF4-FFF2-40B4-BE49-F238E27FC236}">
+              <a16:creationId xmlns:a16="http://schemas.microsoft.com/office/drawing/2014/main" id="{4629953B-2F21-741B-8FF2-2ADA85F09FED}"/>
+            </a:ext>
+          </a:extLst>
+        </p:cNvPr>
+        <p:cNvGrpSpPr/>
+        <p:nvPr/>
+      </p:nvGrpSpPr>
+      <p:grpSpPr>
+        <a:xfrm>
+          <a:off x="0" y="0"/>
+          <a:ext cx="0" cy="0"/>
+          <a:chOff x="0" y="0"/>
+          <a:chExt cx="0" cy="0"/>
+        </a:xfrm>
+      </p:grpSpPr>
+      <p:sp>
+        <p:nvSpPr>
+          <p:cNvPr id="2" name="Slide Image Placeholder 1">
+            <a:extLst>
+              <a:ext uri="{FF2B5EF4-FFF2-40B4-BE49-F238E27FC236}">
+                <a16:creationId xmlns:a16="http://schemas.microsoft.com/office/drawing/2014/main" id="{776F03EF-24FA-CD41-1104-50EA3A76C1B7}"/>
+              </a:ext>
+            </a:extLst>
+          </p:cNvPr>
+          <p:cNvSpPr>
+            <a:spLocks noGrp="1" noRot="1" noChangeAspect="1"/>
+          </p:cNvSpPr>
+          <p:nvPr>
+            <p:ph type="sldImg"/>
+          </p:nvPr>
+        </p:nvSpPr>
+        <p:spPr/>
+      </p:sp>
+      <p:sp>
+        <p:nvSpPr>
+          <p:cNvPr id="3" name="Notes Placeholder 2">
+            <a:extLst>
+              <a:ext uri="{FF2B5EF4-FFF2-40B4-BE49-F238E27FC236}">
+                <a16:creationId xmlns:a16="http://schemas.microsoft.com/office/drawing/2014/main" id="{584F20C4-F069-1839-867D-E7DD4DAF68CB}"/>
+              </a:ext>
+            </a:extLst>
+          </p:cNvPr>
+          <p:cNvSpPr>
+            <a:spLocks noGrp="1"/>
+          </p:cNvSpPr>
+          <p:nvPr>
+            <p:ph type="body" idx="1"/>
+          </p:nvPr>
+        </p:nvSpPr>
+        <p:spPr/>
+        <p:txBody>
+          <a:bodyPr/>
+          <a:lstStyle/>
+          <a:p>
+            <a:endParaRPr lang="en-US" dirty="0"/>
+          </a:p>
+        </p:txBody>
+      </p:sp>
+      <p:sp>
+        <p:nvSpPr>
+          <p:cNvPr id="4" name="Slide Number Placeholder 3">
+            <a:extLst>
+              <a:ext uri="{FF2B5EF4-FFF2-40B4-BE49-F238E27FC236}">
+                <a16:creationId xmlns:a16="http://schemas.microsoft.com/office/drawing/2014/main" id="{54D27528-7CA3-B0AD-503C-7443F0E08F93}"/>
+              </a:ext>
+            </a:extLst>
+          </p:cNvPr>
+          <p:cNvSpPr>
+            <a:spLocks noGrp="1"/>
+          </p:cNvSpPr>
+          <p:nvPr>
+            <p:ph type="sldNum" sz="quarter" idx="10"/>
+          </p:nvPr>
+        </p:nvSpPr>
+        <p:spPr/>
+        <p:txBody>
+          <a:bodyPr/>
+          <a:lstStyle/>
+          <a:p>
+            <a:pPr marL="0" marR="0" lvl="0" indent="0" algn="l" defTabSz="914400" rtl="0" eaLnBrk="1" fontAlgn="auto" latinLnBrk="0" hangingPunct="1">
+              <a:lnSpc>
+                <a:spcPct val="100000"/>
+              </a:lnSpc>
+              <a:spcBef>
+                <a:spcPts val="0"/>
+              </a:spcBef>
+              <a:spcAft>
+                <a:spcPts val="0"/>
+              </a:spcAft>
+              <a:buClrTx/>
+              <a:buSzTx/>
+              <a:buFontTx/>
+              <a:buNone/>
+              <a:tabLst/>
+              <a:defRPr/>
+            </a:pPr>
+            <a:fld id="{F7021451-1387-4CA6-816F-3879F97B5CBC}" type="slidenum">
+              <a:rPr kumimoji="0" lang="en-US" sz="1800" b="0" i="0" u="none" strike="noStrike" kern="1200" cap="none" spc="0" normalizeH="0" baseline="0" noProof="0">
+                <a:ln>
+                  <a:noFill/>
+                </a:ln>
+                <a:solidFill>
+                  <a:prstClr val="black"/>
+                </a:solidFill>
+                <a:effectLst/>
+                <a:uLnTx/>
+                <a:uFillTx/>
+                <a:latin typeface="Aptos" panose="02110004020202020204"/>
+                <a:ea typeface="+mn-ea"/>
+                <a:cs typeface="+mn-cs"/>
+              </a:rPr>
+              <a:pPr marL="0" marR="0" lvl="0" indent="0" algn="l" defTabSz="914400" rtl="0" eaLnBrk="1" fontAlgn="auto" latinLnBrk="0" hangingPunct="1">
+                <a:lnSpc>
+                  <a:spcPct val="100000"/>
+                </a:lnSpc>
+                <a:spcBef>
+                  <a:spcPts val="0"/>
+                </a:spcBef>
+                <a:spcAft>
+                  <a:spcPts val="0"/>
+                </a:spcAft>
+                <a:buClrTx/>
+                <a:buSzTx/>
+                <a:buFontTx/>
+                <a:buNone/>
+                <a:tabLst/>
+                <a:defRPr/>
+              </a:pPr>
+              <a:t>7</a:t>
+            </a:fld>
+            <a:endParaRPr kumimoji="0" lang="en-US" sz="1800" b="0" i="0" u="none" strike="noStrike" kern="1200" cap="none" spc="0" normalizeH="0" baseline="0" noProof="0">
+              <a:ln>
+                <a:noFill/>
+              </a:ln>
+              <a:solidFill>
+                <a:prstClr val="black"/>
+              </a:solidFill>
+              <a:effectLst/>
+              <a:uLnTx/>
+              <a:uFillTx/>
+              <a:latin typeface="Aptos" panose="02110004020202020204"/>
+              <a:ea typeface="+mn-ea"/>
+              <a:cs typeface="+mn-cs"/>
+            </a:endParaRPr>
+          </a:p>
+        </p:txBody>
+      </p:sp>
+    </p:spTree>
+    <p:extLst>
+      <p:ext uri="{BB962C8B-B14F-4D97-AF65-F5344CB8AC3E}">
+        <p14:creationId xmlns:p14="http://schemas.microsoft.com/office/powerpoint/2010/main" val="3598299461"/>
+      </p:ext>
+    </p:extLst>
+  </p:cSld>
+  <p:clrMapOvr>
+    <a:masterClrMapping/>
+  </p:clrMapOvr>
+</p:notes>
+</file>
+
+<file path=ppt/notesSlides/notesSlide8.xml><?xml version="1.0" encoding="utf-8"?>
+<p:notes xmlns:a="http://schemas.openxmlformats.org/drawingml/2006/main" xmlns:r="http://schemas.openxmlformats.org/officeDocument/2006/relationships" xmlns:p="http://schemas.openxmlformats.org/presentationml/2006/main">
+  <p:cSld>
+    <p:spTree>
+      <p:nvGrpSpPr>
         <p:cNvPr id="1" name=""/>
         <p:cNvGrpSpPr/>
         <p:nvPr/>
@@ -1034,10 +1044,6 @@
           <a:bodyPr/>
           <a:lstStyle/>
           <a:p>
-            <a:r>
-              <a:rPr lang="en-US" dirty="0"/>
-              <a:t/>
-            </a:r>
             <a:endParaRPr lang="en-US" dirty="0"/>
           </a:p>
         </p:txBody>
@@ -1059,7 +1065,7 @@
           <a:p>
             <a:fld id="{F7021451-1387-4CA6-816F-3879F97B5CBC}" type="slidenum">
               <a:rPr lang="en-US"/>
-              <a:t>7</a:t>
+              <a:t>8</a:t>
             </a:fld>
             <a:endParaRPr lang="en-US"/>
           </a:p>
@@ -1111,6 +1117,11 @@
 <file path=ppt/slideMasters/slideMaster1.xml><?xml version="1.0" encoding="utf-8"?>
 <p:sldMaster xmlns:a="http://schemas.openxmlformats.org/drawingml/2006/main" xmlns:r="http://schemas.openxmlformats.org/officeDocument/2006/relationships" xmlns:p="http://schemas.openxmlformats.org/presentationml/2006/main">
   <p:cSld>
+    <p:bg>
+      <p:bgRef idx="1001">
+        <a:schemeClr val="bg1"/>
+      </p:bgRef>
+    </p:bg>
     <p:spTree>
       <p:nvGrpSpPr>
         <p:cNvPr id="1" name=""/>
@@ -1393,6 +1404,7 @@
         <a:solidFill>
           <a:srgbClr val="1B2A4A"/>
         </a:solidFill>
+        <a:effectLst/>
       </p:bgPr>
     </p:bg>
     <p:spTree>
@@ -1430,7 +1442,7 @@
           <a:bodyPr wrap="square" rtlCol="0" anchor="ctr"/>
           <a:lstStyle/>
           <a:p>
-            <a:pPr algn="l" indent="0" marL="0">
+            <a:pPr marL="0" indent="0" algn="l">
               <a:buNone/>
             </a:pPr>
             <a:r>
@@ -1469,7 +1481,7 @@
           <a:bodyPr wrap="square" rtlCol="0" anchor="ctr"/>
           <a:lstStyle/>
           <a:p>
-            <a:pPr algn="l" indent="0" marL="0">
+            <a:pPr marL="0" indent="0" algn="l">
               <a:buNone/>
             </a:pPr>
             <a:r>
@@ -1489,8 +1501,8 @@
       </p:sp>
       <p:sp>
         <p:nvSpPr>
-          <p:cNvPr id="4" name="BTN_Sustainability">
-            <a:hlinkClick r:id="rId1" tooltip="" action="ppaction://hlinksldjump"/>
+          <p:cNvPr id="4" name="BTN_Link1">
+            <a:hlinkClick r:id="rId3" action="ppaction://hlinksldjump"/>
           </p:cNvPr>
           <p:cNvSpPr/>
           <p:nvPr/>
@@ -1518,7 +1530,7 @@
           <a:bodyPr wrap="square" rtlCol="0" anchor="ctr"/>
           <a:lstStyle/>
           <a:p>
-            <a:pPr algn="ctr" indent="0" marL="0">
+            <a:pPr marL="0" indent="0" algn="ctr">
               <a:buNone/>
             </a:pPr>
             <a:r>
@@ -1530,7 +1542,28 @@
                 <a:ea typeface="Helvetica Neue" pitchFamily="34" charset="-122"/>
                 <a:cs typeface="Helvetica Neue" pitchFamily="34" charset="-120"/>
               </a:rPr>
-              <a:t>Sustainability</a:t>
+              <a:t>Template</a:t>
+            </a:r>
+            <a:br>
+              <a:rPr lang="en-US" sz="2000" b="1" dirty="0">
+                <a:solidFill>
+                  <a:srgbClr val="FFFFFF"/>
+                </a:solidFill>
+                <a:latin typeface="Helvetica Neue" pitchFamily="34" charset="0"/>
+                <a:ea typeface="Helvetica Neue" pitchFamily="34" charset="-122"/>
+                <a:cs typeface="Helvetica Neue" pitchFamily="34" charset="-120"/>
+              </a:rPr>
+            </a:br>
+            <a:r>
+              <a:rPr lang="en-US" sz="2000" b="1" dirty="0">
+                <a:solidFill>
+                  <a:srgbClr val="FFFFFF"/>
+                </a:solidFill>
+                <a:latin typeface="Helvetica Neue" pitchFamily="34" charset="0"/>
+                <a:ea typeface="Helvetica Neue" pitchFamily="34" charset="-122"/>
+                <a:cs typeface="Helvetica Neue" pitchFamily="34" charset="-120"/>
+              </a:rPr>
+              <a:t>Guide</a:t>
             </a:r>
             <a:endParaRPr lang="en-US" sz="2000" dirty="0"/>
           </a:p>
@@ -1538,8 +1571,8 @@
       </p:sp>
       <p:sp>
         <p:nvSpPr>
-          <p:cNvPr id="5" name="BTN_Innovation">
-            <a:hlinkClick r:id="rId2" tooltip="" action="ppaction://hlinksldjump"/>
+          <p:cNvPr id="5" name="BTN_Link2">
+            <a:hlinkClick r:id="rId4" action="ppaction://hlinksldjump"/>
           </p:cNvPr>
           <p:cNvSpPr/>
           <p:nvPr/>
@@ -1567,7 +1600,7 @@
           <a:bodyPr wrap="square" rtlCol="0" anchor="ctr"/>
           <a:lstStyle/>
           <a:p>
-            <a:pPr algn="ctr" indent="0" marL="0">
+            <a:pPr marL="0" indent="0" algn="ctr">
               <a:buNone/>
             </a:pPr>
             <a:r>
@@ -1587,8 +1620,8 @@
       </p:sp>
       <p:sp>
         <p:nvSpPr>
-          <p:cNvPr id="6" name="BTN_People">
-            <a:hlinkClick r:id="rId3" tooltip="" action="ppaction://hlinksldjump"/>
+          <p:cNvPr id="6" name="BTN_Link3">
+            <a:hlinkClick r:id="rId5" action="ppaction://hlinksldjump"/>
           </p:cNvPr>
           <p:cNvSpPr/>
           <p:nvPr/>
@@ -1616,7 +1649,7 @@
           <a:bodyPr wrap="square" rtlCol="0" anchor="ctr"/>
           <a:lstStyle/>
           <a:p>
-            <a:pPr algn="ctr" indent="0" marL="0">
+            <a:pPr marL="0" indent="0" algn="ctr">
               <a:buNone/>
             </a:pPr>
             <a:r>
@@ -1636,8 +1669,8 @@
       </p:sp>
       <p:sp>
         <p:nvSpPr>
-          <p:cNvPr id="7" name="BTN_Contact">
-            <a:hlinkClick r:id="rId4" tooltip="" action="ppaction://hlinksldjump"/>
+          <p:cNvPr id="7" name="BTN_Link4">
+            <a:hlinkClick r:id="rId6" action="ppaction://hlinksldjump"/>
           </p:cNvPr>
           <p:cNvSpPr/>
           <p:nvPr/>
@@ -1665,7 +1698,7 @@
           <a:bodyPr wrap="square" rtlCol="0" anchor="ctr"/>
           <a:lstStyle/>
           <a:p>
-            <a:pPr algn="ctr" indent="0" marL="0">
+            <a:pPr marL="0" indent="0" algn="ctr">
               <a:buNone/>
             </a:pPr>
             <a:r>
@@ -1704,7 +1737,7 @@
           <a:bodyPr wrap="square" rtlCol="0" anchor="ctr"/>
           <a:lstStyle/>
           <a:p>
-            <a:pPr indent="0" marL="0">
+            <a:pPr marL="0" indent="0">
               <a:buNone/>
             </a:pPr>
             <a:r>
@@ -1719,6 +1752,60 @@
               <a:t>stuPad · offline kiosk</a:t>
             </a:r>
             <a:endParaRPr lang="en-US" sz="1000" dirty="0"/>
+          </a:p>
+        </p:txBody>
+      </p:sp>
+      <p:sp>
+        <p:nvSpPr>
+          <p:cNvPr id="9" name="BTN_Terms">
+            <a:hlinkClick r:id="rId7" action="ppaction://hlinksldjump"/>
+            <a:extLst>
+              <a:ext uri="{FF2B5EF4-FFF2-40B4-BE49-F238E27FC236}">
+                <a16:creationId xmlns:a16="http://schemas.microsoft.com/office/drawing/2014/main" id="{BE410B98-D260-BA31-DC49-4896F10180CF}"/>
+              </a:ext>
+            </a:extLst>
+          </p:cNvPr>
+          <p:cNvSpPr/>
+          <p:nvPr/>
+        </p:nvSpPr>
+        <p:spPr>
+          <a:xfrm>
+            <a:off x="3466948" y="5943600"/>
+            <a:ext cx="1645920" cy="548640"/>
+          </a:xfrm>
+          <a:prstGeom prst="roundRect">
+            <a:avLst>
+              <a:gd name="adj" fmla="val 25000"/>
+            </a:avLst>
+          </a:prstGeom>
+          <a:solidFill>
+            <a:srgbClr val="1B2A4A"/>
+          </a:solidFill>
+          <a:ln>
+            <a:solidFill>
+              <a:schemeClr val="bg2"/>
+            </a:solidFill>
+          </a:ln>
+        </p:spPr>
+        <p:txBody>
+          <a:bodyPr wrap="square" rtlCol="0" anchor="ctr"/>
+          <a:lstStyle/>
+          <a:p>
+            <a:pPr marL="0" indent="0" algn="ctr">
+              <a:buNone/>
+            </a:pPr>
+            <a:r>
+              <a:rPr lang="en-US" sz="1400" b="1" dirty="0">
+                <a:solidFill>
+                  <a:srgbClr val="FFFFFF"/>
+                </a:solidFill>
+                <a:latin typeface="Helvetica Neue" pitchFamily="34" charset="0"/>
+                <a:ea typeface="Helvetica Neue" pitchFamily="34" charset="-122"/>
+                <a:cs typeface="Helvetica Neue" pitchFamily="34" charset="-120"/>
+              </a:rPr>
+              <a:t>T&amp;Cs</a:t>
+            </a:r>
+            <a:endParaRPr lang="en-US" sz="1400" dirty="0"/>
           </a:p>
         </p:txBody>
       </p:sp>
@@ -1736,8 +1823,12 @@
     <p:bg>
       <p:bgPr>
         <a:solidFill>
-          <a:srgbClr val="F5F3EE"/>
+          <a:schemeClr val="accent6">
+            <a:lumMod val="60000"/>
+            <a:lumOff val="40000"/>
+          </a:schemeClr>
         </a:solidFill>
+        <a:effectLst/>
       </p:bgPr>
     </p:bg>
     <p:spTree>
@@ -1775,7 +1866,7 @@
           <a:bodyPr wrap="square" rtlCol="0" anchor="ctr"/>
           <a:lstStyle/>
           <a:p>
-            <a:pPr indent="0" marL="0">
+            <a:pPr marL="0" indent="0">
               <a:buNone/>
             </a:pPr>
             <a:r>
@@ -1787,7 +1878,7 @@
                 <a:ea typeface="Helvetica Neue" pitchFamily="34" charset="-122"/>
                 <a:cs typeface="Helvetica Neue" pitchFamily="34" charset="-120"/>
               </a:rPr>
-              <a:t>Sustainability</a:t>
+              <a:t>Guide – Page 1</a:t>
             </a:r>
             <a:endParaRPr lang="en-US" sz="3000" dirty="0"/>
           </a:p>
@@ -1802,7 +1893,7 @@
         <p:spPr>
           <a:xfrm>
             <a:off x="548640" y="1554480"/>
-            <a:ext cx="8686800" cy="1828800"/>
+            <a:ext cx="8686800" cy="3601982"/>
           </a:xfrm>
           <a:prstGeom prst="rect">
             <a:avLst/>
@@ -1814,10 +1905,21 @@
           <a:bodyPr wrap="square" rtlCol="0" anchor="t"/>
           <a:lstStyle/>
           <a:p>
-            <a:pPr indent="0" marL="0">
+            <a:pPr marL="0" indent="0">
               <a:buNone/>
             </a:pPr>
             <a:r>
+              <a:rPr lang="en-US" sz="1600" dirty="0" err="1">
+                <a:solidFill>
+                  <a:srgbClr val="333333"/>
+                </a:solidFill>
+                <a:latin typeface="Helvetica Neue" pitchFamily="34" charset="0"/>
+                <a:ea typeface="Helvetica Neue" pitchFamily="34" charset="-122"/>
+                <a:cs typeface="Helvetica Neue" pitchFamily="34" charset="-120"/>
+              </a:rPr>
+              <a:t>stuPad</a:t>
+            </a:r>
+            <a:r>
               <a:rPr lang="en-US" sz="1600" dirty="0">
                 <a:solidFill>
                   <a:srgbClr val="333333"/>
@@ -1826,16 +1928,88 @@
                 <a:ea typeface="Helvetica Neue" pitchFamily="34" charset="-122"/>
                 <a:cs typeface="Helvetica Neue" pitchFamily="34" charset="-120"/>
               </a:rPr>
-              <a:t>This is the Sustainability destination slide. It demonstrates text, a solid background and a Home link back to slide 1.</a:t>
+              <a:t> Kiosk uses PowerPoint links to create the navigation structure. Right click the object you want to be a button and edit or add a link and link to the slide you want to.</a:t>
+            </a:r>
+          </a:p>
+          <a:p>
+            <a:pPr marL="0" indent="0">
+              <a:buNone/>
+            </a:pPr>
+            <a:endParaRPr lang="en-US" sz="1600" dirty="0">
+              <a:solidFill>
+                <a:srgbClr val="333333"/>
+              </a:solidFill>
+              <a:latin typeface="Helvetica Neue" pitchFamily="34" charset="0"/>
+              <a:ea typeface="Helvetica Neue" pitchFamily="34" charset="-122"/>
+              <a:cs typeface="Helvetica Neue" pitchFamily="34" charset="-120"/>
+            </a:endParaRPr>
+          </a:p>
+          <a:p>
+            <a:pPr marL="0" indent="0">
+              <a:buNone/>
+            </a:pPr>
+            <a:r>
+              <a:rPr lang="en-US" sz="1600" dirty="0"/>
+              <a:t>If you have a slide that can be accessed from anywhere, such as terms and conditions or a disclaimer, you can add a “back” button that you should add this by choosing insert &gt; action &gt; action on click &gt; link to: Last </a:t>
+            </a:r>
+            <a:r>
+              <a:rPr lang="en-US" sz="1600"/>
+              <a:t>Slide Viewed.</a:t>
             </a:r>
             <a:endParaRPr lang="en-US" sz="1600" dirty="0"/>
           </a:p>
+          <a:p>
+            <a:pPr marL="0" indent="0">
+              <a:buNone/>
+            </a:pPr>
+            <a:endParaRPr lang="en-US" sz="1600" dirty="0"/>
+          </a:p>
+          <a:p>
+            <a:pPr marL="0" indent="0">
+              <a:buNone/>
+            </a:pPr>
+            <a:r>
+              <a:rPr lang="en-US" sz="1600" dirty="0"/>
+              <a:t>When you import the slides into </a:t>
+            </a:r>
+            <a:r>
+              <a:rPr lang="en-US" sz="1600" dirty="0" err="1"/>
+              <a:t>stuPad</a:t>
+            </a:r>
+            <a:r>
+              <a:rPr lang="en-US" sz="1600" dirty="0"/>
+              <a:t> kiosk you can give the links on slide 1 more useful names, in this template they will appear as Link 1, Link 2 </a:t>
+            </a:r>
+            <a:r>
+              <a:rPr lang="en-US" sz="1600" dirty="0" err="1"/>
+              <a:t>etc</a:t>
+            </a:r>
+            <a:r>
+              <a:rPr lang="en-US" sz="1600" dirty="0"/>
+              <a:t>, so you could add more descriptive names for the report. </a:t>
+            </a:r>
+          </a:p>
+          <a:p>
+            <a:pPr marL="0" indent="0">
+              <a:buNone/>
+            </a:pPr>
+            <a:endParaRPr lang="en-US" sz="1600" dirty="0"/>
+          </a:p>
+          <a:p>
+            <a:pPr marL="0" indent="0">
+              <a:buNone/>
+            </a:pPr>
+            <a:r>
+              <a:rPr lang="en-US" sz="1600" dirty="0"/>
+              <a:t>If you add or remove slides you are strongly advised to test every link and flow on an iPad if you add or remove slides.</a:t>
+            </a:r>
+          </a:p>
         </p:txBody>
       </p:sp>
       <p:sp>
         <p:nvSpPr>
           <p:cNvPr id="4" name="BTN_Home">
-            <a:hlinkClick r:id="rId1" tooltip="" action="ppaction://hlinksldjump"/>
+            <a:hlinkClick r:id="rId3" action="ppaction://hlinksldjump"/>
           </p:cNvPr>
           <p:cNvSpPr/>
           <p:nvPr/>
@@ -1859,7 +2033,7 @@
           <a:bodyPr wrap="square" rtlCol="0" anchor="ctr"/>
           <a:lstStyle/>
           <a:p>
-            <a:pPr algn="ctr" indent="0" marL="0">
+            <a:pPr marL="0" indent="0" algn="ctr">
               <a:buNone/>
             </a:pPr>
             <a:r>
@@ -1880,14 +2054,19 @@
       <p:sp>
         <p:nvSpPr>
           <p:cNvPr id="5" name="BTN_Next">
-            <a:hlinkClick r:id="rId2" tooltip="" action="ppaction://hlinksldjump"/>
+            <a:hlinkClick r:id="rId3" action="ppaction://hlinksldjump"/>
+            <a:extLst>
+              <a:ext uri="{FF2B5EF4-FFF2-40B4-BE49-F238E27FC236}">
+                <a16:creationId xmlns:a16="http://schemas.microsoft.com/office/drawing/2014/main" id="{12B3850C-901E-25F7-28AB-7B0812705D3B}"/>
+              </a:ext>
+            </a:extLst>
           </p:cNvPr>
           <p:cNvSpPr/>
           <p:nvPr/>
         </p:nvSpPr>
         <p:spPr>
           <a:xfrm>
-            <a:off x="2377440" y="5943600"/>
+            <a:off x="9993977" y="5943600"/>
             <a:ext cx="1645920" cy="548640"/>
           </a:xfrm>
           <a:prstGeom prst="roundRect">
@@ -1896,7 +2075,7 @@
             </a:avLst>
           </a:prstGeom>
           <a:solidFill>
-            <a:srgbClr val="2E7D6B"/>
+            <a:srgbClr val="1B2A4A"/>
           </a:solidFill>
           <a:ln/>
         </p:spPr>
@@ -1904,7 +2083,7 @@
           <a:bodyPr wrap="square" rtlCol="0" anchor="ctr"/>
           <a:lstStyle/>
           <a:p>
-            <a:pPr algn="ctr" indent="0" marL="0">
+            <a:pPr marL="0" indent="0" algn="ctr">
               <a:buNone/>
             </a:pPr>
             <a:r>
@@ -1917,6 +2096,60 @@
                 <a:cs typeface="Helvetica Neue" pitchFamily="34" charset="-120"/>
               </a:rPr>
               <a:t>Next</a:t>
+            </a:r>
+            <a:endParaRPr lang="en-US" sz="1400" dirty="0"/>
+          </a:p>
+        </p:txBody>
+      </p:sp>
+      <p:sp>
+        <p:nvSpPr>
+          <p:cNvPr id="8" name="BTN_Terms">
+            <a:hlinkClick r:id="rId4" action="ppaction://hlinksldjump"/>
+            <a:extLst>
+              <a:ext uri="{FF2B5EF4-FFF2-40B4-BE49-F238E27FC236}">
+                <a16:creationId xmlns:a16="http://schemas.microsoft.com/office/drawing/2014/main" id="{89106FCE-ADD6-B649-F062-78FDA9806C79}"/>
+              </a:ext>
+            </a:extLst>
+          </p:cNvPr>
+          <p:cNvSpPr/>
+          <p:nvPr/>
+        </p:nvSpPr>
+        <p:spPr>
+          <a:xfrm>
+            <a:off x="3466948" y="5943600"/>
+            <a:ext cx="1645920" cy="548640"/>
+          </a:xfrm>
+          <a:prstGeom prst="roundRect">
+            <a:avLst>
+              <a:gd name="adj" fmla="val 25000"/>
+            </a:avLst>
+          </a:prstGeom>
+          <a:solidFill>
+            <a:srgbClr val="1B2A4A"/>
+          </a:solidFill>
+          <a:ln>
+            <a:solidFill>
+              <a:schemeClr val="bg2"/>
+            </a:solidFill>
+          </a:ln>
+        </p:spPr>
+        <p:txBody>
+          <a:bodyPr wrap="square" rtlCol="0" anchor="ctr"/>
+          <a:lstStyle/>
+          <a:p>
+            <a:pPr marL="0" indent="0" algn="ctr">
+              <a:buNone/>
+            </a:pPr>
+            <a:r>
+              <a:rPr lang="en-US" sz="1400" b="1" dirty="0">
+                <a:solidFill>
+                  <a:srgbClr val="FFFFFF"/>
+                </a:solidFill>
+                <a:latin typeface="Helvetica Neue" pitchFamily="34" charset="0"/>
+                <a:ea typeface="Helvetica Neue" pitchFamily="34" charset="-122"/>
+                <a:cs typeface="Helvetica Neue" pitchFamily="34" charset="-120"/>
+              </a:rPr>
+              <a:t>T&amp;Cs</a:t>
             </a:r>
             <a:endParaRPr lang="en-US" sz="1400" dirty="0"/>
           </a:p>
@@ -1932,12 +2165,550 @@
 
 <file path=ppt/slides/slide3.xml><?xml version="1.0" encoding="utf-8"?>
 <p:sld xmlns:a="http://schemas.openxmlformats.org/drawingml/2006/main" xmlns:r="http://schemas.openxmlformats.org/officeDocument/2006/relationships" xmlns:p="http://schemas.openxmlformats.org/presentationml/2006/main">
+  <p:cSld>
+    <p:bg>
+      <p:bgPr>
+        <a:solidFill>
+          <a:schemeClr val="accent6">
+            <a:lumMod val="60000"/>
+            <a:lumOff val="40000"/>
+          </a:schemeClr>
+        </a:solidFill>
+        <a:effectLst/>
+      </p:bgPr>
+    </p:bg>
+    <p:spTree>
+      <p:nvGrpSpPr>
+        <p:cNvPr id="1" name="">
+          <a:extLst>
+            <a:ext uri="{FF2B5EF4-FFF2-40B4-BE49-F238E27FC236}">
+              <a16:creationId xmlns:a16="http://schemas.microsoft.com/office/drawing/2014/main" id="{CEB4770F-B33E-5E31-947B-D81A782A9A8C}"/>
+            </a:ext>
+          </a:extLst>
+        </p:cNvPr>
+        <p:cNvGrpSpPr/>
+        <p:nvPr/>
+      </p:nvGrpSpPr>
+      <p:grpSpPr>
+        <a:xfrm>
+          <a:off x="0" y="0"/>
+          <a:ext cx="0" cy="0"/>
+          <a:chOff x="0" y="0"/>
+          <a:chExt cx="0" cy="0"/>
+        </a:xfrm>
+      </p:grpSpPr>
+      <p:sp>
+        <p:nvSpPr>
+          <p:cNvPr id="2" name="Text 0">
+            <a:extLst>
+              <a:ext uri="{FF2B5EF4-FFF2-40B4-BE49-F238E27FC236}">
+                <a16:creationId xmlns:a16="http://schemas.microsoft.com/office/drawing/2014/main" id="{2106AEA1-9C00-25DF-2D9A-AB52C8F1ED1E}"/>
+              </a:ext>
+            </a:extLst>
+          </p:cNvPr>
+          <p:cNvSpPr/>
+          <p:nvPr/>
+        </p:nvSpPr>
+        <p:spPr>
+          <a:xfrm>
+            <a:off x="548640" y="457200"/>
+            <a:ext cx="11091672" cy="914400"/>
+          </a:xfrm>
+          <a:prstGeom prst="rect">
+            <a:avLst/>
+          </a:prstGeom>
+          <a:noFill/>
+          <a:ln/>
+        </p:spPr>
+        <p:txBody>
+          <a:bodyPr wrap="square" rtlCol="0" anchor="ctr"/>
+          <a:lstStyle/>
+          <a:p>
+            <a:pPr marL="0" marR="0" lvl="0" indent="0" algn="l" defTabSz="914400" rtl="0" eaLnBrk="1" fontAlgn="auto" latinLnBrk="0" hangingPunct="1">
+              <a:lnSpc>
+                <a:spcPct val="100000"/>
+              </a:lnSpc>
+              <a:spcBef>
+                <a:spcPts val="0"/>
+              </a:spcBef>
+              <a:spcAft>
+                <a:spcPts val="0"/>
+              </a:spcAft>
+              <a:buClrTx/>
+              <a:buSzTx/>
+              <a:buFontTx/>
+              <a:buNone/>
+              <a:tabLst/>
+              <a:defRPr/>
+            </a:pPr>
+            <a:r>
+              <a:rPr kumimoji="0" lang="en-US" sz="3000" b="1" i="0" u="none" strike="noStrike" kern="1200" cap="none" spc="0" normalizeH="0" baseline="0" noProof="0" dirty="0">
+                <a:ln>
+                  <a:noFill/>
+                </a:ln>
+                <a:solidFill>
+                  <a:srgbClr val="1B2A4A"/>
+                </a:solidFill>
+                <a:effectLst/>
+                <a:uLnTx/>
+                <a:uFillTx/>
+                <a:latin typeface="Helvetica Neue" pitchFamily="34" charset="0"/>
+                <a:ea typeface="Helvetica Neue" pitchFamily="34" charset="-122"/>
+                <a:cs typeface="Helvetica Neue" pitchFamily="34" charset="-120"/>
+              </a:rPr>
+              <a:t>Guide - Page 2</a:t>
+            </a:r>
+            <a:endParaRPr kumimoji="0" lang="en-US" sz="3000" b="0" i="0" u="none" strike="noStrike" kern="1200" cap="none" spc="0" normalizeH="0" baseline="0" noProof="0" dirty="0">
+              <a:ln>
+                <a:noFill/>
+              </a:ln>
+              <a:solidFill>
+                <a:prstClr val="black"/>
+              </a:solidFill>
+              <a:effectLst/>
+              <a:uLnTx/>
+              <a:uFillTx/>
+              <a:latin typeface="Calibri" panose="020F0502020204030204"/>
+              <a:ea typeface="+mn-ea"/>
+              <a:cs typeface="+mn-cs"/>
+            </a:endParaRPr>
+          </a:p>
+        </p:txBody>
+      </p:sp>
+      <p:sp>
+        <p:nvSpPr>
+          <p:cNvPr id="3" name="Text 1">
+            <a:extLst>
+              <a:ext uri="{FF2B5EF4-FFF2-40B4-BE49-F238E27FC236}">
+                <a16:creationId xmlns:a16="http://schemas.microsoft.com/office/drawing/2014/main" id="{DB8F994C-9D66-8A14-F7A7-546A5B0F2EEB}"/>
+              </a:ext>
+            </a:extLst>
+          </p:cNvPr>
+          <p:cNvSpPr/>
+          <p:nvPr/>
+        </p:nvSpPr>
+        <p:spPr>
+          <a:xfrm>
+            <a:off x="548640" y="1554479"/>
+            <a:ext cx="8686800" cy="3799945"/>
+          </a:xfrm>
+          <a:prstGeom prst="rect">
+            <a:avLst/>
+          </a:prstGeom>
+          <a:noFill/>
+          <a:ln/>
+        </p:spPr>
+        <p:txBody>
+          <a:bodyPr wrap="square" rtlCol="0" anchor="t"/>
+          <a:lstStyle/>
+          <a:p>
+            <a:pPr marL="0" marR="0" lvl="0" indent="0" algn="l" defTabSz="914400" rtl="0" eaLnBrk="1" fontAlgn="auto" latinLnBrk="0" hangingPunct="1">
+              <a:lnSpc>
+                <a:spcPct val="100000"/>
+              </a:lnSpc>
+              <a:spcBef>
+                <a:spcPts val="0"/>
+              </a:spcBef>
+              <a:spcAft>
+                <a:spcPts val="0"/>
+              </a:spcAft>
+              <a:buClrTx/>
+              <a:buSzTx/>
+              <a:buFontTx/>
+              <a:buNone/>
+              <a:tabLst/>
+              <a:defRPr/>
+            </a:pPr>
+            <a:r>
+              <a:rPr kumimoji="0" lang="en-US" sz="1600" b="0" i="0" u="none" strike="noStrike" kern="1200" cap="none" spc="0" normalizeH="0" baseline="0" noProof="0" dirty="0">
+                <a:ln>
+                  <a:noFill/>
+                </a:ln>
+                <a:solidFill>
+                  <a:srgbClr val="333333"/>
+                </a:solidFill>
+                <a:effectLst/>
+                <a:uLnTx/>
+                <a:uFillTx/>
+                <a:latin typeface="Helvetica Neue" pitchFamily="34" charset="0"/>
+                <a:ea typeface="Helvetica Neue" pitchFamily="34" charset="-122"/>
+                <a:cs typeface="Helvetica Neue" pitchFamily="34" charset="-120"/>
+              </a:rPr>
+              <a:t>There are some limitations to the slide render engine that the iPad software uses. Any text that has flowed beyond the bounds of the text box will be cut off and cropping images can be inconsistent.</a:t>
+            </a:r>
+          </a:p>
+          <a:p>
+            <a:pPr marL="0" marR="0" lvl="0" indent="0" algn="l" defTabSz="914400" rtl="0" eaLnBrk="1" fontAlgn="auto" latinLnBrk="0" hangingPunct="1">
+              <a:lnSpc>
+                <a:spcPct val="100000"/>
+              </a:lnSpc>
+              <a:spcBef>
+                <a:spcPts val="0"/>
+              </a:spcBef>
+              <a:spcAft>
+                <a:spcPts val="0"/>
+              </a:spcAft>
+              <a:buClrTx/>
+              <a:buSzTx/>
+              <a:buFontTx/>
+              <a:buNone/>
+              <a:tabLst/>
+              <a:defRPr/>
+            </a:pPr>
+            <a:endParaRPr lang="en-US" sz="1600" dirty="0">
+              <a:solidFill>
+                <a:srgbClr val="333333"/>
+              </a:solidFill>
+              <a:latin typeface="Helvetica Neue" pitchFamily="34" charset="0"/>
+              <a:ea typeface="Helvetica Neue" pitchFamily="34" charset="-122"/>
+              <a:cs typeface="Helvetica Neue" pitchFamily="34" charset="-120"/>
+            </a:endParaRPr>
+          </a:p>
+          <a:p>
+            <a:pPr marL="0" marR="0" lvl="0" indent="0" algn="l" defTabSz="914400" rtl="0" eaLnBrk="1" fontAlgn="auto" latinLnBrk="0" hangingPunct="1">
+              <a:lnSpc>
+                <a:spcPct val="100000"/>
+              </a:lnSpc>
+              <a:spcBef>
+                <a:spcPts val="0"/>
+              </a:spcBef>
+              <a:spcAft>
+                <a:spcPts val="0"/>
+              </a:spcAft>
+              <a:buClrTx/>
+              <a:buSzTx/>
+              <a:buFontTx/>
+              <a:buNone/>
+              <a:tabLst/>
+              <a:defRPr/>
+            </a:pPr>
+            <a:r>
+              <a:rPr kumimoji="0" lang="en-US" sz="1600" b="0" i="0" u="none" strike="noStrike" kern="1200" cap="none" spc="0" normalizeH="0" baseline="0" noProof="0" dirty="0">
+                <a:ln>
+                  <a:noFill/>
+                </a:ln>
+                <a:solidFill>
+                  <a:srgbClr val="333333"/>
+                </a:solidFill>
+                <a:effectLst/>
+                <a:uLnTx/>
+                <a:uFillTx/>
+                <a:latin typeface="Helvetica Neue" pitchFamily="34" charset="0"/>
+                <a:ea typeface="Helvetica Neue" pitchFamily="34" charset="-122"/>
+                <a:cs typeface="Helvetica Neue" pitchFamily="34" charset="-120"/>
+              </a:rPr>
+              <a:t>You can configure the settings of the app when you import the slides. You should also configure guided access mode to restrict the iPad to only running the </a:t>
+            </a:r>
+            <a:r>
+              <a:rPr kumimoji="0" lang="en-US" sz="1600" b="0" i="0" u="none" strike="noStrike" kern="1200" cap="none" spc="0" normalizeH="0" baseline="0" noProof="0" dirty="0" err="1">
+                <a:ln>
+                  <a:noFill/>
+                </a:ln>
+                <a:solidFill>
+                  <a:srgbClr val="333333"/>
+                </a:solidFill>
+                <a:effectLst/>
+                <a:uLnTx/>
+                <a:uFillTx/>
+                <a:latin typeface="Helvetica Neue" pitchFamily="34" charset="0"/>
+                <a:ea typeface="Helvetica Neue" pitchFamily="34" charset="-122"/>
+                <a:cs typeface="Helvetica Neue" pitchFamily="34" charset="-120"/>
+              </a:rPr>
+              <a:t>stuPad</a:t>
+            </a:r>
+            <a:r>
+              <a:rPr kumimoji="0" lang="en-US" sz="1600" b="0" i="0" u="none" strike="noStrike" kern="1200" cap="none" spc="0" normalizeH="0" baseline="0" noProof="0" dirty="0">
+                <a:ln>
+                  <a:noFill/>
+                </a:ln>
+                <a:solidFill>
+                  <a:srgbClr val="333333"/>
+                </a:solidFill>
+                <a:effectLst/>
+                <a:uLnTx/>
+                <a:uFillTx/>
+                <a:latin typeface="Helvetica Neue" pitchFamily="34" charset="0"/>
+                <a:ea typeface="Helvetica Neue" pitchFamily="34" charset="-122"/>
+                <a:cs typeface="Helvetica Neue" pitchFamily="34" charset="-120"/>
+              </a:rPr>
+              <a:t> webapp. </a:t>
+            </a:r>
+          </a:p>
+          <a:p>
+            <a:pPr marL="0" marR="0" lvl="0" indent="0" algn="l" defTabSz="914400" rtl="0" eaLnBrk="1" fontAlgn="auto" latinLnBrk="0" hangingPunct="1">
+              <a:lnSpc>
+                <a:spcPct val="100000"/>
+              </a:lnSpc>
+              <a:spcBef>
+                <a:spcPts val="0"/>
+              </a:spcBef>
+              <a:spcAft>
+                <a:spcPts val="0"/>
+              </a:spcAft>
+              <a:buClrTx/>
+              <a:buSzTx/>
+              <a:buFontTx/>
+              <a:buNone/>
+              <a:tabLst/>
+              <a:defRPr/>
+            </a:pPr>
+            <a:endParaRPr lang="en-US" sz="1600" dirty="0">
+              <a:solidFill>
+                <a:srgbClr val="333333"/>
+              </a:solidFill>
+              <a:latin typeface="Helvetica Neue" pitchFamily="34" charset="0"/>
+              <a:ea typeface="Helvetica Neue" pitchFamily="34" charset="-122"/>
+              <a:cs typeface="Helvetica Neue" pitchFamily="34" charset="-120"/>
+            </a:endParaRPr>
+          </a:p>
+          <a:p>
+            <a:pPr marL="0" marR="0" lvl="0" indent="0" algn="l" defTabSz="914400" rtl="0" eaLnBrk="1" fontAlgn="auto" latinLnBrk="0" hangingPunct="1">
+              <a:lnSpc>
+                <a:spcPct val="100000"/>
+              </a:lnSpc>
+              <a:spcBef>
+                <a:spcPts val="0"/>
+              </a:spcBef>
+              <a:spcAft>
+                <a:spcPts val="0"/>
+              </a:spcAft>
+              <a:buClrTx/>
+              <a:buSzTx/>
+              <a:buFontTx/>
+              <a:buNone/>
+              <a:tabLst/>
+              <a:defRPr/>
+            </a:pPr>
+            <a:r>
+              <a:rPr kumimoji="0" lang="en-US" sz="1600" b="0" i="0" u="none" strike="noStrike" kern="1200" cap="none" spc="0" normalizeH="0" baseline="0" noProof="0" dirty="0">
+                <a:ln>
+                  <a:noFill/>
+                </a:ln>
+                <a:solidFill>
+                  <a:srgbClr val="333333"/>
+                </a:solidFill>
+                <a:effectLst/>
+                <a:uLnTx/>
+                <a:uFillTx/>
+                <a:latin typeface="Helvetica Neue" pitchFamily="34" charset="0"/>
+                <a:ea typeface="Helvetica Neue" pitchFamily="34" charset="-122"/>
+                <a:cs typeface="Helvetica Neue" pitchFamily="34" charset="-120"/>
+              </a:rPr>
+              <a:t>You should run </a:t>
+            </a:r>
+            <a:r>
+              <a:rPr kumimoji="0" lang="en-US" sz="1600" b="0" i="0" u="none" strike="noStrike" kern="1200" cap="none" spc="0" normalizeH="0" baseline="0" noProof="0" dirty="0" err="1">
+                <a:ln>
+                  <a:noFill/>
+                </a:ln>
+                <a:solidFill>
+                  <a:srgbClr val="333333"/>
+                </a:solidFill>
+                <a:effectLst/>
+                <a:uLnTx/>
+                <a:uFillTx/>
+                <a:latin typeface="Helvetica Neue" pitchFamily="34" charset="0"/>
+                <a:ea typeface="Helvetica Neue" pitchFamily="34" charset="-122"/>
+                <a:cs typeface="Helvetica Neue" pitchFamily="34" charset="-120"/>
+              </a:rPr>
+              <a:t>stuPad</a:t>
+            </a:r>
+            <a:r>
+              <a:rPr kumimoji="0" lang="en-US" sz="1600" b="0" i="0" u="none" strike="noStrike" kern="1200" cap="none" spc="0" normalizeH="0" baseline="0" noProof="0" dirty="0">
+                <a:ln>
+                  <a:noFill/>
+                </a:ln>
+                <a:solidFill>
+                  <a:srgbClr val="333333"/>
+                </a:solidFill>
+                <a:effectLst/>
+                <a:uLnTx/>
+                <a:uFillTx/>
+                <a:latin typeface="Helvetica Neue" pitchFamily="34" charset="0"/>
+                <a:ea typeface="Helvetica Neue" pitchFamily="34" charset="-122"/>
+                <a:cs typeface="Helvetica Neue" pitchFamily="34" charset="-120"/>
+              </a:rPr>
+              <a:t> as a webapp that you have added to the iPad home screen as this reduces the chance of losing any interaction data.</a:t>
+            </a:r>
+            <a:endParaRPr kumimoji="0" lang="en-US" sz="1600" b="0" i="0" u="none" strike="noStrike" kern="1200" cap="none" spc="0" normalizeH="0" baseline="0" noProof="0" dirty="0">
+              <a:ln>
+                <a:noFill/>
+              </a:ln>
+              <a:solidFill>
+                <a:prstClr val="black"/>
+              </a:solidFill>
+              <a:effectLst/>
+              <a:uLnTx/>
+              <a:uFillTx/>
+              <a:latin typeface="Calibri" panose="020F0502020204030204"/>
+              <a:ea typeface="+mn-ea"/>
+              <a:cs typeface="+mn-cs"/>
+            </a:endParaRPr>
+          </a:p>
+        </p:txBody>
+      </p:sp>
+      <p:sp>
+        <p:nvSpPr>
+          <p:cNvPr id="4" name="BTN_Home">
+            <a:hlinkClick r:id="rId3" action="ppaction://hlinksldjump"/>
+            <a:extLst>
+              <a:ext uri="{FF2B5EF4-FFF2-40B4-BE49-F238E27FC236}">
+                <a16:creationId xmlns:a16="http://schemas.microsoft.com/office/drawing/2014/main" id="{D0ECCD7E-3B69-9352-1EAD-BB549E93B519}"/>
+              </a:ext>
+            </a:extLst>
+          </p:cNvPr>
+          <p:cNvSpPr/>
+          <p:nvPr/>
+        </p:nvSpPr>
+        <p:spPr>
+          <a:xfrm>
+            <a:off x="548640" y="5943600"/>
+            <a:ext cx="1645920" cy="548640"/>
+          </a:xfrm>
+          <a:prstGeom prst="roundRect">
+            <a:avLst>
+              <a:gd name="adj" fmla="val 25000"/>
+            </a:avLst>
+          </a:prstGeom>
+          <a:solidFill>
+            <a:srgbClr val="1B2A4A"/>
+          </a:solidFill>
+          <a:ln/>
+        </p:spPr>
+        <p:txBody>
+          <a:bodyPr wrap="square" rtlCol="0" anchor="ctr"/>
+          <a:lstStyle/>
+          <a:p>
+            <a:pPr marL="0" marR="0" lvl="0" indent="0" algn="ctr" defTabSz="914400" rtl="0" eaLnBrk="1" fontAlgn="auto" latinLnBrk="0" hangingPunct="1">
+              <a:lnSpc>
+                <a:spcPct val="100000"/>
+              </a:lnSpc>
+              <a:spcBef>
+                <a:spcPts val="0"/>
+              </a:spcBef>
+              <a:spcAft>
+                <a:spcPts val="0"/>
+              </a:spcAft>
+              <a:buClrTx/>
+              <a:buSzTx/>
+              <a:buFontTx/>
+              <a:buNone/>
+              <a:tabLst/>
+              <a:defRPr/>
+            </a:pPr>
+            <a:r>
+              <a:rPr kumimoji="0" lang="en-US" sz="1400" b="1" i="0" u="none" strike="noStrike" kern="1200" cap="none" spc="0" normalizeH="0" baseline="0" noProof="0" dirty="0">
+                <a:ln>
+                  <a:noFill/>
+                </a:ln>
+                <a:solidFill>
+                  <a:srgbClr val="FFFFFF"/>
+                </a:solidFill>
+                <a:effectLst/>
+                <a:uLnTx/>
+                <a:uFillTx/>
+                <a:latin typeface="Helvetica Neue" pitchFamily="34" charset="0"/>
+                <a:ea typeface="Helvetica Neue" pitchFamily="34" charset="-122"/>
+                <a:cs typeface="Helvetica Neue" pitchFamily="34" charset="-120"/>
+              </a:rPr>
+              <a:t>Home</a:t>
+            </a:r>
+            <a:endParaRPr kumimoji="0" lang="en-US" sz="1400" b="0" i="0" u="none" strike="noStrike" kern="1200" cap="none" spc="0" normalizeH="0" baseline="0" noProof="0" dirty="0">
+              <a:ln>
+                <a:noFill/>
+              </a:ln>
+              <a:solidFill>
+                <a:prstClr val="black"/>
+              </a:solidFill>
+              <a:effectLst/>
+              <a:uLnTx/>
+              <a:uFillTx/>
+              <a:latin typeface="Calibri" panose="020F0502020204030204"/>
+              <a:ea typeface="+mn-ea"/>
+              <a:cs typeface="+mn-cs"/>
+            </a:endParaRPr>
+          </a:p>
+        </p:txBody>
+      </p:sp>
+      <p:sp>
+        <p:nvSpPr>
+          <p:cNvPr id="6" name="BTN_Terms">
+            <a:hlinkClick r:id="rId4" action="ppaction://hlinksldjump"/>
+            <a:extLst>
+              <a:ext uri="{FF2B5EF4-FFF2-40B4-BE49-F238E27FC236}">
+                <a16:creationId xmlns:a16="http://schemas.microsoft.com/office/drawing/2014/main" id="{99076447-D2C8-8DA4-FEB2-7058C6E80B72}"/>
+              </a:ext>
+            </a:extLst>
+          </p:cNvPr>
+          <p:cNvSpPr/>
+          <p:nvPr/>
+        </p:nvSpPr>
+        <p:spPr>
+          <a:xfrm>
+            <a:off x="3466948" y="5943600"/>
+            <a:ext cx="1645920" cy="548640"/>
+          </a:xfrm>
+          <a:prstGeom prst="roundRect">
+            <a:avLst>
+              <a:gd name="adj" fmla="val 25000"/>
+            </a:avLst>
+          </a:prstGeom>
+          <a:solidFill>
+            <a:srgbClr val="1B2A4A"/>
+          </a:solidFill>
+          <a:ln>
+            <a:solidFill>
+              <a:schemeClr val="bg2"/>
+            </a:solidFill>
+          </a:ln>
+        </p:spPr>
+        <p:txBody>
+          <a:bodyPr wrap="square" rtlCol="0" anchor="ctr"/>
+          <a:lstStyle/>
+          <a:p>
+            <a:pPr marL="0" indent="0" algn="ctr">
+              <a:buNone/>
+            </a:pPr>
+            <a:r>
+              <a:rPr lang="en-US" sz="1400" b="1" dirty="0">
+                <a:solidFill>
+                  <a:srgbClr val="FFFFFF"/>
+                </a:solidFill>
+                <a:latin typeface="Helvetica Neue" pitchFamily="34" charset="0"/>
+                <a:ea typeface="Helvetica Neue" pitchFamily="34" charset="-122"/>
+                <a:cs typeface="Helvetica Neue" pitchFamily="34" charset="-120"/>
+              </a:rPr>
+              <a:t>T&amp;Cs</a:t>
+            </a:r>
+            <a:endParaRPr lang="en-US" sz="1400" dirty="0"/>
+          </a:p>
+        </p:txBody>
+      </p:sp>
+    </p:spTree>
+    <p:extLst>
+      <p:ext uri="{BB962C8B-B14F-4D97-AF65-F5344CB8AC3E}">
+        <p14:creationId xmlns:p14="http://schemas.microsoft.com/office/powerpoint/2010/main" val="589714743"/>
+      </p:ext>
+    </p:extLst>
+  </p:cSld>
+  <p:clrMapOvr>
+    <a:masterClrMapping/>
+  </p:clrMapOvr>
+</p:sld>
+</file>
+
+<file path=ppt/slides/slide4.xml><?xml version="1.0" encoding="utf-8"?>
+<p:sld xmlns:a="http://schemas.openxmlformats.org/drawingml/2006/main" xmlns:r="http://schemas.openxmlformats.org/officeDocument/2006/relationships" xmlns:p="http://schemas.openxmlformats.org/presentationml/2006/main">
   <p:cSld name="Slide 3">
     <p:bg>
       <p:bgPr>
         <a:solidFill>
-          <a:srgbClr val="F5F3EE"/>
+          <a:schemeClr val="accent1">
+            <a:lumMod val="60000"/>
+            <a:lumOff val="40000"/>
+          </a:schemeClr>
         </a:solidFill>
+        <a:effectLst/>
       </p:bgPr>
     </p:bg>
     <p:spTree>
@@ -1975,7 +2746,7 @@
           <a:bodyPr wrap="square" rtlCol="0" anchor="ctr"/>
           <a:lstStyle/>
           <a:p>
-            <a:pPr indent="0" marL="0">
+            <a:pPr marL="0" indent="0">
               <a:buNone/>
             </a:pPr>
             <a:r>
@@ -2014,7 +2785,7 @@
           <a:bodyPr wrap="square" rtlCol="0" anchor="t"/>
           <a:lstStyle/>
           <a:p>
-            <a:pPr indent="0" marL="0">
+            <a:pPr marL="0" indent="0">
               <a:buNone/>
             </a:pPr>
             <a:r>
@@ -2035,7 +2806,7 @@
       <p:sp>
         <p:nvSpPr>
           <p:cNvPr id="4" name="BTN_Home">
-            <a:hlinkClick r:id="rId1" tooltip="" action="ppaction://hlinksldjump"/>
+            <a:hlinkClick r:id="rId3" action="ppaction://hlinksldjump"/>
           </p:cNvPr>
           <p:cNvSpPr/>
           <p:nvPr/>
@@ -2059,7 +2830,7 @@
           <a:bodyPr wrap="square" rtlCol="0" anchor="ctr"/>
           <a:lstStyle/>
           <a:p>
-            <a:pPr algn="ctr" indent="0" marL="0">
+            <a:pPr marL="0" indent="0" algn="ctr">
               <a:buNone/>
             </a:pPr>
             <a:r>
@@ -2072,6 +2843,60 @@
                 <a:cs typeface="Helvetica Neue" pitchFamily="34" charset="-120"/>
               </a:rPr>
               <a:t>Home</a:t>
+            </a:r>
+            <a:endParaRPr lang="en-US" sz="1400" dirty="0"/>
+          </a:p>
+        </p:txBody>
+      </p:sp>
+      <p:sp>
+        <p:nvSpPr>
+          <p:cNvPr id="6" name="BTN_Terms">
+            <a:hlinkClick r:id="rId4" action="ppaction://hlinksldjump"/>
+            <a:extLst>
+              <a:ext uri="{FF2B5EF4-FFF2-40B4-BE49-F238E27FC236}">
+                <a16:creationId xmlns:a16="http://schemas.microsoft.com/office/drawing/2014/main" id="{1DAB0F41-7943-356C-A24A-70231D828551}"/>
+              </a:ext>
+            </a:extLst>
+          </p:cNvPr>
+          <p:cNvSpPr/>
+          <p:nvPr/>
+        </p:nvSpPr>
+        <p:spPr>
+          <a:xfrm>
+            <a:off x="3466948" y="5943600"/>
+            <a:ext cx="1645920" cy="548640"/>
+          </a:xfrm>
+          <a:prstGeom prst="roundRect">
+            <a:avLst>
+              <a:gd name="adj" fmla="val 25000"/>
+            </a:avLst>
+          </a:prstGeom>
+          <a:solidFill>
+            <a:srgbClr val="1B2A4A"/>
+          </a:solidFill>
+          <a:ln>
+            <a:solidFill>
+              <a:schemeClr val="bg2"/>
+            </a:solidFill>
+          </a:ln>
+        </p:spPr>
+        <p:txBody>
+          <a:bodyPr wrap="square" rtlCol="0" anchor="ctr"/>
+          <a:lstStyle/>
+          <a:p>
+            <a:pPr marL="0" indent="0" algn="ctr">
+              <a:buNone/>
+            </a:pPr>
+            <a:r>
+              <a:rPr lang="en-US" sz="1400" b="1" dirty="0">
+                <a:solidFill>
+                  <a:srgbClr val="FFFFFF"/>
+                </a:solidFill>
+                <a:latin typeface="Helvetica Neue" pitchFamily="34" charset="0"/>
+                <a:ea typeface="Helvetica Neue" pitchFamily="34" charset="-122"/>
+                <a:cs typeface="Helvetica Neue" pitchFamily="34" charset="-120"/>
+              </a:rPr>
+              <a:t>T&amp;Cs</a:t>
             </a:r>
             <a:endParaRPr lang="en-US" sz="1400" dirty="0"/>
           </a:p>
@@ -2085,14 +2910,18 @@
 </p:sld>
 </file>
 
-<file path=ppt/slides/slide4.xml><?xml version="1.0" encoding="utf-8"?>
+<file path=ppt/slides/slide5.xml><?xml version="1.0" encoding="utf-8"?>
 <p:sld xmlns:a="http://schemas.openxmlformats.org/drawingml/2006/main" xmlns:r="http://schemas.openxmlformats.org/officeDocument/2006/relationships" xmlns:p="http://schemas.openxmlformats.org/presentationml/2006/main">
   <p:cSld name="Slide 4">
     <p:bg>
       <p:bgPr>
         <a:solidFill>
-          <a:srgbClr val="F5F3EE"/>
+          <a:schemeClr val="accent4">
+            <a:lumMod val="60000"/>
+            <a:lumOff val="40000"/>
+          </a:schemeClr>
         </a:solidFill>
+        <a:effectLst/>
       </p:bgPr>
     </p:bg>
     <p:spTree>
@@ -2130,7 +2959,7 @@
           <a:bodyPr wrap="square" rtlCol="0" anchor="ctr"/>
           <a:lstStyle/>
           <a:p>
-            <a:pPr indent="0" marL="0">
+            <a:pPr marL="0" indent="0">
               <a:buNone/>
             </a:pPr>
             <a:r>
@@ -2169,7 +2998,7 @@
           <a:bodyPr wrap="square" rtlCol="0" anchor="t"/>
           <a:lstStyle/>
           <a:p>
-            <a:pPr indent="0" marL="0">
+            <a:pPr marL="0" indent="0">
               <a:buNone/>
             </a:pPr>
             <a:r>
@@ -2190,7 +3019,7 @@
       <p:sp>
         <p:nvSpPr>
           <p:cNvPr id="4" name="BTN_Home">
-            <a:hlinkClick r:id="rId1" tooltip="" action="ppaction://hlinksldjump"/>
+            <a:hlinkClick r:id="rId3" action="ppaction://hlinksldjump"/>
           </p:cNvPr>
           <p:cNvSpPr/>
           <p:nvPr/>
@@ -2214,7 +3043,7 @@
           <a:bodyPr wrap="square" rtlCol="0" anchor="ctr"/>
           <a:lstStyle/>
           <a:p>
-            <a:pPr algn="ctr" indent="0" marL="0">
+            <a:pPr marL="0" indent="0" algn="ctr">
               <a:buNone/>
             </a:pPr>
             <a:r>
@@ -2227,6 +3056,60 @@
                 <a:cs typeface="Helvetica Neue" pitchFamily="34" charset="-120"/>
               </a:rPr>
               <a:t>Home</a:t>
+            </a:r>
+            <a:endParaRPr lang="en-US" sz="1400" dirty="0"/>
+          </a:p>
+        </p:txBody>
+      </p:sp>
+      <p:sp>
+        <p:nvSpPr>
+          <p:cNvPr id="5" name="BTN_Terms">
+            <a:hlinkClick r:id="rId4" action="ppaction://hlinksldjump"/>
+            <a:extLst>
+              <a:ext uri="{FF2B5EF4-FFF2-40B4-BE49-F238E27FC236}">
+                <a16:creationId xmlns:a16="http://schemas.microsoft.com/office/drawing/2014/main" id="{980D1034-E51B-9730-0986-C983C691ED2E}"/>
+              </a:ext>
+            </a:extLst>
+          </p:cNvPr>
+          <p:cNvSpPr/>
+          <p:nvPr/>
+        </p:nvSpPr>
+        <p:spPr>
+          <a:xfrm>
+            <a:off x="3466948" y="5943600"/>
+            <a:ext cx="1645920" cy="548640"/>
+          </a:xfrm>
+          <a:prstGeom prst="roundRect">
+            <a:avLst>
+              <a:gd name="adj" fmla="val 25000"/>
+            </a:avLst>
+          </a:prstGeom>
+          <a:solidFill>
+            <a:srgbClr val="1B2A4A"/>
+          </a:solidFill>
+          <a:ln>
+            <a:solidFill>
+              <a:schemeClr val="bg2"/>
+            </a:solidFill>
+          </a:ln>
+        </p:spPr>
+        <p:txBody>
+          <a:bodyPr wrap="square" rtlCol="0" anchor="ctr"/>
+          <a:lstStyle/>
+          <a:p>
+            <a:pPr marL="0" indent="0" algn="ctr">
+              <a:buNone/>
+            </a:pPr>
+            <a:r>
+              <a:rPr lang="en-US" sz="1400" b="1" dirty="0">
+                <a:solidFill>
+                  <a:srgbClr val="FFFFFF"/>
+                </a:solidFill>
+                <a:latin typeface="Helvetica Neue" pitchFamily="34" charset="0"/>
+                <a:ea typeface="Helvetica Neue" pitchFamily="34" charset="-122"/>
+                <a:cs typeface="Helvetica Neue" pitchFamily="34" charset="-120"/>
+              </a:rPr>
+              <a:t>T&amp;Cs</a:t>
             </a:r>
             <a:endParaRPr lang="en-US" sz="1400" dirty="0"/>
           </a:p>
@@ -2240,14 +3123,17 @@
 </p:sld>
 </file>
 
-<file path=ppt/slides/slide5.xml><?xml version="1.0" encoding="utf-8"?>
+<file path=ppt/slides/slide6.xml><?xml version="1.0" encoding="utf-8"?>
 <p:sld xmlns:a="http://schemas.openxmlformats.org/drawingml/2006/main" xmlns:r="http://schemas.openxmlformats.org/officeDocument/2006/relationships" xmlns:p="http://schemas.openxmlformats.org/presentationml/2006/main">
   <p:cSld name="Slide 5">
     <p:bg>
       <p:bgPr>
         <a:solidFill>
-          <a:srgbClr val="F5F3EE"/>
+          <a:srgbClr val="7A2E5C">
+            <a:alpha val="65490"/>
+          </a:srgbClr>
         </a:solidFill>
+        <a:effectLst/>
       </p:bgPr>
     </p:bg>
     <p:spTree>
@@ -2285,13 +3171,13 @@
           <a:bodyPr wrap="square" rtlCol="0" anchor="ctr"/>
           <a:lstStyle/>
           <a:p>
-            <a:pPr indent="0" marL="0">
+            <a:pPr marL="0" indent="0">
               <a:buNone/>
             </a:pPr>
             <a:r>
               <a:rPr lang="en-US" sz="3000" b="1" dirty="0">
                 <a:solidFill>
-                  <a:srgbClr val="1B2A4A"/>
+                  <a:schemeClr val="bg1"/>
                 </a:solidFill>
                 <a:latin typeface="Helvetica Neue" pitchFamily="34" charset="0"/>
                 <a:ea typeface="Helvetica Neue" pitchFamily="34" charset="-122"/>
@@ -2299,7 +3185,11 @@
               </a:rPr>
               <a:t>Contact</a:t>
             </a:r>
-            <a:endParaRPr lang="en-US" sz="3000" dirty="0"/>
+            <a:endParaRPr lang="en-US" sz="3000" dirty="0">
+              <a:solidFill>
+                <a:schemeClr val="bg1"/>
+              </a:solidFill>
+            </a:endParaRPr>
           </a:p>
         </p:txBody>
       </p:sp>
@@ -2324,13 +3214,13 @@
           <a:bodyPr wrap="square" rtlCol="0" anchor="t"/>
           <a:lstStyle/>
           <a:p>
-            <a:pPr indent="0" marL="0">
+            <a:pPr marL="0" indent="0">
               <a:buNone/>
             </a:pPr>
             <a:r>
               <a:rPr lang="en-US" sz="1600" dirty="0">
                 <a:solidFill>
-                  <a:srgbClr val="333333"/>
+                  <a:schemeClr val="bg1"/>
                 </a:solidFill>
                 <a:latin typeface="Helvetica Neue" pitchFamily="34" charset="0"/>
                 <a:ea typeface="Helvetica Neue" pitchFamily="34" charset="-122"/>
@@ -2338,14 +3228,18 @@
               </a:rPr>
               <a:t>This is the Contact destination slide. It demonstrates text, a solid background and a Home link back to slide 1.</a:t>
             </a:r>
-            <a:endParaRPr lang="en-US" sz="1600" dirty="0"/>
+            <a:endParaRPr lang="en-US" sz="1600" dirty="0">
+              <a:solidFill>
+                <a:schemeClr val="bg1"/>
+              </a:solidFill>
+            </a:endParaRPr>
           </a:p>
         </p:txBody>
       </p:sp>
       <p:sp>
         <p:nvSpPr>
           <p:cNvPr id="4" name="BTN_Home">
-            <a:hlinkClick r:id="rId1" tooltip="" action="ppaction://hlinksldjump"/>
+            <a:hlinkClick r:id="rId3" action="ppaction://hlinksldjump"/>
           </p:cNvPr>
           <p:cNvSpPr/>
           <p:nvPr/>
@@ -2369,7 +3263,7 @@
           <a:bodyPr wrap="square" rtlCol="0" anchor="ctr"/>
           <a:lstStyle/>
           <a:p>
-            <a:pPr algn="ctr" indent="0" marL="0">
+            <a:pPr marL="0" indent="0" algn="ctr">
               <a:buNone/>
             </a:pPr>
             <a:r>
@@ -2382,6 +3276,60 @@
                 <a:cs typeface="Helvetica Neue" pitchFamily="34" charset="-120"/>
               </a:rPr>
               <a:t>Home</a:t>
+            </a:r>
+            <a:endParaRPr lang="en-US" sz="1400" dirty="0"/>
+          </a:p>
+        </p:txBody>
+      </p:sp>
+      <p:sp>
+        <p:nvSpPr>
+          <p:cNvPr id="5" name="BTN_Terms">
+            <a:hlinkClick r:id="rId4" action="ppaction://hlinksldjump"/>
+            <a:extLst>
+              <a:ext uri="{FF2B5EF4-FFF2-40B4-BE49-F238E27FC236}">
+                <a16:creationId xmlns:a16="http://schemas.microsoft.com/office/drawing/2014/main" id="{5FE546F3-60AF-86F9-820B-5EDB2FD096BB}"/>
+              </a:ext>
+            </a:extLst>
+          </p:cNvPr>
+          <p:cNvSpPr/>
+          <p:nvPr/>
+        </p:nvSpPr>
+        <p:spPr>
+          <a:xfrm>
+            <a:off x="3466948" y="5943600"/>
+            <a:ext cx="1645920" cy="548640"/>
+          </a:xfrm>
+          <a:prstGeom prst="roundRect">
+            <a:avLst>
+              <a:gd name="adj" fmla="val 25000"/>
+            </a:avLst>
+          </a:prstGeom>
+          <a:solidFill>
+            <a:srgbClr val="1B2A4A"/>
+          </a:solidFill>
+          <a:ln>
+            <a:solidFill>
+              <a:schemeClr val="bg2"/>
+            </a:solidFill>
+          </a:ln>
+        </p:spPr>
+        <p:txBody>
+          <a:bodyPr wrap="square" rtlCol="0" anchor="ctr"/>
+          <a:lstStyle/>
+          <a:p>
+            <a:pPr marL="0" indent="0" algn="ctr">
+              <a:buNone/>
+            </a:pPr>
+            <a:r>
+              <a:rPr lang="en-US" sz="1400" b="1" dirty="0">
+                <a:solidFill>
+                  <a:srgbClr val="FFFFFF"/>
+                </a:solidFill>
+                <a:latin typeface="Helvetica Neue" pitchFamily="34" charset="0"/>
+                <a:ea typeface="Helvetica Neue" pitchFamily="34" charset="-122"/>
+                <a:cs typeface="Helvetica Neue" pitchFamily="34" charset="-120"/>
+              </a:rPr>
+              <a:t>T&amp;Cs</a:t>
             </a:r>
             <a:endParaRPr lang="en-US" sz="1400" dirty="0"/>
           </a:p>
@@ -2395,7 +3343,442 @@
 </p:sld>
 </file>
 
-<file path=ppt/slides/slide6.xml><?xml version="1.0" encoding="utf-8"?>
+<file path=ppt/slides/slide7.xml><?xml version="1.0" encoding="utf-8"?>
+<p:sld xmlns:a="http://schemas.openxmlformats.org/drawingml/2006/main" xmlns:r="http://schemas.openxmlformats.org/officeDocument/2006/relationships" xmlns:p="http://schemas.openxmlformats.org/presentationml/2006/main">
+  <p:cSld>
+    <p:bg>
+      <p:bgPr>
+        <a:solidFill>
+          <a:srgbClr val="F5F3EE"/>
+        </a:solidFill>
+        <a:effectLst/>
+      </p:bgPr>
+    </p:bg>
+    <p:spTree>
+      <p:nvGrpSpPr>
+        <p:cNvPr id="1" name="">
+          <a:extLst>
+            <a:ext uri="{FF2B5EF4-FFF2-40B4-BE49-F238E27FC236}">
+              <a16:creationId xmlns:a16="http://schemas.microsoft.com/office/drawing/2014/main" id="{F3756800-8B0B-5E52-70F7-665232F60A55}"/>
+            </a:ext>
+          </a:extLst>
+        </p:cNvPr>
+        <p:cNvGrpSpPr/>
+        <p:nvPr/>
+      </p:nvGrpSpPr>
+      <p:grpSpPr>
+        <a:xfrm>
+          <a:off x="0" y="0"/>
+          <a:ext cx="0" cy="0"/>
+          <a:chOff x="0" y="0"/>
+          <a:chExt cx="0" cy="0"/>
+        </a:xfrm>
+      </p:grpSpPr>
+      <p:sp>
+        <p:nvSpPr>
+          <p:cNvPr id="2" name="Text 0">
+            <a:extLst>
+              <a:ext uri="{FF2B5EF4-FFF2-40B4-BE49-F238E27FC236}">
+                <a16:creationId xmlns:a16="http://schemas.microsoft.com/office/drawing/2014/main" id="{F201B3AE-24D2-46AF-DE43-BE4145C55A77}"/>
+              </a:ext>
+            </a:extLst>
+          </p:cNvPr>
+          <p:cNvSpPr/>
+          <p:nvPr/>
+        </p:nvSpPr>
+        <p:spPr>
+          <a:xfrm>
+            <a:off x="548640" y="457200"/>
+            <a:ext cx="11091672" cy="914400"/>
+          </a:xfrm>
+          <a:prstGeom prst="rect">
+            <a:avLst/>
+          </a:prstGeom>
+          <a:noFill/>
+          <a:ln/>
+        </p:spPr>
+        <p:txBody>
+          <a:bodyPr wrap="square" rtlCol="0" anchor="ctr"/>
+          <a:lstStyle/>
+          <a:p>
+            <a:pPr marL="0" marR="0" lvl="0" indent="0" algn="l" defTabSz="914400" rtl="0" eaLnBrk="1" fontAlgn="auto" latinLnBrk="0" hangingPunct="1">
+              <a:lnSpc>
+                <a:spcPct val="100000"/>
+              </a:lnSpc>
+              <a:spcBef>
+                <a:spcPts val="0"/>
+              </a:spcBef>
+              <a:spcAft>
+                <a:spcPts val="0"/>
+              </a:spcAft>
+              <a:buClrTx/>
+              <a:buSzTx/>
+              <a:buFontTx/>
+              <a:buNone/>
+              <a:tabLst/>
+              <a:defRPr/>
+            </a:pPr>
+            <a:r>
+              <a:rPr kumimoji="0" lang="en-US" sz="3000" b="1" i="0" u="none" strike="noStrike" kern="1200" cap="none" spc="0" normalizeH="0" baseline="0" noProof="0" dirty="0">
+                <a:ln>
+                  <a:noFill/>
+                </a:ln>
+                <a:solidFill>
+                  <a:srgbClr val="1B2A4A"/>
+                </a:solidFill>
+                <a:effectLst/>
+                <a:uLnTx/>
+                <a:uFillTx/>
+                <a:latin typeface="Helvetica Neue" pitchFamily="34" charset="0"/>
+                <a:ea typeface="Helvetica Neue" pitchFamily="34" charset="-122"/>
+                <a:cs typeface="Helvetica Neue" pitchFamily="34" charset="-120"/>
+              </a:rPr>
+              <a:t>Terms and Conditions</a:t>
+            </a:r>
+            <a:endParaRPr kumimoji="0" lang="en-US" sz="3000" b="0" i="0" u="none" strike="noStrike" kern="1200" cap="none" spc="0" normalizeH="0" baseline="0" noProof="0" dirty="0">
+              <a:ln>
+                <a:noFill/>
+              </a:ln>
+              <a:solidFill>
+                <a:prstClr val="black"/>
+              </a:solidFill>
+              <a:effectLst/>
+              <a:uLnTx/>
+              <a:uFillTx/>
+              <a:latin typeface="Calibri" panose="020F0502020204030204"/>
+              <a:ea typeface="+mn-ea"/>
+              <a:cs typeface="+mn-cs"/>
+            </a:endParaRPr>
+          </a:p>
+        </p:txBody>
+      </p:sp>
+      <p:sp>
+        <p:nvSpPr>
+          <p:cNvPr id="3" name="Text 1">
+            <a:extLst>
+              <a:ext uri="{FF2B5EF4-FFF2-40B4-BE49-F238E27FC236}">
+                <a16:creationId xmlns:a16="http://schemas.microsoft.com/office/drawing/2014/main" id="{930A4AEB-FD72-5751-938B-DF814B61170F}"/>
+              </a:ext>
+            </a:extLst>
+          </p:cNvPr>
+          <p:cNvSpPr/>
+          <p:nvPr/>
+        </p:nvSpPr>
+        <p:spPr>
+          <a:xfrm>
+            <a:off x="548640" y="1554480"/>
+            <a:ext cx="8686800" cy="1828800"/>
+          </a:xfrm>
+          <a:prstGeom prst="rect">
+            <a:avLst/>
+          </a:prstGeom>
+          <a:noFill/>
+          <a:ln/>
+        </p:spPr>
+        <p:txBody>
+          <a:bodyPr wrap="square" rtlCol="0" anchor="t"/>
+          <a:lstStyle/>
+          <a:p>
+            <a:pPr marL="0" marR="0" lvl="0" indent="0" algn="l" defTabSz="914400" rtl="0" eaLnBrk="1" fontAlgn="auto" latinLnBrk="0" hangingPunct="1">
+              <a:lnSpc>
+                <a:spcPct val="100000"/>
+              </a:lnSpc>
+              <a:spcBef>
+                <a:spcPts val="0"/>
+              </a:spcBef>
+              <a:spcAft>
+                <a:spcPts val="0"/>
+              </a:spcAft>
+              <a:buClrTx/>
+              <a:buSzTx/>
+              <a:buFontTx/>
+              <a:buNone/>
+              <a:tabLst/>
+              <a:defRPr/>
+            </a:pPr>
+            <a:r>
+              <a:rPr kumimoji="0" lang="en-US" sz="1600" b="0" i="0" u="none" strike="noStrike" kern="1200" cap="none" spc="0" normalizeH="0" baseline="0" noProof="0" dirty="0">
+                <a:ln>
+                  <a:noFill/>
+                </a:ln>
+                <a:solidFill>
+                  <a:srgbClr val="333333"/>
+                </a:solidFill>
+                <a:effectLst/>
+                <a:uLnTx/>
+                <a:uFillTx/>
+                <a:latin typeface="Helvetica Neue" pitchFamily="34" charset="0"/>
+                <a:ea typeface="Helvetica Neue" pitchFamily="34" charset="-122"/>
+                <a:cs typeface="Helvetica Neue" pitchFamily="34" charset="-120"/>
+              </a:rPr>
+              <a:t>This is an example of a slide that will navigate to the previous slide.</a:t>
+            </a:r>
+            <a:br>
+              <a:rPr kumimoji="0" lang="en-US" sz="1600" b="0" i="0" u="none" strike="noStrike" kern="1200" cap="none" spc="0" normalizeH="0" baseline="0" noProof="0" dirty="0">
+                <a:ln>
+                  <a:noFill/>
+                </a:ln>
+                <a:solidFill>
+                  <a:srgbClr val="333333"/>
+                </a:solidFill>
+                <a:effectLst/>
+                <a:uLnTx/>
+                <a:uFillTx/>
+                <a:latin typeface="Helvetica Neue" pitchFamily="34" charset="0"/>
+                <a:ea typeface="Helvetica Neue" pitchFamily="34" charset="-122"/>
+                <a:cs typeface="Helvetica Neue" pitchFamily="34" charset="-120"/>
+              </a:rPr>
+            </a:br>
+            <a:br>
+              <a:rPr kumimoji="0" lang="en-US" sz="1600" b="0" i="0" u="none" strike="noStrike" kern="1200" cap="none" spc="0" normalizeH="0" baseline="0" noProof="0" dirty="0">
+                <a:ln>
+                  <a:noFill/>
+                </a:ln>
+                <a:solidFill>
+                  <a:srgbClr val="333333"/>
+                </a:solidFill>
+                <a:effectLst/>
+                <a:uLnTx/>
+                <a:uFillTx/>
+                <a:latin typeface="Helvetica Neue" pitchFamily="34" charset="0"/>
+                <a:ea typeface="Helvetica Neue" pitchFamily="34" charset="-122"/>
+                <a:cs typeface="Helvetica Neue" pitchFamily="34" charset="-120"/>
+              </a:rPr>
+            </a:br>
+            <a:r>
+              <a:rPr kumimoji="0" lang="en-US" sz="1600" b="0" i="0" u="none" strike="noStrike" kern="1200" cap="none" spc="0" normalizeH="0" baseline="0" noProof="0" dirty="0">
+                <a:ln>
+                  <a:noFill/>
+                </a:ln>
+                <a:solidFill>
+                  <a:srgbClr val="333333"/>
+                </a:solidFill>
+                <a:effectLst/>
+                <a:uLnTx/>
+                <a:uFillTx/>
+                <a:latin typeface="Helvetica Neue" pitchFamily="34" charset="0"/>
+                <a:ea typeface="Helvetica Neue" pitchFamily="34" charset="-122"/>
+                <a:cs typeface="Helvetica Neue" pitchFamily="34" charset="-120"/>
+              </a:rPr>
+              <a:t>This special case needs to be added by choosing:</a:t>
+            </a:r>
+            <a:br>
+              <a:rPr kumimoji="0" lang="en-US" sz="1600" b="0" i="0" u="none" strike="noStrike" kern="1200" cap="none" spc="0" normalizeH="0" baseline="0" noProof="0" dirty="0">
+                <a:ln>
+                  <a:noFill/>
+                </a:ln>
+                <a:solidFill>
+                  <a:srgbClr val="333333"/>
+                </a:solidFill>
+                <a:effectLst/>
+                <a:uLnTx/>
+                <a:uFillTx/>
+                <a:latin typeface="Helvetica Neue" pitchFamily="34" charset="0"/>
+                <a:ea typeface="Helvetica Neue" pitchFamily="34" charset="-122"/>
+                <a:cs typeface="Helvetica Neue" pitchFamily="34" charset="-120"/>
+              </a:rPr>
+            </a:br>
+            <a:br>
+              <a:rPr kumimoji="0" lang="en-US" sz="1600" b="0" i="0" u="none" strike="noStrike" kern="1200" cap="none" spc="0" normalizeH="0" baseline="0" noProof="0" dirty="0">
+                <a:ln>
+                  <a:noFill/>
+                </a:ln>
+                <a:solidFill>
+                  <a:srgbClr val="333333"/>
+                </a:solidFill>
+                <a:effectLst/>
+                <a:uLnTx/>
+                <a:uFillTx/>
+                <a:latin typeface="Helvetica Neue" pitchFamily="34" charset="0"/>
+                <a:ea typeface="Helvetica Neue" pitchFamily="34" charset="-122"/>
+                <a:cs typeface="Helvetica Neue" pitchFamily="34" charset="-120"/>
+              </a:rPr>
+            </a:br>
+            <a:r>
+              <a:rPr kumimoji="0" lang="en-US" sz="1600" b="0" i="0" u="none" strike="noStrike" kern="1200" cap="none" spc="0" normalizeH="0" baseline="0" noProof="0" dirty="0">
+                <a:ln>
+                  <a:noFill/>
+                </a:ln>
+                <a:solidFill>
+                  <a:srgbClr val="333333"/>
+                </a:solidFill>
+                <a:effectLst/>
+                <a:uLnTx/>
+                <a:uFillTx/>
+                <a:latin typeface="Helvetica Neue" pitchFamily="34" charset="0"/>
+                <a:ea typeface="Helvetica Neue" pitchFamily="34" charset="-122"/>
+                <a:cs typeface="Helvetica Neue" pitchFamily="34" charset="-120"/>
+              </a:rPr>
+              <a:t>Insert &gt; Action &gt; Action on click &gt; Last Slide Viewed </a:t>
+            </a:r>
+            <a:endParaRPr kumimoji="0" lang="en-US" sz="1600" b="0" i="0" u="none" strike="noStrike" kern="1200" cap="none" spc="0" normalizeH="0" baseline="0" noProof="0" dirty="0">
+              <a:ln>
+                <a:noFill/>
+              </a:ln>
+              <a:solidFill>
+                <a:prstClr val="black"/>
+              </a:solidFill>
+              <a:effectLst/>
+              <a:uLnTx/>
+              <a:uFillTx/>
+              <a:latin typeface="Calibri" panose="020F0502020204030204"/>
+              <a:ea typeface="+mn-ea"/>
+              <a:cs typeface="+mn-cs"/>
+            </a:endParaRPr>
+          </a:p>
+        </p:txBody>
+      </p:sp>
+      <p:sp>
+        <p:nvSpPr>
+          <p:cNvPr id="4" name="BTN_Home">
+            <a:hlinkClick r:id="rId3" action="ppaction://hlinksldjump"/>
+            <a:extLst>
+              <a:ext uri="{FF2B5EF4-FFF2-40B4-BE49-F238E27FC236}">
+                <a16:creationId xmlns:a16="http://schemas.microsoft.com/office/drawing/2014/main" id="{E10032C3-E61E-AA12-B48D-3F98400DCA86}"/>
+              </a:ext>
+            </a:extLst>
+          </p:cNvPr>
+          <p:cNvSpPr/>
+          <p:nvPr/>
+        </p:nvSpPr>
+        <p:spPr>
+          <a:xfrm>
+            <a:off x="548640" y="5943600"/>
+            <a:ext cx="1645920" cy="548640"/>
+          </a:xfrm>
+          <a:prstGeom prst="roundRect">
+            <a:avLst>
+              <a:gd name="adj" fmla="val 25000"/>
+            </a:avLst>
+          </a:prstGeom>
+          <a:solidFill>
+            <a:srgbClr val="1B2A4A"/>
+          </a:solidFill>
+          <a:ln/>
+        </p:spPr>
+        <p:txBody>
+          <a:bodyPr wrap="square" rtlCol="0" anchor="ctr"/>
+          <a:lstStyle/>
+          <a:p>
+            <a:pPr marL="0" marR="0" lvl="0" indent="0" algn="ctr" defTabSz="914400" rtl="0" eaLnBrk="1" fontAlgn="auto" latinLnBrk="0" hangingPunct="1">
+              <a:lnSpc>
+                <a:spcPct val="100000"/>
+              </a:lnSpc>
+              <a:spcBef>
+                <a:spcPts val="0"/>
+              </a:spcBef>
+              <a:spcAft>
+                <a:spcPts val="0"/>
+              </a:spcAft>
+              <a:buClrTx/>
+              <a:buSzTx/>
+              <a:buFontTx/>
+              <a:buNone/>
+              <a:tabLst/>
+              <a:defRPr/>
+            </a:pPr>
+            <a:r>
+              <a:rPr kumimoji="0" lang="en-US" sz="1400" b="1" i="0" u="none" strike="noStrike" kern="1200" cap="none" spc="0" normalizeH="0" baseline="0" noProof="0" dirty="0">
+                <a:ln>
+                  <a:noFill/>
+                </a:ln>
+                <a:solidFill>
+                  <a:srgbClr val="FFFFFF"/>
+                </a:solidFill>
+                <a:effectLst/>
+                <a:uLnTx/>
+                <a:uFillTx/>
+                <a:latin typeface="Helvetica Neue" pitchFamily="34" charset="0"/>
+                <a:ea typeface="Helvetica Neue" pitchFamily="34" charset="-122"/>
+                <a:cs typeface="Helvetica Neue" pitchFamily="34" charset="-120"/>
+              </a:rPr>
+              <a:t>Home</a:t>
+            </a:r>
+            <a:endParaRPr kumimoji="0" lang="en-US" sz="1400" b="0" i="0" u="none" strike="noStrike" kern="1200" cap="none" spc="0" normalizeH="0" baseline="0" noProof="0" dirty="0">
+              <a:ln>
+                <a:noFill/>
+              </a:ln>
+              <a:solidFill>
+                <a:prstClr val="black"/>
+              </a:solidFill>
+              <a:effectLst/>
+              <a:uLnTx/>
+              <a:uFillTx/>
+              <a:latin typeface="Calibri" panose="020F0502020204030204"/>
+              <a:ea typeface="+mn-ea"/>
+              <a:cs typeface="+mn-cs"/>
+            </a:endParaRPr>
+          </a:p>
+        </p:txBody>
+      </p:sp>
+      <p:sp>
+        <p:nvSpPr>
+          <p:cNvPr id="5" name="BTN_Terms">
+            <a:hlinkClick r:id="" action="ppaction://hlinkshowjump?jump=lastslideviewed"/>
+            <a:extLst>
+              <a:ext uri="{FF2B5EF4-FFF2-40B4-BE49-F238E27FC236}">
+                <a16:creationId xmlns:a16="http://schemas.microsoft.com/office/drawing/2014/main" id="{C43321BA-5AC6-0BDC-61A3-09AD0E225F19}"/>
+              </a:ext>
+            </a:extLst>
+          </p:cNvPr>
+          <p:cNvSpPr/>
+          <p:nvPr/>
+        </p:nvSpPr>
+        <p:spPr>
+          <a:xfrm>
+            <a:off x="3466948" y="5943600"/>
+            <a:ext cx="1645920" cy="548640"/>
+          </a:xfrm>
+          <a:prstGeom prst="roundRect">
+            <a:avLst>
+              <a:gd name="adj" fmla="val 25000"/>
+            </a:avLst>
+          </a:prstGeom>
+          <a:solidFill>
+            <a:srgbClr val="1B2A4A"/>
+          </a:solidFill>
+          <a:ln>
+            <a:solidFill>
+              <a:schemeClr val="bg2"/>
+            </a:solidFill>
+          </a:ln>
+        </p:spPr>
+        <p:txBody>
+          <a:bodyPr wrap="square" rtlCol="0" anchor="ctr"/>
+          <a:lstStyle/>
+          <a:p>
+            <a:pPr marL="0" indent="0" algn="ctr">
+              <a:buNone/>
+            </a:pPr>
+            <a:r>
+              <a:rPr lang="en-US" sz="1400" b="1" dirty="0">
+                <a:solidFill>
+                  <a:srgbClr val="FFFFFF"/>
+                </a:solidFill>
+                <a:latin typeface="Helvetica Neue" pitchFamily="34" charset="0"/>
+                <a:ea typeface="Helvetica Neue" pitchFamily="34" charset="-122"/>
+                <a:cs typeface="Helvetica Neue" pitchFamily="34" charset="-120"/>
+              </a:rPr>
+              <a:t>&lt; Back</a:t>
+            </a:r>
+            <a:endParaRPr lang="en-US" sz="1400" dirty="0"/>
+          </a:p>
+        </p:txBody>
+      </p:sp>
+    </p:spTree>
+    <p:extLst>
+      <p:ext uri="{BB962C8B-B14F-4D97-AF65-F5344CB8AC3E}">
+        <p14:creationId xmlns:p14="http://schemas.microsoft.com/office/powerpoint/2010/main" val="2903637696"/>
+      </p:ext>
+    </p:extLst>
+  </p:cSld>
+  <p:clrMapOvr>
+    <a:masterClrMapping/>
+  </p:clrMapOvr>
+</p:sld>
+</file>
+
+<file path=ppt/slides/slide8.xml><?xml version="1.0" encoding="utf-8"?>
 <p:sld xmlns:a="http://schemas.openxmlformats.org/drawingml/2006/main" xmlns:r="http://schemas.openxmlformats.org/officeDocument/2006/relationships" xmlns:p="http://schemas.openxmlformats.org/presentationml/2006/main">
   <p:cSld name="Slide 6">
     <p:bg>
@@ -2403,6 +3786,7 @@
         <a:solidFill>
           <a:srgbClr val="FFFFFF"/>
         </a:solidFill>
+        <a:effectLst/>
       </p:bgPr>
     </p:bg>
     <p:spTree>
@@ -2440,7 +3824,7 @@
           <a:bodyPr wrap="square" rtlCol="0" anchor="ctr"/>
           <a:lstStyle/>
           <a:p>
-            <a:pPr indent="0" marL="0">
+            <a:pPr marL="0" indent="0">
               <a:buNone/>
             </a:pPr>
             <a:r>
@@ -2565,206 +3949,6 @@
                 <a:cs typeface="Helvetica Neue" pitchFamily="34" charset="-120"/>
               </a:rPr>
               <a:t>Use system or bundled fonts only; anything else is flagged at setup.</a:t>
-            </a:r>
-            <a:endParaRPr lang="en-US" sz="1400" dirty="0"/>
-          </a:p>
-        </p:txBody>
-      </p:sp>
-    </p:spTree>
-  </p:cSld>
-  <p:clrMapOvr>
-    <a:masterClrMapping/>
-  </p:clrMapOvr>
-</p:sld>
-</file>
-
-<file path=ppt/slides/slide7.xml><?xml version="1.0" encoding="utf-8"?>
-<p:sld xmlns:a="http://schemas.openxmlformats.org/drawingml/2006/main" xmlns:r="http://schemas.openxmlformats.org/officeDocument/2006/relationships" xmlns:p="http://schemas.openxmlformats.org/presentationml/2006/main">
-  <p:cSld name="Slide 7">
-    <p:bg>
-      <p:bgPr>
-        <a:solidFill>
-          <a:srgbClr val="F5F3EE"/>
-        </a:solidFill>
-      </p:bgPr>
-    </p:bg>
-    <p:spTree>
-      <p:nvGrpSpPr>
-        <p:cNvPr id="1" name=""/>
-        <p:cNvGrpSpPr/>
-        <p:nvPr/>
-      </p:nvGrpSpPr>
-      <p:grpSpPr>
-        <a:xfrm>
-          <a:off x="0" y="0"/>
-          <a:ext cx="0" cy="0"/>
-          <a:chOff x="0" y="0"/>
-          <a:chExt cx="0" cy="0"/>
-        </a:xfrm>
-      </p:grpSpPr>
-      <p:sp>
-        <p:nvSpPr>
-          <p:cNvPr id="2" name="Text 0"/>
-          <p:cNvSpPr/>
-          <p:nvPr/>
-        </p:nvSpPr>
-        <p:spPr>
-          <a:xfrm>
-            <a:off x="548640" y="457200"/>
-            <a:ext cx="11091672" cy="914400"/>
-          </a:xfrm>
-          <a:prstGeom prst="rect">
-            <a:avLst/>
-          </a:prstGeom>
-          <a:noFill/>
-          <a:ln/>
-        </p:spPr>
-        <p:txBody>
-          <a:bodyPr wrap="square" rtlCol="0" anchor="ctr"/>
-          <a:lstStyle/>
-          <a:p>
-            <a:pPr indent="0" marL="0">
-              <a:buNone/>
-            </a:pPr>
-            <a:r>
-              <a:rPr lang="en-US" sz="3000" b="1" dirty="0">
-                <a:solidFill>
-                  <a:srgbClr val="1B2A4A"/>
-                </a:solidFill>
-                <a:latin typeface="Helvetica Neue" pitchFamily="34" charset="0"/>
-                <a:ea typeface="Helvetica Neue" pitchFamily="34" charset="-122"/>
-                <a:cs typeface="Helvetica Neue" pitchFamily="34" charset="-120"/>
-              </a:rPr>
-              <a:t>Sustainability (continued)</a:t>
-            </a:r>
-            <a:endParaRPr lang="en-US" sz="3000" dirty="0"/>
-          </a:p>
-        </p:txBody>
-      </p:sp>
-      <p:sp>
-        <p:nvSpPr>
-          <p:cNvPr id="3" name="Text 1"/>
-          <p:cNvSpPr/>
-          <p:nvPr/>
-        </p:nvSpPr>
-        <p:spPr>
-          <a:xfrm>
-            <a:off x="548640" y="1554480"/>
-            <a:ext cx="8686800" cy="1828800"/>
-          </a:xfrm>
-          <a:prstGeom prst="rect">
-            <a:avLst/>
-          </a:prstGeom>
-          <a:noFill/>
-          <a:ln/>
-        </p:spPr>
-        <p:txBody>
-          <a:bodyPr wrap="square" rtlCol="0" anchor="t"/>
-          <a:lstStyle/>
-          <a:p>
-            <a:pPr indent="0" marL="0">
-              <a:buNone/>
-            </a:pPr>
-            <a:r>
-              <a:rPr lang="en-US" sz="1600" dirty="0">
-                <a:solidFill>
-                  <a:srgbClr val="333333"/>
-                </a:solidFill>
-                <a:latin typeface="Helvetica Neue" pitchFamily="34" charset="0"/>
-                <a:ea typeface="Helvetica Neue" pitchFamily="34" charset="-122"/>
-                <a:cs typeface="Helvetica Neue" pitchFamily="34" charset="-120"/>
-              </a:rPr>
-              <a:t>A second slide chained from the Sustainability destination via its "Next" button, showing multi-level navigation beyond the Home &lt;-&gt; Destination pair.</a:t>
-            </a:r>
-            <a:endParaRPr lang="en-US" sz="1600" dirty="0"/>
-          </a:p>
-        </p:txBody>
-      </p:sp>
-      <p:sp>
-        <p:nvSpPr>
-          <p:cNvPr id="4" name="BTN_Back">
-            <a:hlinkClick r:id="rId1" tooltip="" action="ppaction://hlinksldjump"/>
-          </p:cNvPr>
-          <p:cNvSpPr/>
-          <p:nvPr/>
-        </p:nvSpPr>
-        <p:spPr>
-          <a:xfrm>
-            <a:off x="548640" y="5943600"/>
-            <a:ext cx="1645920" cy="548640"/>
-          </a:xfrm>
-          <a:prstGeom prst="roundRect">
-            <a:avLst>
-              <a:gd name="adj" fmla="val 25000"/>
-            </a:avLst>
-          </a:prstGeom>
-          <a:solidFill>
-            <a:srgbClr val="2E7D6B"/>
-          </a:solidFill>
-          <a:ln/>
-        </p:spPr>
-        <p:txBody>
-          <a:bodyPr wrap="square" rtlCol="0" anchor="ctr"/>
-          <a:lstStyle/>
-          <a:p>
-            <a:pPr algn="ctr" indent="0" marL="0">
-              <a:buNone/>
-            </a:pPr>
-            <a:r>
-              <a:rPr lang="en-US" sz="1400" b="1" dirty="0">
-                <a:solidFill>
-                  <a:srgbClr val="FFFFFF"/>
-                </a:solidFill>
-                <a:latin typeface="Helvetica Neue" pitchFamily="34" charset="0"/>
-                <a:ea typeface="Helvetica Neue" pitchFamily="34" charset="-122"/>
-                <a:cs typeface="Helvetica Neue" pitchFamily="34" charset="-120"/>
-              </a:rPr>
-              <a:t>Back</a:t>
-            </a:r>
-            <a:endParaRPr lang="en-US" sz="1400" dirty="0"/>
-          </a:p>
-        </p:txBody>
-      </p:sp>
-      <p:sp>
-        <p:nvSpPr>
-          <p:cNvPr id="5" name="BTN_Home">
-            <a:hlinkClick r:id="rId2" tooltip="" action="ppaction://hlinksldjump"/>
-          </p:cNvPr>
-          <p:cNvSpPr/>
-          <p:nvPr/>
-        </p:nvSpPr>
-        <p:spPr>
-          <a:xfrm>
-            <a:off x="2377440" y="5943600"/>
-            <a:ext cx="1645920" cy="548640"/>
-          </a:xfrm>
-          <a:prstGeom prst="roundRect">
-            <a:avLst>
-              <a:gd name="adj" fmla="val 25000"/>
-            </a:avLst>
-          </a:prstGeom>
-          <a:solidFill>
-            <a:srgbClr val="1B2A4A"/>
-          </a:solidFill>
-          <a:ln/>
-        </p:spPr>
-        <p:txBody>
-          <a:bodyPr wrap="square" rtlCol="0" anchor="ctr"/>
-          <a:lstStyle/>
-          <a:p>
-            <a:pPr algn="ctr" indent="0" marL="0">
-              <a:buNone/>
-            </a:pPr>
-            <a:r>
-              <a:rPr lang="en-US" sz="1400" b="1" dirty="0">
-                <a:solidFill>
-                  <a:srgbClr val="FFFFFF"/>
-                </a:solidFill>
-                <a:latin typeface="Helvetica Neue" pitchFamily="34" charset="0"/>
-                <a:ea typeface="Helvetica Neue" pitchFamily="34" charset="-122"/>
-                <a:cs typeface="Helvetica Neue" pitchFamily="34" charset="-120"/>
-              </a:rPr>
-              <a:t>Home</a:t>
             </a:r>
             <a:endParaRPr lang="en-US" sz="1400" dirty="0"/>
           </a:p>
@@ -3071,4 +4255,319 @@
     </a:ext>
   </a:extLst>
 </a:theme>
+</file>
+
+<file path=ppt/theme/theme2.xml><?xml version="1.0" encoding="utf-8"?>
+<a:theme xmlns:a="http://schemas.openxmlformats.org/drawingml/2006/main" name="Office Theme">
+  <a:themeElements>
+    <a:clrScheme name="Office">
+      <a:dk1>
+        <a:sysClr val="windowText" lastClr="000000"/>
+      </a:dk1>
+      <a:lt1>
+        <a:sysClr val="window" lastClr="FFFFFF"/>
+      </a:lt1>
+      <a:dk2>
+        <a:srgbClr val="0E2841"/>
+      </a:dk2>
+      <a:lt2>
+        <a:srgbClr val="E8E8E8"/>
+      </a:lt2>
+      <a:accent1>
+        <a:srgbClr val="156082"/>
+      </a:accent1>
+      <a:accent2>
+        <a:srgbClr val="E97132"/>
+      </a:accent2>
+      <a:accent3>
+        <a:srgbClr val="196B24"/>
+      </a:accent3>
+      <a:accent4>
+        <a:srgbClr val="0F9ED5"/>
+      </a:accent4>
+      <a:accent5>
+        <a:srgbClr val="A02B93"/>
+      </a:accent5>
+      <a:accent6>
+        <a:srgbClr val="4EA72E"/>
+      </a:accent6>
+      <a:hlink>
+        <a:srgbClr val="467886"/>
+      </a:hlink>
+      <a:folHlink>
+        <a:srgbClr val="96607D"/>
+      </a:folHlink>
+    </a:clrScheme>
+    <a:fontScheme name="Office">
+      <a:majorFont>
+        <a:latin typeface="Aptos Display" panose="02110004020202020204"/>
+        <a:ea typeface=""/>
+        <a:cs typeface=""/>
+        <a:font script="Jpan" typeface="游ゴシック Light"/>
+        <a:font script="Hang" typeface="맑은 고딕"/>
+        <a:font script="Hans" typeface="等线 Light"/>
+        <a:font script="Hant" typeface="新細明體"/>
+        <a:font script="Arab" typeface="Times New Roman"/>
+        <a:font script="Hebr" typeface="Times New Roman"/>
+        <a:font script="Thai" typeface="Angsana New"/>
+        <a:font script="Ethi" typeface="Nyala"/>
+        <a:font script="Beng" typeface="Vrinda"/>
+        <a:font script="Gujr" typeface="Shruti"/>
+        <a:font script="Khmr" typeface="MoolBoran"/>
+        <a:font script="Knda" typeface="Tunga"/>
+        <a:font script="Guru" typeface="Raavi"/>
+        <a:font script="Cans" typeface="Euphemia"/>
+        <a:font script="Cher" typeface="Plantagenet Cherokee"/>
+        <a:font script="Yiii" typeface="Microsoft Yi Baiti"/>
+        <a:font script="Tibt" typeface="Microsoft Himalaya"/>
+        <a:font script="Thaa" typeface="MV Boli"/>
+        <a:font script="Deva" typeface="Mangal"/>
+        <a:font script="Telu" typeface="Gautami"/>
+        <a:font script="Taml" typeface="Latha"/>
+        <a:font script="Syrc" typeface="Estrangelo Edessa"/>
+        <a:font script="Orya" typeface="Kalinga"/>
+        <a:font script="Mlym" typeface="Kartika"/>
+        <a:font script="Laoo" typeface="DokChampa"/>
+        <a:font script="Sinh" typeface="Iskoola Pota"/>
+        <a:font script="Mong" typeface="Mongolian Baiti"/>
+        <a:font script="Viet" typeface="Times New Roman"/>
+        <a:font script="Uigh" typeface="Microsoft Uighur"/>
+        <a:font script="Geor" typeface="Sylfaen"/>
+        <a:font script="Armn" typeface="Arial"/>
+        <a:font script="Bugi" typeface="Leelawadee UI"/>
+        <a:font script="Bopo" typeface="Microsoft JhengHei"/>
+        <a:font script="Java" typeface="Javanese Text"/>
+        <a:font script="Lisu" typeface="Segoe UI"/>
+        <a:font script="Mymr" typeface="Myanmar Text"/>
+        <a:font script="Nkoo" typeface="Ebrima"/>
+        <a:font script="Olck" typeface="Nirmala UI"/>
+        <a:font script="Osma" typeface="Ebrima"/>
+        <a:font script="Phag" typeface="Phagspa"/>
+        <a:font script="Syrn" typeface="Estrangelo Edessa"/>
+        <a:font script="Syrj" typeface="Estrangelo Edessa"/>
+        <a:font script="Syre" typeface="Estrangelo Edessa"/>
+        <a:font script="Sora" typeface="Nirmala UI"/>
+        <a:font script="Tale" typeface="Microsoft Tai Le"/>
+        <a:font script="Talu" typeface="Microsoft New Tai Lue"/>
+        <a:font script="Tfng" typeface="Ebrima"/>
+      </a:majorFont>
+      <a:minorFont>
+        <a:latin typeface="Aptos" panose="02110004020202020204"/>
+        <a:ea typeface=""/>
+        <a:cs typeface=""/>
+        <a:font script="Jpan" typeface="游ゴシック"/>
+        <a:font script="Hang" typeface="맑은 고딕"/>
+        <a:font script="Hans" typeface="等线"/>
+        <a:font script="Hant" typeface="新細明體"/>
+        <a:font script="Arab" typeface="Arial"/>
+        <a:font script="Hebr" typeface="Arial"/>
+        <a:font script="Thai" typeface="Cordia New"/>
+        <a:font script="Ethi" typeface="Nyala"/>
+        <a:font script="Beng" typeface="Vrinda"/>
+        <a:font script="Gujr" typeface="Shruti"/>
+        <a:font script="Khmr" typeface="DaunPenh"/>
+        <a:font script="Knda" typeface="Tunga"/>
+        <a:font script="Guru" typeface="Raavi"/>
+        <a:font script="Cans" typeface="Euphemia"/>
+        <a:font script="Cher" typeface="Plantagenet Cherokee"/>
+        <a:font script="Yiii" typeface="Microsoft Yi Baiti"/>
+        <a:font script="Tibt" typeface="Microsoft Himalaya"/>
+        <a:font script="Thaa" typeface="MV Boli"/>
+        <a:font script="Deva" typeface="Mangal"/>
+        <a:font script="Telu" typeface="Gautami"/>
+        <a:font script="Taml" typeface="Latha"/>
+        <a:font script="Syrc" typeface="Estrangelo Edessa"/>
+        <a:font script="Orya" typeface="Kalinga"/>
+        <a:font script="Mlym" typeface="Kartika"/>
+        <a:font script="Laoo" typeface="DokChampa"/>
+        <a:font script="Sinh" typeface="Iskoola Pota"/>
+        <a:font script="Mong" typeface="Mongolian Baiti"/>
+        <a:font script="Viet" typeface="Arial"/>
+        <a:font script="Uigh" typeface="Microsoft Uighur"/>
+        <a:font script="Geor" typeface="Sylfaen"/>
+        <a:font script="Armn" typeface="Arial"/>
+        <a:font script="Bugi" typeface="Leelawadee UI"/>
+        <a:font script="Bopo" typeface="Microsoft JhengHei"/>
+        <a:font script="Java" typeface="Javanese Text"/>
+        <a:font script="Lisu" typeface="Segoe UI"/>
+        <a:font script="Mymr" typeface="Myanmar Text"/>
+        <a:font script="Nkoo" typeface="Ebrima"/>
+        <a:font script="Olck" typeface="Nirmala UI"/>
+        <a:font script="Osma" typeface="Ebrima"/>
+        <a:font script="Phag" typeface="Phagspa"/>
+        <a:font script="Syrn" typeface="Estrangelo Edessa"/>
+        <a:font script="Syrj" typeface="Estrangelo Edessa"/>
+        <a:font script="Syre" typeface="Estrangelo Edessa"/>
+        <a:font script="Sora" typeface="Nirmala UI"/>
+        <a:font script="Tale" typeface="Microsoft Tai Le"/>
+        <a:font script="Talu" typeface="Microsoft New Tai Lue"/>
+        <a:font script="Tfng" typeface="Ebrima"/>
+      </a:minorFont>
+    </a:fontScheme>
+    <a:fmtScheme name="Office">
+      <a:fillStyleLst>
+        <a:solidFill>
+          <a:schemeClr val="phClr"/>
+        </a:solidFill>
+        <a:gradFill rotWithShape="1">
+          <a:gsLst>
+            <a:gs pos="0">
+              <a:schemeClr val="phClr">
+                <a:lumMod val="110000"/>
+                <a:satMod val="105000"/>
+                <a:tint val="67000"/>
+              </a:schemeClr>
+            </a:gs>
+            <a:gs pos="50000">
+              <a:schemeClr val="phClr">
+                <a:lumMod val="105000"/>
+                <a:satMod val="103000"/>
+                <a:tint val="73000"/>
+              </a:schemeClr>
+            </a:gs>
+            <a:gs pos="100000">
+              <a:schemeClr val="phClr">
+                <a:lumMod val="105000"/>
+                <a:satMod val="109000"/>
+                <a:tint val="81000"/>
+              </a:schemeClr>
+            </a:gs>
+          </a:gsLst>
+          <a:lin ang="5400000" scaled="0"/>
+        </a:gradFill>
+        <a:gradFill rotWithShape="1">
+          <a:gsLst>
+            <a:gs pos="0">
+              <a:schemeClr val="phClr">
+                <a:satMod val="103000"/>
+                <a:lumMod val="102000"/>
+                <a:tint val="94000"/>
+              </a:schemeClr>
+            </a:gs>
+            <a:gs pos="50000">
+              <a:schemeClr val="phClr">
+                <a:satMod val="110000"/>
+                <a:lumMod val="100000"/>
+                <a:shade val="100000"/>
+              </a:schemeClr>
+            </a:gs>
+            <a:gs pos="100000">
+              <a:schemeClr val="phClr">
+                <a:lumMod val="99000"/>
+                <a:satMod val="120000"/>
+                <a:shade val="78000"/>
+              </a:schemeClr>
+            </a:gs>
+          </a:gsLst>
+          <a:lin ang="5400000" scaled="0"/>
+        </a:gradFill>
+      </a:fillStyleLst>
+      <a:lnStyleLst>
+        <a:ln w="12700" cap="flat" cmpd="sng" algn="ctr">
+          <a:solidFill>
+            <a:schemeClr val="phClr"/>
+          </a:solidFill>
+          <a:prstDash val="solid"/>
+          <a:miter lim="800000"/>
+        </a:ln>
+        <a:ln w="19050" cap="flat" cmpd="sng" algn="ctr">
+          <a:solidFill>
+            <a:schemeClr val="phClr"/>
+          </a:solidFill>
+          <a:prstDash val="solid"/>
+          <a:miter lim="800000"/>
+        </a:ln>
+        <a:ln w="25400" cap="flat" cmpd="sng" algn="ctr">
+          <a:solidFill>
+            <a:schemeClr val="phClr"/>
+          </a:solidFill>
+          <a:prstDash val="solid"/>
+          <a:miter lim="800000"/>
+        </a:ln>
+      </a:lnStyleLst>
+      <a:effectStyleLst>
+        <a:effectStyle>
+          <a:effectLst/>
+        </a:effectStyle>
+        <a:effectStyle>
+          <a:effectLst/>
+        </a:effectStyle>
+        <a:effectStyle>
+          <a:effectLst>
+            <a:outerShdw blurRad="57150" dist="19050" dir="5400000" algn="ctr" rotWithShape="0">
+              <a:srgbClr val="000000">
+                <a:alpha val="63000"/>
+              </a:srgbClr>
+            </a:outerShdw>
+          </a:effectLst>
+        </a:effectStyle>
+      </a:effectStyleLst>
+      <a:bgFillStyleLst>
+        <a:solidFill>
+          <a:schemeClr val="phClr"/>
+        </a:solidFill>
+        <a:solidFill>
+          <a:schemeClr val="phClr">
+            <a:tint val="95000"/>
+            <a:satMod val="170000"/>
+          </a:schemeClr>
+        </a:solidFill>
+        <a:gradFill rotWithShape="1">
+          <a:gsLst>
+            <a:gs pos="0">
+              <a:schemeClr val="phClr">
+                <a:tint val="93000"/>
+                <a:satMod val="150000"/>
+                <a:shade val="98000"/>
+                <a:lumMod val="102000"/>
+              </a:schemeClr>
+            </a:gs>
+            <a:gs pos="50000">
+              <a:schemeClr val="phClr">
+                <a:tint val="98000"/>
+                <a:satMod val="130000"/>
+                <a:shade val="90000"/>
+                <a:lumMod val="103000"/>
+              </a:schemeClr>
+            </a:gs>
+            <a:gs pos="100000">
+              <a:schemeClr val="phClr">
+                <a:shade val="63000"/>
+                <a:satMod val="120000"/>
+              </a:schemeClr>
+            </a:gs>
+          </a:gsLst>
+          <a:lin ang="5400000" scaled="0"/>
+        </a:gradFill>
+      </a:bgFillStyleLst>
+    </a:fmtScheme>
+  </a:themeElements>
+  <a:objectDefaults>
+    <a:lnDef>
+      <a:spPr/>
+      <a:bodyPr/>
+      <a:lstStyle/>
+      <a:style>
+        <a:lnRef idx="2">
+          <a:schemeClr val="accent1"/>
+        </a:lnRef>
+        <a:fillRef idx="0">
+          <a:schemeClr val="accent1"/>
+        </a:fillRef>
+        <a:effectRef idx="1">
+          <a:schemeClr val="accent1"/>
+        </a:effectRef>
+        <a:fontRef idx="minor">
+          <a:schemeClr val="tx1"/>
+        </a:fontRef>
+      </a:style>
+    </a:lnDef>
+  </a:objectDefaults>
+  <a:extraClrSchemeLst/>
+  <a:extLst>
+    <a:ext uri="{05A4C25C-085E-4340-85A3-A5531E510DB2}">
+      <thm15:themeFamily xmlns:thm15="http://schemas.microsoft.com/office/thememl/2012/main" name="Office Theme" id="{2E142A2C-CD16-42D6-873A-C26D2A0506FA}" vid="{1BDDFF52-6CD6-40A5-AB3C-68EB2F1E4D0A}"/>
+    </a:ext>
+  </a:extLst>
+</a:theme>
 </file>
</xml_diff>

<commit_message>
Rebrand template deck to Emota and rename heading to GGPad
The downloadable template (public/template.pptx, hand-edited) now uses
the Emota brand: Montserrat throughout, a blackberry home slide with the
white Emota logo, light-lavender destination slides with the blackberry
logo and a topic-coloured accent bar, and home buttons in teal, violet,
grape and mint. The theme colours and fonts are set to the Emota palette
and Montserrat. The heading reads "GGPad Kiosk Template" and every other
stuPad mention in the deck now says GGPad. Links, shape names and slide
order are unchanged; the Calibri missing-font warning is gone.

Docs now note that the shipped template is hand-maintained and that
npm run template overwrites it. Bump to 1.2.2.

Co-Authored-By: Claude Opus 5.5 <noreply@anthropic.com>
Claude-Session: https://claude.ai/code/session_01GZopXMdx3KfMTAetYfrLev
</commit_message>
<xml_diff>
--- a/public/template.pptx
+++ b/public/template.pptx
@@ -1402,7 +1402,7 @@
     <p:bg>
       <p:bgPr>
         <a:solidFill>
-          <a:srgbClr val="1B2A4A"/>
+          <a:srgbClr val="2A034C"/>
         </a:solidFill>
         <a:effectLst/>
       </p:bgPr>
@@ -1430,7 +1430,7 @@
         <p:spPr>
           <a:xfrm>
             <a:off x="548640" y="457200"/>
-            <a:ext cx="11091672" cy="914400"/>
+            <a:ext cx="8686800" cy="914400"/>
           </a:xfrm>
           <a:prstGeom prst="rect">
             <a:avLst/>
@@ -1448,13 +1448,13 @@
             <a:r>
               <a:rPr lang="en-US" sz="3200" b="1" dirty="0">
                 <a:solidFill>
-                  <a:srgbClr val="FFFFFF"/>
-                </a:solidFill>
-                <a:latin typeface="Helvetica Neue" pitchFamily="34" charset="0"/>
-                <a:ea typeface="Helvetica Neue" pitchFamily="34" charset="-122"/>
-                <a:cs typeface="Helvetica Neue" pitchFamily="34" charset="-120"/>
-              </a:rPr>
-              <a:t>stuPad Kiosk Template</a:t>
+                  <a:srgbClr val="FBFAFF"/>
+                </a:solidFill>
+                <a:latin typeface="Montserrat" pitchFamily="34" charset="0"/>
+                <a:ea typeface="Montserrat" pitchFamily="34" charset="-122"/>
+                <a:cs typeface="Montserrat" pitchFamily="34" charset="-120"/>
+              </a:rPr>
+              <a:t>GGPad Kiosk Template</a:t>
             </a:r>
             <a:endParaRPr lang="en-US" sz="3200" dirty="0"/>
           </a:p>
@@ -1469,7 +1469,7 @@
         <p:spPr>
           <a:xfrm>
             <a:off x="548640" y="1234440"/>
-            <a:ext cx="11091672" cy="457200"/>
+            <a:ext cx="8686800" cy="457200"/>
           </a:xfrm>
           <a:prstGeom prst="rect">
             <a:avLst/>
@@ -1487,11 +1487,11 @@
             <a:r>
               <a:rPr lang="en-US" sz="1600" dirty="0">
                 <a:solidFill>
-                  <a:srgbClr val="C8CEDB"/>
-                </a:solidFill>
-                <a:latin typeface="Helvetica Neue" pitchFamily="34" charset="0"/>
-                <a:ea typeface="Helvetica Neue" pitchFamily="34" charset="-122"/>
-                <a:cs typeface="Helvetica Neue" pitchFamily="34" charset="-120"/>
+                  <a:srgbClr val="C5C5D6"/>
+                </a:solidFill>
+                <a:latin typeface="Montserrat" pitchFamily="34" charset="0"/>
+                <a:ea typeface="Montserrat" pitchFamily="34" charset="-122"/>
+                <a:cs typeface="Montserrat" pitchFamily="34" charset="-120"/>
               </a:rPr>
               <a:t>Tap a topic to explore</a:t>
             </a:r>
@@ -1518,11 +1518,11 @@
             </a:avLst>
           </a:prstGeom>
           <a:solidFill>
-            <a:srgbClr val="2E7D6B"/>
+            <a:srgbClr val="00CA9F"/>
           </a:solidFill>
           <a:ln w="12700">
             <a:solidFill>
-              <a:srgbClr val="FFFFFF"/>
+              <a:srgbClr val="E2E2F2"/>
             </a:solidFill>
           </a:ln>
         </p:spPr>
@@ -1536,32 +1536,32 @@
             <a:r>
               <a:rPr lang="en-US" sz="2000" b="1" dirty="0">
                 <a:solidFill>
-                  <a:srgbClr val="FFFFFF"/>
-                </a:solidFill>
-                <a:latin typeface="Helvetica Neue" pitchFamily="34" charset="0"/>
-                <a:ea typeface="Helvetica Neue" pitchFamily="34" charset="-122"/>
-                <a:cs typeface="Helvetica Neue" pitchFamily="34" charset="-120"/>
+                  <a:srgbClr val="042B29"/>
+                </a:solidFill>
+                <a:latin typeface="Montserrat" pitchFamily="34" charset="0"/>
+                <a:ea typeface="Montserrat" pitchFamily="34" charset="-122"/>
+                <a:cs typeface="Montserrat" pitchFamily="34" charset="-120"/>
               </a:rPr>
               <a:t>Template</a:t>
             </a:r>
             <a:br>
               <a:rPr lang="en-US" sz="2000" b="1" dirty="0">
                 <a:solidFill>
-                  <a:srgbClr val="FFFFFF"/>
-                </a:solidFill>
-                <a:latin typeface="Helvetica Neue" pitchFamily="34" charset="0"/>
-                <a:ea typeface="Helvetica Neue" pitchFamily="34" charset="-122"/>
-                <a:cs typeface="Helvetica Neue" pitchFamily="34" charset="-120"/>
+                  <a:srgbClr val="042B29"/>
+                </a:solidFill>
+                <a:latin typeface="Montserrat" pitchFamily="34" charset="0"/>
+                <a:ea typeface="Montserrat" pitchFamily="34" charset="-122"/>
+                <a:cs typeface="Montserrat" pitchFamily="34" charset="-120"/>
               </a:rPr>
             </a:br>
             <a:r>
               <a:rPr lang="en-US" sz="2000" b="1" dirty="0">
                 <a:solidFill>
-                  <a:srgbClr val="FFFFFF"/>
-                </a:solidFill>
-                <a:latin typeface="Helvetica Neue" pitchFamily="34" charset="0"/>
-                <a:ea typeface="Helvetica Neue" pitchFamily="34" charset="-122"/>
-                <a:cs typeface="Helvetica Neue" pitchFamily="34" charset="-120"/>
+                  <a:srgbClr val="042B29"/>
+                </a:solidFill>
+                <a:latin typeface="Montserrat" pitchFamily="34" charset="0"/>
+                <a:ea typeface="Montserrat" pitchFamily="34" charset="-122"/>
+                <a:cs typeface="Montserrat" pitchFamily="34" charset="-120"/>
               </a:rPr>
               <a:t>Guide</a:t>
             </a:r>
@@ -1588,11 +1588,11 @@
             </a:avLst>
           </a:prstGeom>
           <a:solidFill>
-            <a:srgbClr val="2E5D8A"/>
+            <a:srgbClr val="7949F0"/>
           </a:solidFill>
           <a:ln w="12700">
             <a:solidFill>
-              <a:srgbClr val="FFFFFF"/>
+              <a:srgbClr val="E2E2F2"/>
             </a:solidFill>
           </a:ln>
         </p:spPr>
@@ -1606,11 +1606,11 @@
             <a:r>
               <a:rPr lang="en-US" sz="2000" b="1" dirty="0">
                 <a:solidFill>
-                  <a:srgbClr val="FFFFFF"/>
-                </a:solidFill>
-                <a:latin typeface="Helvetica Neue" pitchFamily="34" charset="0"/>
-                <a:ea typeface="Helvetica Neue" pitchFamily="34" charset="-122"/>
-                <a:cs typeface="Helvetica Neue" pitchFamily="34" charset="-120"/>
+                  <a:srgbClr val="FBFAFF"/>
+                </a:solidFill>
+                <a:latin typeface="Montserrat" pitchFamily="34" charset="0"/>
+                <a:ea typeface="Montserrat" pitchFamily="34" charset="-122"/>
+                <a:cs typeface="Montserrat" pitchFamily="34" charset="-120"/>
               </a:rPr>
               <a:t>Innovation</a:t>
             </a:r>
@@ -1637,11 +1637,11 @@
             </a:avLst>
           </a:prstGeom>
           <a:solidFill>
-            <a:srgbClr val="8A5D2E"/>
+            <a:srgbClr val="451284"/>
           </a:solidFill>
           <a:ln w="12700">
             <a:solidFill>
-              <a:srgbClr val="FFFFFF"/>
+              <a:srgbClr val="E2E2F2"/>
             </a:solidFill>
           </a:ln>
         </p:spPr>
@@ -1655,11 +1655,11 @@
             <a:r>
               <a:rPr lang="en-US" sz="2000" b="1" dirty="0">
                 <a:solidFill>
-                  <a:srgbClr val="FFFFFF"/>
-                </a:solidFill>
-                <a:latin typeface="Helvetica Neue" pitchFamily="34" charset="0"/>
-                <a:ea typeface="Helvetica Neue" pitchFamily="34" charset="-122"/>
-                <a:cs typeface="Helvetica Neue" pitchFamily="34" charset="-120"/>
+                  <a:srgbClr val="FBFAFF"/>
+                </a:solidFill>
+                <a:latin typeface="Montserrat" pitchFamily="34" charset="0"/>
+                <a:ea typeface="Montserrat" pitchFamily="34" charset="-122"/>
+                <a:cs typeface="Montserrat" pitchFamily="34" charset="-120"/>
               </a:rPr>
               <a:t>People</a:t>
             </a:r>
@@ -1686,11 +1686,11 @@
             </a:avLst>
           </a:prstGeom>
           <a:solidFill>
-            <a:srgbClr val="7A2E5D"/>
+            <a:srgbClr val="7EF5BD"/>
           </a:solidFill>
           <a:ln w="12700">
             <a:solidFill>
-              <a:srgbClr val="FFFFFF"/>
+              <a:srgbClr val="E2E2F2"/>
             </a:solidFill>
           </a:ln>
         </p:spPr>
@@ -1704,11 +1704,11 @@
             <a:r>
               <a:rPr lang="en-US" sz="2000" b="1" dirty="0">
                 <a:solidFill>
-                  <a:srgbClr val="FFFFFF"/>
-                </a:solidFill>
-                <a:latin typeface="Helvetica Neue" pitchFamily="34" charset="0"/>
-                <a:ea typeface="Helvetica Neue" pitchFamily="34" charset="-122"/>
-                <a:cs typeface="Helvetica Neue" pitchFamily="34" charset="-120"/>
+                  <a:srgbClr val="042B29"/>
+                </a:solidFill>
+                <a:latin typeface="Montserrat" pitchFamily="34" charset="0"/>
+                <a:ea typeface="Montserrat" pitchFamily="34" charset="-122"/>
+                <a:cs typeface="Montserrat" pitchFamily="34" charset="-120"/>
               </a:rPr>
               <a:t>Contact</a:t>
             </a:r>
@@ -1743,13 +1743,13 @@
             <a:r>
               <a:rPr lang="en-US" sz="1000" dirty="0">
                 <a:solidFill>
-                  <a:srgbClr val="8892A6"/>
-                </a:solidFill>
-                <a:latin typeface="Helvetica Neue" pitchFamily="34" charset="0"/>
-                <a:ea typeface="Helvetica Neue" pitchFamily="34" charset="-122"/>
-                <a:cs typeface="Helvetica Neue" pitchFamily="34" charset="-120"/>
-              </a:rPr>
-              <a:t>stuPad · offline kiosk</a:t>
+                  <a:srgbClr val="C5C5D6"/>
+                </a:solidFill>
+                <a:latin typeface="Montserrat" pitchFamily="34" charset="0"/>
+                <a:ea typeface="Montserrat" pitchFamily="34" charset="-122"/>
+                <a:cs typeface="Montserrat" pitchFamily="34" charset="-120"/>
+              </a:rPr>
+              <a:t>GGPad · offline kiosk</a:t>
             </a:r>
             <a:endParaRPr lang="en-US" sz="1000" dirty="0"/>
           </a:p>
@@ -1779,7 +1779,7 @@
             </a:avLst>
           </a:prstGeom>
           <a:solidFill>
-            <a:srgbClr val="1B2A4A"/>
+            <a:srgbClr val="3A1164"/>
           </a:solidFill>
           <a:ln>
             <a:solidFill>
@@ -1797,11 +1797,11 @@
             <a:r>
               <a:rPr lang="en-US" sz="1400" b="1" dirty="0">
                 <a:solidFill>
-                  <a:srgbClr val="FFFFFF"/>
-                </a:solidFill>
-                <a:latin typeface="Helvetica Neue" pitchFamily="34" charset="0"/>
-                <a:ea typeface="Helvetica Neue" pitchFamily="34" charset="-122"/>
-                <a:cs typeface="Helvetica Neue" pitchFamily="34" charset="-120"/>
+                  <a:srgbClr val="FBFAFF"/>
+                </a:solidFill>
+                <a:latin typeface="Montserrat" pitchFamily="34" charset="0"/>
+                <a:ea typeface="Montserrat" pitchFamily="34" charset="-122"/>
+                <a:cs typeface="Montserrat" pitchFamily="34" charset="-120"/>
               </a:rPr>
               <a:t>T&amp;Cs</a:t>
             </a:r>
@@ -1809,6 +1809,30 @@
           </a:p>
         </p:txBody>
       </p:sp>
+      <p:pic>
+        <p:nvPicPr>
+          <p:cNvPr id="10" name="Emota logo" descr="Emota, an Inizio Engage company"/>
+          <p:cNvPicPr>
+            <a:picLocks noChangeAspect="1"/>
+          </p:cNvPicPr>
+          <p:nvPr/>
+        </p:nvPicPr>
+        <p:blipFill>
+          <a:blip r:embed="rIdEmotaLogo"/>
+          <a:stretch>
+            <a:fillRect/>
+          </a:stretch>
+        </p:blipFill>
+        <p:spPr>
+          <a:xfrm>
+            <a:off x="9631375" y="566928"/>
+            <a:ext cx="2011680" cy="717499"/>
+          </a:xfrm>
+          <a:prstGeom prst="rect">
+            <a:avLst/>
+          </a:prstGeom>
+        </p:spPr>
+      </p:pic>
     </p:spTree>
   </p:cSld>
   <p:clrMapOvr>
@@ -1823,10 +1847,7 @@
     <p:bg>
       <p:bgPr>
         <a:solidFill>
-          <a:schemeClr val="accent6">
-            <a:lumMod val="60000"/>
-            <a:lumOff val="40000"/>
-          </a:schemeClr>
+          <a:srgbClr val="F6F4FB"/>
         </a:solidFill>
         <a:effectLst/>
       </p:bgPr>
@@ -1854,7 +1875,7 @@
         <p:spPr>
           <a:xfrm>
             <a:off x="548640" y="457200"/>
-            <a:ext cx="11091672" cy="914400"/>
+            <a:ext cx="9144000" cy="914400"/>
           </a:xfrm>
           <a:prstGeom prst="rect">
             <a:avLst/>
@@ -1872,11 +1893,11 @@
             <a:r>
               <a:rPr lang="en-US" sz="3000" b="1" dirty="0">
                 <a:solidFill>
-                  <a:srgbClr val="1B2A4A"/>
-                </a:solidFill>
-                <a:latin typeface="Helvetica Neue" pitchFamily="34" charset="0"/>
-                <a:ea typeface="Helvetica Neue" pitchFamily="34" charset="-122"/>
-                <a:cs typeface="Helvetica Neue" pitchFamily="34" charset="-120"/>
+                  <a:srgbClr val="2A034C"/>
+                </a:solidFill>
+                <a:latin typeface="Montserrat" pitchFamily="34" charset="0"/>
+                <a:ea typeface="Montserrat" pitchFamily="34" charset="-122"/>
+                <a:cs typeface="Montserrat" pitchFamily="34" charset="-120"/>
               </a:rPr>
               <a:t>Guide – Page 1</a:t>
             </a:r>
@@ -1911,22 +1932,22 @@
             <a:r>
               <a:rPr lang="en-US" sz="1600" dirty="0" err="1">
                 <a:solidFill>
-                  <a:srgbClr val="333333"/>
-                </a:solidFill>
-                <a:latin typeface="Helvetica Neue" pitchFamily="34" charset="0"/>
-                <a:ea typeface="Helvetica Neue" pitchFamily="34" charset="-122"/>
-                <a:cs typeface="Helvetica Neue" pitchFamily="34" charset="-120"/>
-              </a:rPr>
-              <a:t>stuPad</a:t>
+                  <a:srgbClr val="2A034C"/>
+                </a:solidFill>
+                <a:latin typeface="Montserrat" pitchFamily="34" charset="0"/>
+                <a:ea typeface="Montserrat" pitchFamily="34" charset="-122"/>
+                <a:cs typeface="Montserrat" pitchFamily="34" charset="-120"/>
+              </a:rPr>
+              <a:t>GGPad</a:t>
             </a:r>
             <a:r>
               <a:rPr lang="en-US" sz="1600" dirty="0">
                 <a:solidFill>
-                  <a:srgbClr val="333333"/>
-                </a:solidFill>
-                <a:latin typeface="Helvetica Neue" pitchFamily="34" charset="0"/>
-                <a:ea typeface="Helvetica Neue" pitchFamily="34" charset="-122"/>
-                <a:cs typeface="Helvetica Neue" pitchFamily="34" charset="-120"/>
+                  <a:srgbClr val="2A034C"/>
+                </a:solidFill>
+                <a:latin typeface="Montserrat" pitchFamily="34" charset="0"/>
+                <a:ea typeface="Montserrat" pitchFamily="34" charset="-122"/>
+                <a:cs typeface="Montserrat" pitchFamily="34" charset="-120"/>
               </a:rPr>
               <a:t> Kiosk uses PowerPoint links to create the navigation structure. Right click the object you want to be a button and edit or add a link and link to the slide you want to.</a:t>
             </a:r>
@@ -1937,11 +1958,11 @@
             </a:pPr>
             <a:endParaRPr lang="en-US" sz="1600" dirty="0">
               <a:solidFill>
-                <a:srgbClr val="333333"/>
+                <a:srgbClr val="2A034C"/>
               </a:solidFill>
-              <a:latin typeface="Helvetica Neue" pitchFamily="34" charset="0"/>
-              <a:ea typeface="Helvetica Neue" pitchFamily="34" charset="-122"/>
-              <a:cs typeface="Helvetica Neue" pitchFamily="34" charset="-120"/>
+              <a:latin typeface="Montserrat" pitchFamily="34" charset="0"/>
+              <a:ea typeface="Montserrat" pitchFamily="34" charset="-122"/>
+              <a:cs typeface="Montserrat" pitchFamily="34" charset="-120"/>
             </a:endParaRPr>
           </a:p>
           <a:p>
@@ -1974,7 +1995,7 @@
             </a:r>
             <a:r>
               <a:rPr lang="en-US" sz="1600" dirty="0" err="1"/>
-              <a:t>stuPad</a:t>
+              <a:t>GGPad</a:t>
             </a:r>
             <a:r>
               <a:rPr lang="en-US" sz="1600" dirty="0"/>
@@ -2025,7 +2046,7 @@
             </a:avLst>
           </a:prstGeom>
           <a:solidFill>
-            <a:srgbClr val="1B2A4A"/>
+            <a:srgbClr val="2A034C"/>
           </a:solidFill>
           <a:ln/>
         </p:spPr>
@@ -2039,11 +2060,11 @@
             <a:r>
               <a:rPr lang="en-US" sz="1400" b="1" dirty="0">
                 <a:solidFill>
-                  <a:srgbClr val="FFFFFF"/>
-                </a:solidFill>
-                <a:latin typeface="Helvetica Neue" pitchFamily="34" charset="0"/>
-                <a:ea typeface="Helvetica Neue" pitchFamily="34" charset="-122"/>
-                <a:cs typeface="Helvetica Neue" pitchFamily="34" charset="-120"/>
+                  <a:srgbClr val="FBFAFF"/>
+                </a:solidFill>
+                <a:latin typeface="Montserrat" pitchFamily="34" charset="0"/>
+                <a:ea typeface="Montserrat" pitchFamily="34" charset="-122"/>
+                <a:cs typeface="Montserrat" pitchFamily="34" charset="-120"/>
               </a:rPr>
               <a:t>Home</a:t>
             </a:r>
@@ -2075,7 +2096,7 @@
             </a:avLst>
           </a:prstGeom>
           <a:solidFill>
-            <a:srgbClr val="1B2A4A"/>
+            <a:srgbClr val="00CA9F"/>
           </a:solidFill>
           <a:ln/>
         </p:spPr>
@@ -2089,11 +2110,11 @@
             <a:r>
               <a:rPr lang="en-US" sz="1400" b="1" dirty="0">
                 <a:solidFill>
-                  <a:srgbClr val="FFFFFF"/>
-                </a:solidFill>
-                <a:latin typeface="Helvetica Neue" pitchFamily="34" charset="0"/>
-                <a:ea typeface="Helvetica Neue" pitchFamily="34" charset="-122"/>
-                <a:cs typeface="Helvetica Neue" pitchFamily="34" charset="-120"/>
+                  <a:srgbClr val="042B29"/>
+                </a:solidFill>
+                <a:latin typeface="Montserrat" pitchFamily="34" charset="0"/>
+                <a:ea typeface="Montserrat" pitchFamily="34" charset="-122"/>
+                <a:cs typeface="Montserrat" pitchFamily="34" charset="-120"/>
               </a:rPr>
               <a:t>Next</a:t>
             </a:r>
@@ -2125,7 +2146,7 @@
             </a:avLst>
           </a:prstGeom>
           <a:solidFill>
-            <a:srgbClr val="1B2A4A"/>
+            <a:srgbClr val="2A034C"/>
           </a:solidFill>
           <a:ln>
             <a:solidFill>
@@ -2143,11 +2164,11 @@
             <a:r>
               <a:rPr lang="en-US" sz="1400" b="1" dirty="0">
                 <a:solidFill>
-                  <a:srgbClr val="FFFFFF"/>
-                </a:solidFill>
-                <a:latin typeface="Helvetica Neue" pitchFamily="34" charset="0"/>
-                <a:ea typeface="Helvetica Neue" pitchFamily="34" charset="-122"/>
-                <a:cs typeface="Helvetica Neue" pitchFamily="34" charset="-120"/>
+                  <a:srgbClr val="FBFAFF"/>
+                </a:solidFill>
+                <a:latin typeface="Montserrat" pitchFamily="34" charset="0"/>
+                <a:ea typeface="Montserrat" pitchFamily="34" charset="-122"/>
+                <a:cs typeface="Montserrat" pitchFamily="34" charset="-120"/>
               </a:rPr>
               <a:t>T&amp;Cs</a:t>
             </a:r>
@@ -2155,6 +2176,59 @@
           </a:p>
         </p:txBody>
       </p:sp>
+      <p:sp>
+        <p:nvSpPr>
+          <p:cNvPr id="9" name="Accent bar"/>
+          <p:cNvSpPr/>
+          <p:nvPr/>
+        </p:nvSpPr>
+        <p:spPr>
+          <a:xfrm>
+            <a:off x="548640" y="1371600"/>
+            <a:ext cx="822960" cy="64008"/>
+          </a:xfrm>
+          <a:prstGeom prst="rect">
+            <a:avLst/>
+          </a:prstGeom>
+          <a:solidFill>
+            <a:srgbClr val="00CA9F"/>
+          </a:solidFill>
+          <a:ln>
+            <a:noFill/>
+          </a:ln>
+        </p:spPr>
+        <p:txBody>
+          <a:bodyPr/>
+          <a:lstStyle/>
+          <a:p>
+            <a:endParaRPr lang="en-US"/>
+          </a:p>
+        </p:txBody>
+      </p:sp>
+      <p:pic>
+        <p:nvPicPr>
+          <p:cNvPr id="10" name="Emota logo" descr="Emota, an Inizio Engage company"/>
+          <p:cNvPicPr>
+            <a:picLocks noChangeAspect="1"/>
+          </p:cNvPicPr>
+          <p:nvPr/>
+        </p:nvPicPr>
+        <p:blipFill>
+          <a:blip r:embed="rIdEmotaLogo"/>
+          <a:stretch>
+            <a:fillRect/>
+          </a:stretch>
+        </p:blipFill>
+        <p:spPr>
+          <a:xfrm>
+            <a:off x="10088575" y="548640"/>
+            <a:ext cx="1554480" cy="554431"/>
+          </a:xfrm>
+          <a:prstGeom prst="rect">
+            <a:avLst/>
+          </a:prstGeom>
+        </p:spPr>
+      </p:pic>
     </p:spTree>
   </p:cSld>
   <p:clrMapOvr>
@@ -2169,10 +2243,7 @@
     <p:bg>
       <p:bgPr>
         <a:solidFill>
-          <a:schemeClr val="accent6">
-            <a:lumMod val="60000"/>
-            <a:lumOff val="40000"/>
-          </a:schemeClr>
+          <a:srgbClr val="F6F4FB"/>
         </a:solidFill>
         <a:effectLst/>
       </p:bgPr>
@@ -2212,7 +2283,7 @@
         <p:spPr>
           <a:xfrm>
             <a:off x="548640" y="457200"/>
-            <a:ext cx="11091672" cy="914400"/>
+            <a:ext cx="9144000" cy="914400"/>
           </a:xfrm>
           <a:prstGeom prst="rect">
             <a:avLst/>
@@ -2247,14 +2318,14 @@
                   <a:noFill/>
                 </a:ln>
                 <a:solidFill>
-                  <a:srgbClr val="1B2A4A"/>
+                  <a:srgbClr val="2A034C"/>
                 </a:solidFill>
                 <a:effectLst/>
                 <a:uLnTx/>
                 <a:uFillTx/>
-                <a:latin typeface="Helvetica Neue" pitchFamily="34" charset="0"/>
-                <a:ea typeface="Helvetica Neue" pitchFamily="34" charset="-122"/>
-                <a:cs typeface="Helvetica Neue" pitchFamily="34" charset="-120"/>
+                <a:latin typeface="Montserrat" pitchFamily="34" charset="0"/>
+                <a:ea typeface="Montserrat" pitchFamily="34" charset="-122"/>
+                <a:cs typeface="Montserrat" pitchFamily="34" charset="-120"/>
               </a:rPr>
               <a:t>Guide - Page 2</a:t>
             </a:r>
@@ -2268,7 +2339,7 @@
               <a:effectLst/>
               <a:uLnTx/>
               <a:uFillTx/>
-              <a:latin typeface="Calibri" panose="020F0502020204030204"/>
+              <a:latin typeface="Montserrat" panose="020F0502020204030204"/>
               <a:ea typeface="+mn-ea"/>
               <a:cs typeface="+mn-cs"/>
             </a:endParaRPr>
@@ -2325,14 +2396,14 @@
                   <a:noFill/>
                 </a:ln>
                 <a:solidFill>
-                  <a:srgbClr val="333333"/>
+                  <a:srgbClr val="2A034C"/>
                 </a:solidFill>
                 <a:effectLst/>
                 <a:uLnTx/>
                 <a:uFillTx/>
-                <a:latin typeface="Helvetica Neue" pitchFamily="34" charset="0"/>
-                <a:ea typeface="Helvetica Neue" pitchFamily="34" charset="-122"/>
-                <a:cs typeface="Helvetica Neue" pitchFamily="34" charset="-120"/>
+                <a:latin typeface="Montserrat" pitchFamily="34" charset="0"/>
+                <a:ea typeface="Montserrat" pitchFamily="34" charset="-122"/>
+                <a:cs typeface="Montserrat" pitchFamily="34" charset="-120"/>
               </a:rPr>
               <a:t>There are some limitations to the slide render engine that the iPad software uses. Any text that has flowed beyond the bounds of the text box will be cut off and cropping images can be inconsistent.</a:t>
             </a:r>
@@ -2357,11 +2428,11 @@
             </a:pPr>
             <a:endParaRPr lang="en-US" sz="1600" dirty="0">
               <a:solidFill>
-                <a:srgbClr val="333333"/>
+                <a:srgbClr val="2A034C"/>
               </a:solidFill>
-              <a:latin typeface="Helvetica Neue" pitchFamily="34" charset="0"/>
-              <a:ea typeface="Helvetica Neue" pitchFamily="34" charset="-122"/>
-              <a:cs typeface="Helvetica Neue" pitchFamily="34" charset="-120"/>
+              <a:latin typeface="Montserrat" pitchFamily="34" charset="0"/>
+              <a:ea typeface="Montserrat" pitchFamily="34" charset="-122"/>
+              <a:cs typeface="Montserrat" pitchFamily="34" charset="-120"/>
             </a:endParaRPr>
           </a:p>
           <a:p>
@@ -2388,14 +2459,14 @@
                   <a:noFill/>
                 </a:ln>
                 <a:solidFill>
-                  <a:srgbClr val="333333"/>
+                  <a:srgbClr val="2A034C"/>
                 </a:solidFill>
                 <a:effectLst/>
                 <a:uLnTx/>
                 <a:uFillTx/>
-                <a:latin typeface="Helvetica Neue" pitchFamily="34" charset="0"/>
-                <a:ea typeface="Helvetica Neue" pitchFamily="34" charset="-122"/>
-                <a:cs typeface="Helvetica Neue" pitchFamily="34" charset="-120"/>
+                <a:latin typeface="Montserrat" pitchFamily="34" charset="0"/>
+                <a:ea typeface="Montserrat" pitchFamily="34" charset="-122"/>
+                <a:cs typeface="Montserrat" pitchFamily="34" charset="-120"/>
               </a:rPr>
               <a:t>You can configure the settings of the app when you import the slides. You should also configure guided access mode to restrict the iPad to only running the </a:t>
             </a:r>
@@ -2405,16 +2476,16 @@
                   <a:noFill/>
                 </a:ln>
                 <a:solidFill>
-                  <a:srgbClr val="333333"/>
+                  <a:srgbClr val="2A034C"/>
                 </a:solidFill>
                 <a:effectLst/>
                 <a:uLnTx/>
                 <a:uFillTx/>
-                <a:latin typeface="Helvetica Neue" pitchFamily="34" charset="0"/>
-                <a:ea typeface="Helvetica Neue" pitchFamily="34" charset="-122"/>
-                <a:cs typeface="Helvetica Neue" pitchFamily="34" charset="-120"/>
-              </a:rPr>
-              <a:t>stuPad</a:t>
+                <a:latin typeface="Montserrat" pitchFamily="34" charset="0"/>
+                <a:ea typeface="Montserrat" pitchFamily="34" charset="-122"/>
+                <a:cs typeface="Montserrat" pitchFamily="34" charset="-120"/>
+              </a:rPr>
+              <a:t>GGPad</a:t>
             </a:r>
             <a:r>
               <a:rPr kumimoji="0" lang="en-US" sz="1600" b="0" i="0" u="none" strike="noStrike" kern="1200" cap="none" spc="0" normalizeH="0" baseline="0" noProof="0" dirty="0">
@@ -2422,14 +2493,14 @@
                   <a:noFill/>
                 </a:ln>
                 <a:solidFill>
-                  <a:srgbClr val="333333"/>
+                  <a:srgbClr val="2A034C"/>
                 </a:solidFill>
                 <a:effectLst/>
                 <a:uLnTx/>
                 <a:uFillTx/>
-                <a:latin typeface="Helvetica Neue" pitchFamily="34" charset="0"/>
-                <a:ea typeface="Helvetica Neue" pitchFamily="34" charset="-122"/>
-                <a:cs typeface="Helvetica Neue" pitchFamily="34" charset="-120"/>
+                <a:latin typeface="Montserrat" pitchFamily="34" charset="0"/>
+                <a:ea typeface="Montserrat" pitchFamily="34" charset="-122"/>
+                <a:cs typeface="Montserrat" pitchFamily="34" charset="-120"/>
               </a:rPr>
               <a:t> webapp. </a:t>
             </a:r>
@@ -2454,11 +2525,11 @@
             </a:pPr>
             <a:endParaRPr lang="en-US" sz="1600" dirty="0">
               <a:solidFill>
-                <a:srgbClr val="333333"/>
+                <a:srgbClr val="2A034C"/>
               </a:solidFill>
-              <a:latin typeface="Helvetica Neue" pitchFamily="34" charset="0"/>
-              <a:ea typeface="Helvetica Neue" pitchFamily="34" charset="-122"/>
-              <a:cs typeface="Helvetica Neue" pitchFamily="34" charset="-120"/>
+              <a:latin typeface="Montserrat" pitchFamily="34" charset="0"/>
+              <a:ea typeface="Montserrat" pitchFamily="34" charset="-122"/>
+              <a:cs typeface="Montserrat" pitchFamily="34" charset="-120"/>
             </a:endParaRPr>
           </a:p>
           <a:p>
@@ -2485,14 +2556,14 @@
                   <a:noFill/>
                 </a:ln>
                 <a:solidFill>
-                  <a:srgbClr val="333333"/>
+                  <a:srgbClr val="2A034C"/>
                 </a:solidFill>
                 <a:effectLst/>
                 <a:uLnTx/>
                 <a:uFillTx/>
-                <a:latin typeface="Helvetica Neue" pitchFamily="34" charset="0"/>
-                <a:ea typeface="Helvetica Neue" pitchFamily="34" charset="-122"/>
-                <a:cs typeface="Helvetica Neue" pitchFamily="34" charset="-120"/>
+                <a:latin typeface="Montserrat" pitchFamily="34" charset="0"/>
+                <a:ea typeface="Montserrat" pitchFamily="34" charset="-122"/>
+                <a:cs typeface="Montserrat" pitchFamily="34" charset="-120"/>
               </a:rPr>
               <a:t>You should run </a:t>
             </a:r>
@@ -2502,16 +2573,16 @@
                   <a:noFill/>
                 </a:ln>
                 <a:solidFill>
-                  <a:srgbClr val="333333"/>
+                  <a:srgbClr val="2A034C"/>
                 </a:solidFill>
                 <a:effectLst/>
                 <a:uLnTx/>
                 <a:uFillTx/>
-                <a:latin typeface="Helvetica Neue" pitchFamily="34" charset="0"/>
-                <a:ea typeface="Helvetica Neue" pitchFamily="34" charset="-122"/>
-                <a:cs typeface="Helvetica Neue" pitchFamily="34" charset="-120"/>
-              </a:rPr>
-              <a:t>stuPad</a:t>
+                <a:latin typeface="Montserrat" pitchFamily="34" charset="0"/>
+                <a:ea typeface="Montserrat" pitchFamily="34" charset="-122"/>
+                <a:cs typeface="Montserrat" pitchFamily="34" charset="-120"/>
+              </a:rPr>
+              <a:t>GGPad</a:t>
             </a:r>
             <a:r>
               <a:rPr kumimoji="0" lang="en-US" sz="1600" b="0" i="0" u="none" strike="noStrike" kern="1200" cap="none" spc="0" normalizeH="0" baseline="0" noProof="0" dirty="0">
@@ -2519,14 +2590,14 @@
                   <a:noFill/>
                 </a:ln>
                 <a:solidFill>
-                  <a:srgbClr val="333333"/>
+                  <a:srgbClr val="2A034C"/>
                 </a:solidFill>
                 <a:effectLst/>
                 <a:uLnTx/>
                 <a:uFillTx/>
-                <a:latin typeface="Helvetica Neue" pitchFamily="34" charset="0"/>
-                <a:ea typeface="Helvetica Neue" pitchFamily="34" charset="-122"/>
-                <a:cs typeface="Helvetica Neue" pitchFamily="34" charset="-120"/>
+                <a:latin typeface="Montserrat" pitchFamily="34" charset="0"/>
+                <a:ea typeface="Montserrat" pitchFamily="34" charset="-122"/>
+                <a:cs typeface="Montserrat" pitchFamily="34" charset="-120"/>
               </a:rPr>
               <a:t> as a webapp that you have added to the iPad home screen as this reduces the chance of losing any interaction data.</a:t>
             </a:r>
@@ -2540,7 +2611,7 @@
               <a:effectLst/>
               <a:uLnTx/>
               <a:uFillTx/>
-              <a:latin typeface="Calibri" panose="020F0502020204030204"/>
+              <a:latin typeface="Montserrat" panose="020F0502020204030204"/>
               <a:ea typeface="+mn-ea"/>
               <a:cs typeface="+mn-cs"/>
             </a:endParaRPr>
@@ -2571,7 +2642,7 @@
             </a:avLst>
           </a:prstGeom>
           <a:solidFill>
-            <a:srgbClr val="1B2A4A"/>
+            <a:srgbClr val="2A034C"/>
           </a:solidFill>
           <a:ln/>
         </p:spPr>
@@ -2602,14 +2673,14 @@
                   <a:noFill/>
                 </a:ln>
                 <a:solidFill>
-                  <a:srgbClr val="FFFFFF"/>
+                  <a:srgbClr val="FBFAFF"/>
                 </a:solidFill>
                 <a:effectLst/>
                 <a:uLnTx/>
                 <a:uFillTx/>
-                <a:latin typeface="Helvetica Neue" pitchFamily="34" charset="0"/>
-                <a:ea typeface="Helvetica Neue" pitchFamily="34" charset="-122"/>
-                <a:cs typeface="Helvetica Neue" pitchFamily="34" charset="-120"/>
+                <a:latin typeface="Montserrat" pitchFamily="34" charset="0"/>
+                <a:ea typeface="Montserrat" pitchFamily="34" charset="-122"/>
+                <a:cs typeface="Montserrat" pitchFamily="34" charset="-120"/>
               </a:rPr>
               <a:t>Home</a:t>
             </a:r>
@@ -2623,7 +2694,7 @@
               <a:effectLst/>
               <a:uLnTx/>
               <a:uFillTx/>
-              <a:latin typeface="Calibri" panose="020F0502020204030204"/>
+              <a:latin typeface="Montserrat" panose="020F0502020204030204"/>
               <a:ea typeface="+mn-ea"/>
               <a:cs typeface="+mn-cs"/>
             </a:endParaRPr>
@@ -2654,7 +2725,7 @@
             </a:avLst>
           </a:prstGeom>
           <a:solidFill>
-            <a:srgbClr val="1B2A4A"/>
+            <a:srgbClr val="2A034C"/>
           </a:solidFill>
           <a:ln>
             <a:solidFill>
@@ -2672,11 +2743,11 @@
             <a:r>
               <a:rPr lang="en-US" sz="1400" b="1" dirty="0">
                 <a:solidFill>
-                  <a:srgbClr val="FFFFFF"/>
-                </a:solidFill>
-                <a:latin typeface="Helvetica Neue" pitchFamily="34" charset="0"/>
-                <a:ea typeface="Helvetica Neue" pitchFamily="34" charset="-122"/>
-                <a:cs typeface="Helvetica Neue" pitchFamily="34" charset="-120"/>
+                  <a:srgbClr val="FBFAFF"/>
+                </a:solidFill>
+                <a:latin typeface="Montserrat" pitchFamily="34" charset="0"/>
+                <a:ea typeface="Montserrat" pitchFamily="34" charset="-122"/>
+                <a:cs typeface="Montserrat" pitchFamily="34" charset="-120"/>
               </a:rPr>
               <a:t>T&amp;Cs</a:t>
             </a:r>
@@ -2684,6 +2755,59 @@
           </a:p>
         </p:txBody>
       </p:sp>
+      <p:sp>
+        <p:nvSpPr>
+          <p:cNvPr id="7" name="Accent bar"/>
+          <p:cNvSpPr/>
+          <p:nvPr/>
+        </p:nvSpPr>
+        <p:spPr>
+          <a:xfrm>
+            <a:off x="548640" y="1371600"/>
+            <a:ext cx="822960" cy="64008"/>
+          </a:xfrm>
+          <a:prstGeom prst="rect">
+            <a:avLst/>
+          </a:prstGeom>
+          <a:solidFill>
+            <a:srgbClr val="00CA9F"/>
+          </a:solidFill>
+          <a:ln>
+            <a:noFill/>
+          </a:ln>
+        </p:spPr>
+        <p:txBody>
+          <a:bodyPr/>
+          <a:lstStyle/>
+          <a:p>
+            <a:endParaRPr lang="en-US"/>
+          </a:p>
+        </p:txBody>
+      </p:sp>
+      <p:pic>
+        <p:nvPicPr>
+          <p:cNvPr id="8" name="Emota logo" descr="Emota, an Inizio Engage company"/>
+          <p:cNvPicPr>
+            <a:picLocks noChangeAspect="1"/>
+          </p:cNvPicPr>
+          <p:nvPr/>
+        </p:nvPicPr>
+        <p:blipFill>
+          <a:blip r:embed="rIdEmotaLogo"/>
+          <a:stretch>
+            <a:fillRect/>
+          </a:stretch>
+        </p:blipFill>
+        <p:spPr>
+          <a:xfrm>
+            <a:off x="10088575" y="548640"/>
+            <a:ext cx="1554480" cy="554431"/>
+          </a:xfrm>
+          <a:prstGeom prst="rect">
+            <a:avLst/>
+          </a:prstGeom>
+        </p:spPr>
+      </p:pic>
     </p:spTree>
     <p:extLst>
       <p:ext uri="{BB962C8B-B14F-4D97-AF65-F5344CB8AC3E}">
@@ -2703,10 +2827,7 @@
     <p:bg>
       <p:bgPr>
         <a:solidFill>
-          <a:schemeClr val="accent1">
-            <a:lumMod val="60000"/>
-            <a:lumOff val="40000"/>
-          </a:schemeClr>
+          <a:srgbClr val="F6F4FB"/>
         </a:solidFill>
         <a:effectLst/>
       </p:bgPr>
@@ -2734,7 +2855,7 @@
         <p:spPr>
           <a:xfrm>
             <a:off x="548640" y="457200"/>
-            <a:ext cx="11091672" cy="914400"/>
+            <a:ext cx="9144000" cy="914400"/>
           </a:xfrm>
           <a:prstGeom prst="rect">
             <a:avLst/>
@@ -2752,11 +2873,11 @@
             <a:r>
               <a:rPr lang="en-US" sz="3000" b="1" dirty="0">
                 <a:solidFill>
-                  <a:srgbClr val="1B2A4A"/>
-                </a:solidFill>
-                <a:latin typeface="Helvetica Neue" pitchFamily="34" charset="0"/>
-                <a:ea typeface="Helvetica Neue" pitchFamily="34" charset="-122"/>
-                <a:cs typeface="Helvetica Neue" pitchFamily="34" charset="-120"/>
+                  <a:srgbClr val="2A034C"/>
+                </a:solidFill>
+                <a:latin typeface="Montserrat" pitchFamily="34" charset="0"/>
+                <a:ea typeface="Montserrat" pitchFamily="34" charset="-122"/>
+                <a:cs typeface="Montserrat" pitchFamily="34" charset="-120"/>
               </a:rPr>
               <a:t>Innovation</a:t>
             </a:r>
@@ -2791,11 +2912,11 @@
             <a:r>
               <a:rPr lang="en-US" sz="1600" dirty="0">
                 <a:solidFill>
-                  <a:srgbClr val="333333"/>
-                </a:solidFill>
-                <a:latin typeface="Helvetica Neue" pitchFamily="34" charset="0"/>
-                <a:ea typeface="Helvetica Neue" pitchFamily="34" charset="-122"/>
-                <a:cs typeface="Helvetica Neue" pitchFamily="34" charset="-120"/>
+                  <a:srgbClr val="2A034C"/>
+                </a:solidFill>
+                <a:latin typeface="Montserrat" pitchFamily="34" charset="0"/>
+                <a:ea typeface="Montserrat" pitchFamily="34" charset="-122"/>
+                <a:cs typeface="Montserrat" pitchFamily="34" charset="-120"/>
               </a:rPr>
               <a:t>This is the Innovation destination slide. It demonstrates text, a solid background and a Home link back to slide 1.</a:t>
             </a:r>
@@ -2822,7 +2943,7 @@
             </a:avLst>
           </a:prstGeom>
           <a:solidFill>
-            <a:srgbClr val="1B2A4A"/>
+            <a:srgbClr val="2A034C"/>
           </a:solidFill>
           <a:ln/>
         </p:spPr>
@@ -2836,11 +2957,11 @@
             <a:r>
               <a:rPr lang="en-US" sz="1400" b="1" dirty="0">
                 <a:solidFill>
-                  <a:srgbClr val="FFFFFF"/>
-                </a:solidFill>
-                <a:latin typeface="Helvetica Neue" pitchFamily="34" charset="0"/>
-                <a:ea typeface="Helvetica Neue" pitchFamily="34" charset="-122"/>
-                <a:cs typeface="Helvetica Neue" pitchFamily="34" charset="-120"/>
+                  <a:srgbClr val="FBFAFF"/>
+                </a:solidFill>
+                <a:latin typeface="Montserrat" pitchFamily="34" charset="0"/>
+                <a:ea typeface="Montserrat" pitchFamily="34" charset="-122"/>
+                <a:cs typeface="Montserrat" pitchFamily="34" charset="-120"/>
               </a:rPr>
               <a:t>Home</a:t>
             </a:r>
@@ -2872,7 +2993,7 @@
             </a:avLst>
           </a:prstGeom>
           <a:solidFill>
-            <a:srgbClr val="1B2A4A"/>
+            <a:srgbClr val="2A034C"/>
           </a:solidFill>
           <a:ln>
             <a:solidFill>
@@ -2890,11 +3011,11 @@
             <a:r>
               <a:rPr lang="en-US" sz="1400" b="1" dirty="0">
                 <a:solidFill>
-                  <a:srgbClr val="FFFFFF"/>
-                </a:solidFill>
-                <a:latin typeface="Helvetica Neue" pitchFamily="34" charset="0"/>
-                <a:ea typeface="Helvetica Neue" pitchFamily="34" charset="-122"/>
-                <a:cs typeface="Helvetica Neue" pitchFamily="34" charset="-120"/>
+                  <a:srgbClr val="FBFAFF"/>
+                </a:solidFill>
+                <a:latin typeface="Montserrat" pitchFamily="34" charset="0"/>
+                <a:ea typeface="Montserrat" pitchFamily="34" charset="-122"/>
+                <a:cs typeface="Montserrat" pitchFamily="34" charset="-120"/>
               </a:rPr>
               <a:t>T&amp;Cs</a:t>
             </a:r>
@@ -2902,6 +3023,59 @@
           </a:p>
         </p:txBody>
       </p:sp>
+      <p:sp>
+        <p:nvSpPr>
+          <p:cNvPr id="7" name="Accent bar"/>
+          <p:cNvSpPr/>
+          <p:nvPr/>
+        </p:nvSpPr>
+        <p:spPr>
+          <a:xfrm>
+            <a:off x="548640" y="1371600"/>
+            <a:ext cx="822960" cy="64008"/>
+          </a:xfrm>
+          <a:prstGeom prst="rect">
+            <a:avLst/>
+          </a:prstGeom>
+          <a:solidFill>
+            <a:srgbClr val="7949F0"/>
+          </a:solidFill>
+          <a:ln>
+            <a:noFill/>
+          </a:ln>
+        </p:spPr>
+        <p:txBody>
+          <a:bodyPr/>
+          <a:lstStyle/>
+          <a:p>
+            <a:endParaRPr lang="en-US"/>
+          </a:p>
+        </p:txBody>
+      </p:sp>
+      <p:pic>
+        <p:nvPicPr>
+          <p:cNvPr id="8" name="Emota logo" descr="Emota, an Inizio Engage company"/>
+          <p:cNvPicPr>
+            <a:picLocks noChangeAspect="1"/>
+          </p:cNvPicPr>
+          <p:nvPr/>
+        </p:nvPicPr>
+        <p:blipFill>
+          <a:blip r:embed="rIdEmotaLogo"/>
+          <a:stretch>
+            <a:fillRect/>
+          </a:stretch>
+        </p:blipFill>
+        <p:spPr>
+          <a:xfrm>
+            <a:off x="10088575" y="548640"/>
+            <a:ext cx="1554480" cy="554431"/>
+          </a:xfrm>
+          <a:prstGeom prst="rect">
+            <a:avLst/>
+          </a:prstGeom>
+        </p:spPr>
+      </p:pic>
     </p:spTree>
   </p:cSld>
   <p:clrMapOvr>
@@ -2916,10 +3090,7 @@
     <p:bg>
       <p:bgPr>
         <a:solidFill>
-          <a:schemeClr val="accent4">
-            <a:lumMod val="60000"/>
-            <a:lumOff val="40000"/>
-          </a:schemeClr>
+          <a:srgbClr val="F6F4FB"/>
         </a:solidFill>
         <a:effectLst/>
       </p:bgPr>
@@ -2947,7 +3118,7 @@
         <p:spPr>
           <a:xfrm>
             <a:off x="548640" y="457200"/>
-            <a:ext cx="11091672" cy="914400"/>
+            <a:ext cx="9144000" cy="914400"/>
           </a:xfrm>
           <a:prstGeom prst="rect">
             <a:avLst/>
@@ -2965,11 +3136,11 @@
             <a:r>
               <a:rPr lang="en-US" sz="3000" b="1" dirty="0">
                 <a:solidFill>
-                  <a:srgbClr val="1B2A4A"/>
-                </a:solidFill>
-                <a:latin typeface="Helvetica Neue" pitchFamily="34" charset="0"/>
-                <a:ea typeface="Helvetica Neue" pitchFamily="34" charset="-122"/>
-                <a:cs typeface="Helvetica Neue" pitchFamily="34" charset="-120"/>
+                  <a:srgbClr val="2A034C"/>
+                </a:solidFill>
+                <a:latin typeface="Montserrat" pitchFamily="34" charset="0"/>
+                <a:ea typeface="Montserrat" pitchFamily="34" charset="-122"/>
+                <a:cs typeface="Montserrat" pitchFamily="34" charset="-120"/>
               </a:rPr>
               <a:t>People</a:t>
             </a:r>
@@ -3004,11 +3175,11 @@
             <a:r>
               <a:rPr lang="en-US" sz="1600" dirty="0">
                 <a:solidFill>
-                  <a:srgbClr val="333333"/>
-                </a:solidFill>
-                <a:latin typeface="Helvetica Neue" pitchFamily="34" charset="0"/>
-                <a:ea typeface="Helvetica Neue" pitchFamily="34" charset="-122"/>
-                <a:cs typeface="Helvetica Neue" pitchFamily="34" charset="-120"/>
+                  <a:srgbClr val="2A034C"/>
+                </a:solidFill>
+                <a:latin typeface="Montserrat" pitchFamily="34" charset="0"/>
+                <a:ea typeface="Montserrat" pitchFamily="34" charset="-122"/>
+                <a:cs typeface="Montserrat" pitchFamily="34" charset="-120"/>
               </a:rPr>
               <a:t>This is the People destination slide. It demonstrates text, a solid background and a Home link back to slide 1.</a:t>
             </a:r>
@@ -3035,7 +3206,7 @@
             </a:avLst>
           </a:prstGeom>
           <a:solidFill>
-            <a:srgbClr val="1B2A4A"/>
+            <a:srgbClr val="2A034C"/>
           </a:solidFill>
           <a:ln/>
         </p:spPr>
@@ -3049,11 +3220,11 @@
             <a:r>
               <a:rPr lang="en-US" sz="1400" b="1" dirty="0">
                 <a:solidFill>
-                  <a:srgbClr val="FFFFFF"/>
-                </a:solidFill>
-                <a:latin typeface="Helvetica Neue" pitchFamily="34" charset="0"/>
-                <a:ea typeface="Helvetica Neue" pitchFamily="34" charset="-122"/>
-                <a:cs typeface="Helvetica Neue" pitchFamily="34" charset="-120"/>
+                  <a:srgbClr val="FBFAFF"/>
+                </a:solidFill>
+                <a:latin typeface="Montserrat" pitchFamily="34" charset="0"/>
+                <a:ea typeface="Montserrat" pitchFamily="34" charset="-122"/>
+                <a:cs typeface="Montserrat" pitchFamily="34" charset="-120"/>
               </a:rPr>
               <a:t>Home</a:t>
             </a:r>
@@ -3085,7 +3256,7 @@
             </a:avLst>
           </a:prstGeom>
           <a:solidFill>
-            <a:srgbClr val="1B2A4A"/>
+            <a:srgbClr val="2A034C"/>
           </a:solidFill>
           <a:ln>
             <a:solidFill>
@@ -3103,11 +3274,11 @@
             <a:r>
               <a:rPr lang="en-US" sz="1400" b="1" dirty="0">
                 <a:solidFill>
-                  <a:srgbClr val="FFFFFF"/>
-                </a:solidFill>
-                <a:latin typeface="Helvetica Neue" pitchFamily="34" charset="0"/>
-                <a:ea typeface="Helvetica Neue" pitchFamily="34" charset="-122"/>
-                <a:cs typeface="Helvetica Neue" pitchFamily="34" charset="-120"/>
+                  <a:srgbClr val="FBFAFF"/>
+                </a:solidFill>
+                <a:latin typeface="Montserrat" pitchFamily="34" charset="0"/>
+                <a:ea typeface="Montserrat" pitchFamily="34" charset="-122"/>
+                <a:cs typeface="Montserrat" pitchFamily="34" charset="-120"/>
               </a:rPr>
               <a:t>T&amp;Cs</a:t>
             </a:r>
@@ -3115,6 +3286,59 @@
           </a:p>
         </p:txBody>
       </p:sp>
+      <p:sp>
+        <p:nvSpPr>
+          <p:cNvPr id="6" name="Accent bar"/>
+          <p:cNvSpPr/>
+          <p:nvPr/>
+        </p:nvSpPr>
+        <p:spPr>
+          <a:xfrm>
+            <a:off x="548640" y="1371600"/>
+            <a:ext cx="822960" cy="64008"/>
+          </a:xfrm>
+          <a:prstGeom prst="rect">
+            <a:avLst/>
+          </a:prstGeom>
+          <a:solidFill>
+            <a:srgbClr val="451284"/>
+          </a:solidFill>
+          <a:ln>
+            <a:noFill/>
+          </a:ln>
+        </p:spPr>
+        <p:txBody>
+          <a:bodyPr/>
+          <a:lstStyle/>
+          <a:p>
+            <a:endParaRPr lang="en-US"/>
+          </a:p>
+        </p:txBody>
+      </p:sp>
+      <p:pic>
+        <p:nvPicPr>
+          <p:cNvPr id="7" name="Emota logo" descr="Emota, an Inizio Engage company"/>
+          <p:cNvPicPr>
+            <a:picLocks noChangeAspect="1"/>
+          </p:cNvPicPr>
+          <p:nvPr/>
+        </p:nvPicPr>
+        <p:blipFill>
+          <a:blip r:embed="rIdEmotaLogo"/>
+          <a:stretch>
+            <a:fillRect/>
+          </a:stretch>
+        </p:blipFill>
+        <p:spPr>
+          <a:xfrm>
+            <a:off x="10088575" y="548640"/>
+            <a:ext cx="1554480" cy="554431"/>
+          </a:xfrm>
+          <a:prstGeom prst="rect">
+            <a:avLst/>
+          </a:prstGeom>
+        </p:spPr>
+      </p:pic>
     </p:spTree>
   </p:cSld>
   <p:clrMapOvr>
@@ -3129,9 +3353,7 @@
     <p:bg>
       <p:bgPr>
         <a:solidFill>
-          <a:srgbClr val="7A2E5C">
-            <a:alpha val="65490"/>
-          </a:srgbClr>
+          <a:srgbClr val="F6F4FB"/>
         </a:solidFill>
         <a:effectLst/>
       </p:bgPr>
@@ -3159,7 +3381,7 @@
         <p:spPr>
           <a:xfrm>
             <a:off x="548640" y="457200"/>
-            <a:ext cx="11091672" cy="914400"/>
+            <a:ext cx="9144000" cy="914400"/>
           </a:xfrm>
           <a:prstGeom prst="rect">
             <a:avLst/>
@@ -3177,17 +3399,17 @@
             <a:r>
               <a:rPr lang="en-US" sz="3000" b="1" dirty="0">
                 <a:solidFill>
-                  <a:schemeClr val="bg1"/>
-                </a:solidFill>
-                <a:latin typeface="Helvetica Neue" pitchFamily="34" charset="0"/>
-                <a:ea typeface="Helvetica Neue" pitchFamily="34" charset="-122"/>
-                <a:cs typeface="Helvetica Neue" pitchFamily="34" charset="-120"/>
+                  <a:srgbClr val="2A034C"/>
+                </a:solidFill>
+                <a:latin typeface="Montserrat" pitchFamily="34" charset="0"/>
+                <a:ea typeface="Montserrat" pitchFamily="34" charset="-122"/>
+                <a:cs typeface="Montserrat" pitchFamily="34" charset="-120"/>
               </a:rPr>
               <a:t>Contact</a:t>
             </a:r>
             <a:endParaRPr lang="en-US" sz="3000" dirty="0">
               <a:solidFill>
-                <a:schemeClr val="bg1"/>
+                <a:srgbClr val="2A034C"/>
               </a:solidFill>
             </a:endParaRPr>
           </a:p>
@@ -3220,17 +3442,17 @@
             <a:r>
               <a:rPr lang="en-US" sz="1600" dirty="0">
                 <a:solidFill>
-                  <a:schemeClr val="bg1"/>
-                </a:solidFill>
-                <a:latin typeface="Helvetica Neue" pitchFamily="34" charset="0"/>
-                <a:ea typeface="Helvetica Neue" pitchFamily="34" charset="-122"/>
-                <a:cs typeface="Helvetica Neue" pitchFamily="34" charset="-120"/>
+                  <a:srgbClr val="2A034C"/>
+                </a:solidFill>
+                <a:latin typeface="Montserrat" pitchFamily="34" charset="0"/>
+                <a:ea typeface="Montserrat" pitchFamily="34" charset="-122"/>
+                <a:cs typeface="Montserrat" pitchFamily="34" charset="-120"/>
               </a:rPr>
               <a:t>This is the Contact destination slide. It demonstrates text, a solid background and a Home link back to slide 1.</a:t>
             </a:r>
             <a:endParaRPr lang="en-US" sz="1600" dirty="0">
               <a:solidFill>
-                <a:schemeClr val="bg1"/>
+                <a:srgbClr val="2A034C"/>
               </a:solidFill>
             </a:endParaRPr>
           </a:p>
@@ -3255,7 +3477,7 @@
             </a:avLst>
           </a:prstGeom>
           <a:solidFill>
-            <a:srgbClr val="1B2A4A"/>
+            <a:srgbClr val="2A034C"/>
           </a:solidFill>
           <a:ln/>
         </p:spPr>
@@ -3269,11 +3491,11 @@
             <a:r>
               <a:rPr lang="en-US" sz="1400" b="1" dirty="0">
                 <a:solidFill>
-                  <a:srgbClr val="FFFFFF"/>
-                </a:solidFill>
-                <a:latin typeface="Helvetica Neue" pitchFamily="34" charset="0"/>
-                <a:ea typeface="Helvetica Neue" pitchFamily="34" charset="-122"/>
-                <a:cs typeface="Helvetica Neue" pitchFamily="34" charset="-120"/>
+                  <a:srgbClr val="FBFAFF"/>
+                </a:solidFill>
+                <a:latin typeface="Montserrat" pitchFamily="34" charset="0"/>
+                <a:ea typeface="Montserrat" pitchFamily="34" charset="-122"/>
+                <a:cs typeface="Montserrat" pitchFamily="34" charset="-120"/>
               </a:rPr>
               <a:t>Home</a:t>
             </a:r>
@@ -3305,7 +3527,7 @@
             </a:avLst>
           </a:prstGeom>
           <a:solidFill>
-            <a:srgbClr val="1B2A4A"/>
+            <a:srgbClr val="2A034C"/>
           </a:solidFill>
           <a:ln>
             <a:solidFill>
@@ -3323,11 +3545,11 @@
             <a:r>
               <a:rPr lang="en-US" sz="1400" b="1" dirty="0">
                 <a:solidFill>
-                  <a:srgbClr val="FFFFFF"/>
-                </a:solidFill>
-                <a:latin typeface="Helvetica Neue" pitchFamily="34" charset="0"/>
-                <a:ea typeface="Helvetica Neue" pitchFamily="34" charset="-122"/>
-                <a:cs typeface="Helvetica Neue" pitchFamily="34" charset="-120"/>
+                  <a:srgbClr val="FBFAFF"/>
+                </a:solidFill>
+                <a:latin typeface="Montserrat" pitchFamily="34" charset="0"/>
+                <a:ea typeface="Montserrat" pitchFamily="34" charset="-122"/>
+                <a:cs typeface="Montserrat" pitchFamily="34" charset="-120"/>
               </a:rPr>
               <a:t>T&amp;Cs</a:t>
             </a:r>
@@ -3335,6 +3557,59 @@
           </a:p>
         </p:txBody>
       </p:sp>
+      <p:sp>
+        <p:nvSpPr>
+          <p:cNvPr id="6" name="Accent bar"/>
+          <p:cNvSpPr/>
+          <p:nvPr/>
+        </p:nvSpPr>
+        <p:spPr>
+          <a:xfrm>
+            <a:off x="548640" y="1371600"/>
+            <a:ext cx="822960" cy="64008"/>
+          </a:xfrm>
+          <a:prstGeom prst="rect">
+            <a:avLst/>
+          </a:prstGeom>
+          <a:solidFill>
+            <a:srgbClr val="7EF5BD"/>
+          </a:solidFill>
+          <a:ln>
+            <a:noFill/>
+          </a:ln>
+        </p:spPr>
+        <p:txBody>
+          <a:bodyPr/>
+          <a:lstStyle/>
+          <a:p>
+            <a:endParaRPr lang="en-US"/>
+          </a:p>
+        </p:txBody>
+      </p:sp>
+      <p:pic>
+        <p:nvPicPr>
+          <p:cNvPr id="7" name="Emota logo" descr="Emota, an Inizio Engage company"/>
+          <p:cNvPicPr>
+            <a:picLocks noChangeAspect="1"/>
+          </p:cNvPicPr>
+          <p:nvPr/>
+        </p:nvPicPr>
+        <p:blipFill>
+          <a:blip r:embed="rIdEmotaLogo"/>
+          <a:stretch>
+            <a:fillRect/>
+          </a:stretch>
+        </p:blipFill>
+        <p:spPr>
+          <a:xfrm>
+            <a:off x="10088575" y="548640"/>
+            <a:ext cx="1554480" cy="554431"/>
+          </a:xfrm>
+          <a:prstGeom prst="rect">
+            <a:avLst/>
+          </a:prstGeom>
+        </p:spPr>
+      </p:pic>
     </p:spTree>
   </p:cSld>
   <p:clrMapOvr>
@@ -3349,7 +3624,7 @@
     <p:bg>
       <p:bgPr>
         <a:solidFill>
-          <a:srgbClr val="F5F3EE"/>
+          <a:srgbClr val="F6F4FB"/>
         </a:solidFill>
         <a:effectLst/>
       </p:bgPr>
@@ -3389,7 +3664,7 @@
         <p:spPr>
           <a:xfrm>
             <a:off x="548640" y="457200"/>
-            <a:ext cx="11091672" cy="914400"/>
+            <a:ext cx="9144000" cy="914400"/>
           </a:xfrm>
           <a:prstGeom prst="rect">
             <a:avLst/>
@@ -3424,14 +3699,14 @@
                   <a:noFill/>
                 </a:ln>
                 <a:solidFill>
-                  <a:srgbClr val="1B2A4A"/>
+                  <a:srgbClr val="2A034C"/>
                 </a:solidFill>
                 <a:effectLst/>
                 <a:uLnTx/>
                 <a:uFillTx/>
-                <a:latin typeface="Helvetica Neue" pitchFamily="34" charset="0"/>
-                <a:ea typeface="Helvetica Neue" pitchFamily="34" charset="-122"/>
-                <a:cs typeface="Helvetica Neue" pitchFamily="34" charset="-120"/>
+                <a:latin typeface="Montserrat" pitchFamily="34" charset="0"/>
+                <a:ea typeface="Montserrat" pitchFamily="34" charset="-122"/>
+                <a:cs typeface="Montserrat" pitchFamily="34" charset="-120"/>
               </a:rPr>
               <a:t>Terms and Conditions</a:t>
             </a:r>
@@ -3445,7 +3720,7 @@
               <a:effectLst/>
               <a:uLnTx/>
               <a:uFillTx/>
-              <a:latin typeface="Calibri" panose="020F0502020204030204"/>
+              <a:latin typeface="Montserrat" panose="020F0502020204030204"/>
               <a:ea typeface="+mn-ea"/>
               <a:cs typeface="+mn-cs"/>
             </a:endParaRPr>
@@ -3502,14 +3777,14 @@
                   <a:noFill/>
                 </a:ln>
                 <a:solidFill>
-                  <a:srgbClr val="333333"/>
+                  <a:srgbClr val="2A034C"/>
                 </a:solidFill>
                 <a:effectLst/>
                 <a:uLnTx/>
                 <a:uFillTx/>
-                <a:latin typeface="Helvetica Neue" pitchFamily="34" charset="0"/>
-                <a:ea typeface="Helvetica Neue" pitchFamily="34" charset="-122"/>
-                <a:cs typeface="Helvetica Neue" pitchFamily="34" charset="-120"/>
+                <a:latin typeface="Montserrat" pitchFamily="34" charset="0"/>
+                <a:ea typeface="Montserrat" pitchFamily="34" charset="-122"/>
+                <a:cs typeface="Montserrat" pitchFamily="34" charset="-120"/>
               </a:rPr>
               <a:t>This is an example of a slide that will navigate to the previous slide.</a:t>
             </a:r>
@@ -3519,14 +3794,14 @@
                   <a:noFill/>
                 </a:ln>
                 <a:solidFill>
-                  <a:srgbClr val="333333"/>
+                  <a:srgbClr val="2A034C"/>
                 </a:solidFill>
                 <a:effectLst/>
                 <a:uLnTx/>
                 <a:uFillTx/>
-                <a:latin typeface="Helvetica Neue" pitchFamily="34" charset="0"/>
-                <a:ea typeface="Helvetica Neue" pitchFamily="34" charset="-122"/>
-                <a:cs typeface="Helvetica Neue" pitchFamily="34" charset="-120"/>
+                <a:latin typeface="Montserrat" pitchFamily="34" charset="0"/>
+                <a:ea typeface="Montserrat" pitchFamily="34" charset="-122"/>
+                <a:cs typeface="Montserrat" pitchFamily="34" charset="-120"/>
               </a:rPr>
             </a:br>
             <a:br>
@@ -3535,14 +3810,14 @@
                   <a:noFill/>
                 </a:ln>
                 <a:solidFill>
-                  <a:srgbClr val="333333"/>
+                  <a:srgbClr val="2A034C"/>
                 </a:solidFill>
                 <a:effectLst/>
                 <a:uLnTx/>
                 <a:uFillTx/>
-                <a:latin typeface="Helvetica Neue" pitchFamily="34" charset="0"/>
-                <a:ea typeface="Helvetica Neue" pitchFamily="34" charset="-122"/>
-                <a:cs typeface="Helvetica Neue" pitchFamily="34" charset="-120"/>
+                <a:latin typeface="Montserrat" pitchFamily="34" charset="0"/>
+                <a:ea typeface="Montserrat" pitchFamily="34" charset="-122"/>
+                <a:cs typeface="Montserrat" pitchFamily="34" charset="-120"/>
               </a:rPr>
             </a:br>
             <a:r>
@@ -3551,14 +3826,14 @@
                   <a:noFill/>
                 </a:ln>
                 <a:solidFill>
-                  <a:srgbClr val="333333"/>
+                  <a:srgbClr val="2A034C"/>
                 </a:solidFill>
                 <a:effectLst/>
                 <a:uLnTx/>
                 <a:uFillTx/>
-                <a:latin typeface="Helvetica Neue" pitchFamily="34" charset="0"/>
-                <a:ea typeface="Helvetica Neue" pitchFamily="34" charset="-122"/>
-                <a:cs typeface="Helvetica Neue" pitchFamily="34" charset="-120"/>
+                <a:latin typeface="Montserrat" pitchFamily="34" charset="0"/>
+                <a:ea typeface="Montserrat" pitchFamily="34" charset="-122"/>
+                <a:cs typeface="Montserrat" pitchFamily="34" charset="-120"/>
               </a:rPr>
               <a:t>This special case needs to be added by choosing:</a:t>
             </a:r>
@@ -3568,14 +3843,14 @@
                   <a:noFill/>
                 </a:ln>
                 <a:solidFill>
-                  <a:srgbClr val="333333"/>
+                  <a:srgbClr val="2A034C"/>
                 </a:solidFill>
                 <a:effectLst/>
                 <a:uLnTx/>
                 <a:uFillTx/>
-                <a:latin typeface="Helvetica Neue" pitchFamily="34" charset="0"/>
-                <a:ea typeface="Helvetica Neue" pitchFamily="34" charset="-122"/>
-                <a:cs typeface="Helvetica Neue" pitchFamily="34" charset="-120"/>
+                <a:latin typeface="Montserrat" pitchFamily="34" charset="0"/>
+                <a:ea typeface="Montserrat" pitchFamily="34" charset="-122"/>
+                <a:cs typeface="Montserrat" pitchFamily="34" charset="-120"/>
               </a:rPr>
             </a:br>
             <a:br>
@@ -3584,14 +3859,14 @@
                   <a:noFill/>
                 </a:ln>
                 <a:solidFill>
-                  <a:srgbClr val="333333"/>
+                  <a:srgbClr val="2A034C"/>
                 </a:solidFill>
                 <a:effectLst/>
                 <a:uLnTx/>
                 <a:uFillTx/>
-                <a:latin typeface="Helvetica Neue" pitchFamily="34" charset="0"/>
-                <a:ea typeface="Helvetica Neue" pitchFamily="34" charset="-122"/>
-                <a:cs typeface="Helvetica Neue" pitchFamily="34" charset="-120"/>
+                <a:latin typeface="Montserrat" pitchFamily="34" charset="0"/>
+                <a:ea typeface="Montserrat" pitchFamily="34" charset="-122"/>
+                <a:cs typeface="Montserrat" pitchFamily="34" charset="-120"/>
               </a:rPr>
             </a:br>
             <a:r>
@@ -3600,14 +3875,14 @@
                   <a:noFill/>
                 </a:ln>
                 <a:solidFill>
-                  <a:srgbClr val="333333"/>
+                  <a:srgbClr val="2A034C"/>
                 </a:solidFill>
                 <a:effectLst/>
                 <a:uLnTx/>
                 <a:uFillTx/>
-                <a:latin typeface="Helvetica Neue" pitchFamily="34" charset="0"/>
-                <a:ea typeface="Helvetica Neue" pitchFamily="34" charset="-122"/>
-                <a:cs typeface="Helvetica Neue" pitchFamily="34" charset="-120"/>
+                <a:latin typeface="Montserrat" pitchFamily="34" charset="0"/>
+                <a:ea typeface="Montserrat" pitchFamily="34" charset="-122"/>
+                <a:cs typeface="Montserrat" pitchFamily="34" charset="-120"/>
               </a:rPr>
               <a:t>Insert &gt; Action &gt; Action on click &gt; Last Slide Viewed </a:t>
             </a:r>
@@ -3621,7 +3896,7 @@
               <a:effectLst/>
               <a:uLnTx/>
               <a:uFillTx/>
-              <a:latin typeface="Calibri" panose="020F0502020204030204"/>
+              <a:latin typeface="Montserrat" panose="020F0502020204030204"/>
               <a:ea typeface="+mn-ea"/>
               <a:cs typeface="+mn-cs"/>
             </a:endParaRPr>
@@ -3652,7 +3927,7 @@
             </a:avLst>
           </a:prstGeom>
           <a:solidFill>
-            <a:srgbClr val="1B2A4A"/>
+            <a:srgbClr val="2A034C"/>
           </a:solidFill>
           <a:ln/>
         </p:spPr>
@@ -3683,14 +3958,14 @@
                   <a:noFill/>
                 </a:ln>
                 <a:solidFill>
-                  <a:srgbClr val="FFFFFF"/>
+                  <a:srgbClr val="FBFAFF"/>
                 </a:solidFill>
                 <a:effectLst/>
                 <a:uLnTx/>
                 <a:uFillTx/>
-                <a:latin typeface="Helvetica Neue" pitchFamily="34" charset="0"/>
-                <a:ea typeface="Helvetica Neue" pitchFamily="34" charset="-122"/>
-                <a:cs typeface="Helvetica Neue" pitchFamily="34" charset="-120"/>
+                <a:latin typeface="Montserrat" pitchFamily="34" charset="0"/>
+                <a:ea typeface="Montserrat" pitchFamily="34" charset="-122"/>
+                <a:cs typeface="Montserrat" pitchFamily="34" charset="-120"/>
               </a:rPr>
               <a:t>Home</a:t>
             </a:r>
@@ -3704,7 +3979,7 @@
               <a:effectLst/>
               <a:uLnTx/>
               <a:uFillTx/>
-              <a:latin typeface="Calibri" panose="020F0502020204030204"/>
+              <a:latin typeface="Montserrat" panose="020F0502020204030204"/>
               <a:ea typeface="+mn-ea"/>
               <a:cs typeface="+mn-cs"/>
             </a:endParaRPr>
@@ -3735,7 +4010,7 @@
             </a:avLst>
           </a:prstGeom>
           <a:solidFill>
-            <a:srgbClr val="1B2A4A"/>
+            <a:srgbClr val="00CA9F"/>
           </a:solidFill>
           <a:ln>
             <a:solidFill>
@@ -3753,11 +4028,11 @@
             <a:r>
               <a:rPr lang="en-US" sz="1400" b="1" dirty="0">
                 <a:solidFill>
-                  <a:srgbClr val="FFFFFF"/>
-                </a:solidFill>
-                <a:latin typeface="Helvetica Neue" pitchFamily="34" charset="0"/>
-                <a:ea typeface="Helvetica Neue" pitchFamily="34" charset="-122"/>
-                <a:cs typeface="Helvetica Neue" pitchFamily="34" charset="-120"/>
+                  <a:srgbClr val="042B29"/>
+                </a:solidFill>
+                <a:latin typeface="Montserrat" pitchFamily="34" charset="0"/>
+                <a:ea typeface="Montserrat" pitchFamily="34" charset="-122"/>
+                <a:cs typeface="Montserrat" pitchFamily="34" charset="-120"/>
               </a:rPr>
               <a:t>&lt; Back</a:t>
             </a:r>
@@ -3765,6 +4040,59 @@
           </a:p>
         </p:txBody>
       </p:sp>
+      <p:sp>
+        <p:nvSpPr>
+          <p:cNvPr id="6" name="Accent bar"/>
+          <p:cNvSpPr/>
+          <p:nvPr/>
+        </p:nvSpPr>
+        <p:spPr>
+          <a:xfrm>
+            <a:off x="548640" y="1371600"/>
+            <a:ext cx="822960" cy="64008"/>
+          </a:xfrm>
+          <a:prstGeom prst="rect">
+            <a:avLst/>
+          </a:prstGeom>
+          <a:solidFill>
+            <a:srgbClr val="00CA9F"/>
+          </a:solidFill>
+          <a:ln>
+            <a:noFill/>
+          </a:ln>
+        </p:spPr>
+        <p:txBody>
+          <a:bodyPr/>
+          <a:lstStyle/>
+          <a:p>
+            <a:endParaRPr lang="en-US"/>
+          </a:p>
+        </p:txBody>
+      </p:sp>
+      <p:pic>
+        <p:nvPicPr>
+          <p:cNvPr id="7" name="Emota logo" descr="Emota, an Inizio Engage company"/>
+          <p:cNvPicPr>
+            <a:picLocks noChangeAspect="1"/>
+          </p:cNvPicPr>
+          <p:nvPr/>
+        </p:nvPicPr>
+        <p:blipFill>
+          <a:blip r:embed="rIdEmotaLogo"/>
+          <a:stretch>
+            <a:fillRect/>
+          </a:stretch>
+        </p:blipFill>
+        <p:spPr>
+          <a:xfrm>
+            <a:off x="10088575" y="548640"/>
+            <a:ext cx="1554480" cy="554431"/>
+          </a:xfrm>
+          <a:prstGeom prst="rect">
+            <a:avLst/>
+          </a:prstGeom>
+        </p:spPr>
+      </p:pic>
     </p:spTree>
     <p:extLst>
       <p:ext uri="{BB962C8B-B14F-4D97-AF65-F5344CB8AC3E}">
@@ -3784,7 +4112,7 @@
     <p:bg>
       <p:bgPr>
         <a:solidFill>
-          <a:srgbClr val="FFFFFF"/>
+          <a:srgbClr val="F6F4FB"/>
         </a:solidFill>
         <a:effectLst/>
       </p:bgPr>
@@ -3812,7 +4140,7 @@
         <p:spPr>
           <a:xfrm>
             <a:off x="548640" y="365760"/>
-            <a:ext cx="11064240" cy="548640"/>
+            <a:ext cx="9144000" cy="548640"/>
           </a:xfrm>
           <a:prstGeom prst="rect">
             <a:avLst/>
@@ -3830,11 +4158,11 @@
             <a:r>
               <a:rPr lang="en-US" sz="2000" b="1" dirty="0">
                 <a:solidFill>
-                  <a:srgbClr val="1B2A4A"/>
-                </a:solidFill>
-                <a:latin typeface="Helvetica Neue" pitchFamily="34" charset="0"/>
-                <a:ea typeface="Helvetica Neue" pitchFamily="34" charset="-122"/>
-                <a:cs typeface="Helvetica Neue" pitchFamily="34" charset="-120"/>
+                  <a:srgbClr val="2A034C"/>
+                </a:solidFill>
+                <a:latin typeface="Montserrat" pitchFamily="34" charset="0"/>
+                <a:ea typeface="Montserrat" pitchFamily="34" charset="-122"/>
+                <a:cs typeface="Montserrat" pitchFamily="34" charset="-120"/>
               </a:rPr>
               <a:t>Template rules (this slide is not linked from Home)</a:t>
             </a:r>
@@ -3870,11 +4198,11 @@
             <a:r>
               <a:rPr lang="en-US" sz="1400" dirty="0">
                 <a:solidFill>
-                  <a:srgbClr val="333333"/>
-                </a:solidFill>
-                <a:latin typeface="Helvetica Neue" pitchFamily="34" charset="0"/>
-                <a:ea typeface="Helvetica Neue" pitchFamily="34" charset="-122"/>
-                <a:cs typeface="Helvetica Neue" pitchFamily="34" charset="-120"/>
+                  <a:srgbClr val="2A034C"/>
+                </a:solidFill>
+                <a:latin typeface="Montserrat" pitchFamily="34" charset="0"/>
+                <a:ea typeface="Montserrat" pitchFamily="34" charset="-122"/>
+                <a:cs typeface="Montserrat" pitchFamily="34" charset="-120"/>
               </a:rPr>
               <a:t>Slide 1 is the home slide and must contain at least 2 button shapes.</a:t>
             </a:r>
@@ -3888,11 +4216,11 @@
             <a:r>
               <a:rPr lang="en-US" sz="1400" dirty="0">
                 <a:solidFill>
-                  <a:srgbClr val="333333"/>
-                </a:solidFill>
-                <a:latin typeface="Helvetica Neue" pitchFamily="34" charset="0"/>
-                <a:ea typeface="Helvetica Neue" pitchFamily="34" charset="-122"/>
-                <a:cs typeface="Helvetica Neue" pitchFamily="34" charset="-120"/>
+                  <a:srgbClr val="2A034C"/>
+                </a:solidFill>
+                <a:latin typeface="Montserrat" pitchFamily="34" charset="0"/>
+                <a:ea typeface="Montserrat" pitchFamily="34" charset="-122"/>
+                <a:cs typeface="Montserrat" pitchFamily="34" charset="-120"/>
               </a:rPr>
               <a:t>Each button links to a later slide via Insert &gt; Link &gt; Place in This Document &gt; Slide N.</a:t>
             </a:r>
@@ -3906,11 +4234,11 @@
             <a:r>
               <a:rPr lang="en-US" sz="1400" dirty="0">
                 <a:solidFill>
-                  <a:srgbClr val="333333"/>
-                </a:solidFill>
-                <a:latin typeface="Helvetica Neue" pitchFamily="34" charset="0"/>
-                <a:ea typeface="Helvetica Neue" pitchFamily="34" charset="-122"/>
-                <a:cs typeface="Helvetica Neue" pitchFamily="34" charset="-120"/>
+                  <a:srgbClr val="2A034C"/>
+                </a:solidFill>
+                <a:latin typeface="Montserrat" pitchFamily="34" charset="0"/>
+                <a:ea typeface="Montserrat" pitchFamily="34" charset="-122"/>
+                <a:cs typeface="Montserrat" pitchFamily="34" charset="-120"/>
               </a:rPr>
               <a:t>Destination slides should include a shape linked back to slide 1 ("Home").</a:t>
             </a:r>
@@ -3924,11 +4252,11 @@
             <a:r>
               <a:rPr lang="en-US" sz="1400" dirty="0">
                 <a:solidFill>
-                  <a:srgbClr val="333333"/>
-                </a:solidFill>
-                <a:latin typeface="Helvetica Neue" pitchFamily="34" charset="0"/>
-                <a:ea typeface="Helvetica Neue" pitchFamily="34" charset="-122"/>
-                <a:cs typeface="Helvetica Neue" pitchFamily="34" charset="-120"/>
+                  <a:srgbClr val="2A034C"/>
+                </a:solidFill>
+                <a:latin typeface="Montserrat" pitchFamily="34" charset="0"/>
+                <a:ea typeface="Montserrat" pitchFamily="34" charset="-122"/>
+                <a:cs typeface="Montserrat" pitchFamily="34" charset="-120"/>
               </a:rPr>
               <a:t>Slides not linked from slide 1 are ignored (flagged as a warning).</a:t>
             </a:r>
@@ -3942,11 +4270,11 @@
             <a:r>
               <a:rPr lang="en-US" sz="1400" dirty="0">
                 <a:solidFill>
-                  <a:srgbClr val="333333"/>
-                </a:solidFill>
-                <a:latin typeface="Helvetica Neue" pitchFamily="34" charset="0"/>
-                <a:ea typeface="Helvetica Neue" pitchFamily="34" charset="-122"/>
-                <a:cs typeface="Helvetica Neue" pitchFamily="34" charset="-120"/>
+                  <a:srgbClr val="2A034C"/>
+                </a:solidFill>
+                <a:latin typeface="Montserrat" pitchFamily="34" charset="0"/>
+                <a:ea typeface="Montserrat" pitchFamily="34" charset="-122"/>
+                <a:cs typeface="Montserrat" pitchFamily="34" charset="-120"/>
               </a:rPr>
               <a:t>Use system or bundled fonts only; anything else is flagged at setup.</a:t>
             </a:r>
@@ -3954,6 +4282,30 @@
           </a:p>
         </p:txBody>
       </p:sp>
+      <p:pic>
+        <p:nvPicPr>
+          <p:cNvPr id="4" name="Emota logo" descr="Emota, an Inizio Engage company"/>
+          <p:cNvPicPr>
+            <a:picLocks noChangeAspect="1"/>
+          </p:cNvPicPr>
+          <p:nvPr/>
+        </p:nvPicPr>
+        <p:blipFill>
+          <a:blip r:embed="rIdEmotaLogo"/>
+          <a:stretch>
+            <a:fillRect/>
+          </a:stretch>
+        </p:blipFill>
+        <p:spPr>
+          <a:xfrm>
+            <a:off x="10088575" y="411480"/>
+            <a:ext cx="1554480" cy="554431"/>
+          </a:xfrm>
+          <a:prstGeom prst="rect">
+            <a:avLst/>
+          </a:prstGeom>
+        </p:spPr>
+      </p:pic>
     </p:spTree>
   </p:cSld>
   <p:clrMapOvr>
@@ -3965,47 +4317,47 @@
 <file path=ppt/theme/theme1.xml><?xml version="1.0" encoding="utf-8"?>
 <a:theme xmlns:a="http://schemas.openxmlformats.org/drawingml/2006/main" name="Office Theme">
   <a:themeElements>
-    <a:clrScheme name="Office">
+    <a:clrScheme name="Emota">
       <a:dk1>
-        <a:sysClr val="windowText" lastClr="000000"/>
+        <a:srgbClr val="2A034C"/>
       </a:dk1>
       <a:lt1>
-        <a:sysClr val="window" lastClr="FFFFFF"/>
+        <a:srgbClr val="FFFFFF"/>
       </a:lt1>
       <a:dk2>
-        <a:srgbClr val="44546A"/>
+        <a:srgbClr val="180A30"/>
       </a:dk2>
       <a:lt2>
-        <a:srgbClr val="E7E6E6"/>
+        <a:srgbClr val="F6F4FB"/>
       </a:lt2>
       <a:accent1>
-        <a:srgbClr val="4472C4"/>
+        <a:srgbClr val="00CA9F"/>
       </a:accent1>
       <a:accent2>
-        <a:srgbClr val="ED7D31"/>
+        <a:srgbClr val="7949F0"/>
       </a:accent2>
       <a:accent3>
-        <a:srgbClr val="A5A5A5"/>
+        <a:srgbClr val="451284"/>
       </a:accent3>
       <a:accent4>
-        <a:srgbClr val="FFC000"/>
+        <a:srgbClr val="7EF5BD"/>
       </a:accent4>
       <a:accent5>
-        <a:srgbClr val="5B9BD5"/>
+        <a:srgbClr val="3A1164"/>
       </a:accent5>
       <a:accent6>
-        <a:srgbClr val="70AD47"/>
+        <a:srgbClr val="414156"/>
       </a:accent6>
       <a:hlink>
-        <a:srgbClr val="0563C1"/>
+        <a:srgbClr val="007A62"/>
       </a:hlink>
       <a:folHlink>
-        <a:srgbClr val="954F72"/>
+        <a:srgbClr val="7949F0"/>
       </a:folHlink>
     </a:clrScheme>
-    <a:fontScheme name="Office">
+    <a:fontScheme name="Emota">
       <a:majorFont>
-        <a:latin typeface="Calibri Light" panose="020F0302020204030204"/>
+        <a:latin typeface="Montserrat"/>
         <a:ea typeface=""/>
         <a:cs typeface=""/>
         <a:font script="Jpan" typeface="游ゴシック Light"/>
@@ -4057,7 +4409,7 @@
         <a:font script="Tfng" typeface="Ebrima"/>
       </a:majorFont>
       <a:minorFont>
-        <a:latin typeface="Calibri" panose="020F0502020204030204"/>
+        <a:latin typeface="Montserrat"/>
         <a:ea typeface=""/>
         <a:cs typeface=""/>
         <a:font script="Jpan" typeface="游ゴシック"/>

</xml_diff>